<commit_message>
Add human and technical dashboard views
</commit_message>
<xml_diff>
--- a/slides/final_adaptive_rl_gym_coach_v3.pptx
+++ b/slides/final_adaptive_rl_gym_coach_v3.pptx
@@ -2,24 +2,24 @@
 <file path=ppt/presentation.xml><?xml version="1.0" encoding="utf-8"?>
 <p:presentation xmlns:p="http://schemas.openxmlformats.org/presentationml/2006/main">
   <p:sldMasterIdLst>
-    <p:sldMasterId xmlns:r="http://schemas.openxmlformats.org/officeDocument/2006/relationships" id="2147483648" r:id="R7e180e199a96498d"/>
+    <p:sldMasterId xmlns:r="http://schemas.openxmlformats.org/officeDocument/2006/relationships" id="2147483648" r:id="Re2ee0d4ebe734ec8"/>
   </p:sldMasterIdLst>
   <p:notesMasterIdLst>
-    <p:notesMasterId xmlns:r="http://schemas.openxmlformats.org/officeDocument/2006/relationships" r:id="Ra93ae63c94ba4916"/>
+    <p:notesMasterId xmlns:r="http://schemas.openxmlformats.org/officeDocument/2006/relationships" r:id="R182d40fdb91c4e8d"/>
   </p:notesMasterIdLst>
   <p:sldIdLst>
-    <p:sldId xmlns:r="http://schemas.openxmlformats.org/officeDocument/2006/relationships" id="256" r:id="R71d9ba0b113d4099"/>
-    <p:sldId xmlns:r="http://schemas.openxmlformats.org/officeDocument/2006/relationships" id="257" r:id="R8b659347fe56453b"/>
-    <p:sldId xmlns:r="http://schemas.openxmlformats.org/officeDocument/2006/relationships" id="258" r:id="R6ffe9aee8c8b46ac"/>
-    <p:sldId xmlns:r="http://schemas.openxmlformats.org/officeDocument/2006/relationships" id="259" r:id="Rf6251b1552134e97"/>
-    <p:sldId xmlns:r="http://schemas.openxmlformats.org/officeDocument/2006/relationships" id="260" r:id="Rff9d781ad6a24cbd"/>
-    <p:sldId xmlns:r="http://schemas.openxmlformats.org/officeDocument/2006/relationships" id="261" r:id="R68ac7ba7b32d4e03"/>
-    <p:sldId xmlns:r="http://schemas.openxmlformats.org/officeDocument/2006/relationships" id="262" r:id="R997591b89b9d48f1"/>
-    <p:sldId xmlns:r="http://schemas.openxmlformats.org/officeDocument/2006/relationships" id="263" r:id="R18a36644dfb54096"/>
-    <p:sldId xmlns:r="http://schemas.openxmlformats.org/officeDocument/2006/relationships" id="264" r:id="R08f0474403694221"/>
-    <p:sldId xmlns:r="http://schemas.openxmlformats.org/officeDocument/2006/relationships" id="265" r:id="R2d13fdc570a44db4"/>
-    <p:sldId xmlns:r="http://schemas.openxmlformats.org/officeDocument/2006/relationships" id="266" r:id="Rbf163a1bc8f642ca"/>
-    <p:sldId xmlns:r="http://schemas.openxmlformats.org/officeDocument/2006/relationships" id="267" r:id="Rbbf20cbc69724ff3"/>
+    <p:sldId xmlns:r="http://schemas.openxmlformats.org/officeDocument/2006/relationships" id="256" r:id="Rebadb4cdd48f45f9"/>
+    <p:sldId xmlns:r="http://schemas.openxmlformats.org/officeDocument/2006/relationships" id="257" r:id="R2e31a65f996a4009"/>
+    <p:sldId xmlns:r="http://schemas.openxmlformats.org/officeDocument/2006/relationships" id="258" r:id="Rf52483facb1f4aad"/>
+    <p:sldId xmlns:r="http://schemas.openxmlformats.org/officeDocument/2006/relationships" id="259" r:id="Rdeb5f05ad79340f3"/>
+    <p:sldId xmlns:r="http://schemas.openxmlformats.org/officeDocument/2006/relationships" id="260" r:id="R0a808f98310146c2"/>
+    <p:sldId xmlns:r="http://schemas.openxmlformats.org/officeDocument/2006/relationships" id="261" r:id="R83c3eb41d0294dc0"/>
+    <p:sldId xmlns:r="http://schemas.openxmlformats.org/officeDocument/2006/relationships" id="262" r:id="R9f89a386dac44174"/>
+    <p:sldId xmlns:r="http://schemas.openxmlformats.org/officeDocument/2006/relationships" id="263" r:id="Rf20a8510613b49ff"/>
+    <p:sldId xmlns:r="http://schemas.openxmlformats.org/officeDocument/2006/relationships" id="264" r:id="R4ae6b4a6ef2240b5"/>
+    <p:sldId xmlns:r="http://schemas.openxmlformats.org/officeDocument/2006/relationships" id="265" r:id="R709553ddfeea47d1"/>
+    <p:sldId xmlns:r="http://schemas.openxmlformats.org/officeDocument/2006/relationships" id="266" r:id="Rc509f03b7acb487a"/>
+    <p:sldId xmlns:r="http://schemas.openxmlformats.org/officeDocument/2006/relationships" id="267" r:id="R757c35f48a364b6a"/>
   </p:sldIdLst>
   <p:sldSz cx="12192000" cy="6858000"/>
   <p:notesSz cx="6858000" cy="9144000"/>
@@ -1243,7 +1243,7 @@
   </p:cSld>
   <p:clrMap bg1="lt1" tx1="dk1" bg2="lt2" tx2="dk2" accent1="accent1" accent2="accent2" accent3="accent3" accent4="accent4" accent5="accent5" accent6="accent6" hlink="hlink" folHlink="folHlink"/>
   <p:sldLayoutIdLst>
-    <p:sldLayoutId xmlns:r="http://schemas.openxmlformats.org/officeDocument/2006/relationships" id="2147483649" r:id="Ra5485570ba9b4d3a"/>
+    <p:sldLayoutId xmlns:r="http://schemas.openxmlformats.org/officeDocument/2006/relationships" id="2147483649" r:id="Rddcd5a116bf34fa6"/>
   </p:sldLayoutIdLst>
   <p:txStyles>
     <p:titleStyle>
@@ -1975,7 +1975,7 @@
           <p:cNvPr id="7" name="">
             <a:extLst xmlns:a="http://schemas.openxmlformats.org/drawingml/2006/main">
               <a:ext uri="{FF2B5EF4-FFF2-40B4-BE49-F238E27FC236}">
-                <a16:creationId xmlns:a16="http://schemas.microsoft.com/office/drawing/2014/main" id="{C848287B-0107-44A5-AA88-820F2DB1E6EE}"/>
+                <a16:creationId xmlns:a16="http://schemas.microsoft.com/office/drawing/2014/main" id="{5260B729-D866-4059-9685-262126F4496E}"/>
               </a:ext>
             </a:extLst>
           </p:cNvPr>
@@ -2032,7 +2032,7 @@
           <p:cNvPr id="2" name="">
             <a:extLst xmlns:a="http://schemas.openxmlformats.org/drawingml/2006/main">
               <a:ext uri="{FF2B5EF4-FFF2-40B4-BE49-F238E27FC236}">
-                <a16:creationId xmlns:a16="http://schemas.microsoft.com/office/drawing/2014/main" id="{ABF9F35E-0B13-4C16-9CD1-13F15919F1AB}"/>
+                <a16:creationId xmlns:a16="http://schemas.microsoft.com/office/drawing/2014/main" id="{C5B657E3-D615-4CFF-817F-27E99EC28F5C}"/>
               </a:ext>
             </a:extLst>
           </p:cNvPr>
@@ -2089,7 +2089,7 @@
           <p:cNvPr id="3" name="">
             <a:extLst xmlns:a="http://schemas.openxmlformats.org/drawingml/2006/main">
               <a:ext uri="{FF2B5EF4-FFF2-40B4-BE49-F238E27FC236}">
-                <a16:creationId xmlns:a16="http://schemas.microsoft.com/office/drawing/2014/main" id="{48FE3D6B-15E6-4A52-B7E8-226BE299A04C}"/>
+                <a16:creationId xmlns:a16="http://schemas.microsoft.com/office/drawing/2014/main" id="{B76248F3-68FA-48C1-A3A3-41971C40606A}"/>
               </a:ext>
             </a:extLst>
           </p:cNvPr>
@@ -2121,7 +2121,7 @@
           <p:cNvPr id="4" name="">
             <a:extLst xmlns:a="http://schemas.openxmlformats.org/drawingml/2006/main">
               <a:ext uri="{FF2B5EF4-FFF2-40B4-BE49-F238E27FC236}">
-                <a16:creationId xmlns:a16="http://schemas.microsoft.com/office/drawing/2014/main" id="{01E8ADF9-AF60-49BA-8FC9-38C282F78BEE}"/>
+                <a16:creationId xmlns:a16="http://schemas.microsoft.com/office/drawing/2014/main" id="{53A0A5EA-18AA-4116-98C9-613A360B72A5}"/>
               </a:ext>
             </a:extLst>
           </p:cNvPr>
@@ -2178,7 +2178,7 @@
           <p:cNvPr id="5" name="">
             <a:extLst xmlns:a="http://schemas.openxmlformats.org/drawingml/2006/main">
               <a:ext uri="{FF2B5EF4-FFF2-40B4-BE49-F238E27FC236}">
-                <a16:creationId xmlns:a16="http://schemas.microsoft.com/office/drawing/2014/main" id="{2C5486DC-CD6E-41BF-8695-E89AC43B90B5}"/>
+                <a16:creationId xmlns:a16="http://schemas.microsoft.com/office/drawing/2014/main" id="{E343E5CF-5D55-4DA0-9E30-F36D94E142EC}"/>
               </a:ext>
             </a:extLst>
           </p:cNvPr>
@@ -2235,7 +2235,7 @@
           <p:cNvPr id="6" name="">
             <a:extLst xmlns:a="http://schemas.openxmlformats.org/drawingml/2006/main">
               <a:ext uri="{FF2B5EF4-FFF2-40B4-BE49-F238E27FC236}">
-                <a16:creationId xmlns:a16="http://schemas.microsoft.com/office/drawing/2014/main" id="{14508B68-7F4F-41EA-BB52-11F31D3CB562}"/>
+                <a16:creationId xmlns:a16="http://schemas.microsoft.com/office/drawing/2014/main" id="{7D8D8664-4678-4281-867A-AEA82A90FF5A}"/>
               </a:ext>
             </a:extLst>
           </p:cNvPr>
@@ -2290,7 +2290,7 @@
     </p:spTree>
     <p:extLst>
       <p:ext uri="{BB962C8B-B14F-4D97-AF65-F5344CB8AC3E}">
-        <p14:creationId xmlns:p14="http://schemas.microsoft.com/office/powerpoint/2010/main" val="639012170"/>
+        <p14:creationId xmlns:p14="http://schemas.microsoft.com/office/powerpoint/2010/main" val="1316825493"/>
       </p:ext>
     </p:extLst>
   </p:cSld>
@@ -2321,7 +2321,7 @@
           <p:cNvPr id="15" name="">
             <a:extLst xmlns:a="http://schemas.openxmlformats.org/drawingml/2006/main">
               <a:ext uri="{FF2B5EF4-FFF2-40B4-BE49-F238E27FC236}">
-                <a16:creationId xmlns:a16="http://schemas.microsoft.com/office/drawing/2014/main" id="{F199C1D9-D07B-4CD3-87EE-037368EA1C9E}"/>
+                <a16:creationId xmlns:a16="http://schemas.microsoft.com/office/drawing/2014/main" id="{E99B8F78-C879-4E50-AB16-0A2BF21222AC}"/>
               </a:ext>
             </a:extLst>
           </p:cNvPr>
@@ -2378,7 +2378,7 @@
           <p:cNvPr id="2" name="">
             <a:extLst xmlns:a="http://schemas.openxmlformats.org/drawingml/2006/main">
               <a:ext uri="{FF2B5EF4-FFF2-40B4-BE49-F238E27FC236}">
-                <a16:creationId xmlns:a16="http://schemas.microsoft.com/office/drawing/2014/main" id="{BC968309-AB10-48FB-BBED-C794316958FB}"/>
+                <a16:creationId xmlns:a16="http://schemas.microsoft.com/office/drawing/2014/main" id="{08EDF287-1882-4266-912A-0D19C6847D6E}"/>
               </a:ext>
             </a:extLst>
           </p:cNvPr>
@@ -2435,7 +2435,7 @@
           <p:cNvPr id="3" name="">
             <a:extLst xmlns:a="http://schemas.openxmlformats.org/drawingml/2006/main">
               <a:ext uri="{FF2B5EF4-FFF2-40B4-BE49-F238E27FC236}">
-                <a16:creationId xmlns:a16="http://schemas.microsoft.com/office/drawing/2014/main" id="{E07D0413-BD30-4916-81D8-045CDCD10F6F}"/>
+                <a16:creationId xmlns:a16="http://schemas.microsoft.com/office/drawing/2014/main" id="{51E95716-947B-4BBE-A320-EF51AAE72A1C}"/>
               </a:ext>
             </a:extLst>
           </p:cNvPr>
@@ -2492,7 +2492,7 @@
           <p:cNvPr id="4" name="">
             <a:extLst xmlns:a="http://schemas.openxmlformats.org/drawingml/2006/main">
               <a:ext uri="{FF2B5EF4-FFF2-40B4-BE49-F238E27FC236}">
-                <a16:creationId xmlns:a16="http://schemas.microsoft.com/office/drawing/2014/main" id="{627E0C61-A93E-41DA-8875-EEC3F64A8047}"/>
+                <a16:creationId xmlns:a16="http://schemas.microsoft.com/office/drawing/2014/main" id="{709B3502-60B9-49D8-A0AF-B4A5FA796906}"/>
               </a:ext>
             </a:extLst>
           </p:cNvPr>
@@ -2539,7 +2539,7 @@
                 <a:ea typeface="Arial"/>
                 <a:cs typeface="Arial"/>
               </a:rPr>
-              <a:t>Pytest passed with 22 unit and integration tests</a:t>
+              <a:t>Pytest passed with 28 unit and integration tests</a:t>
             </a:r>
           </a:p>
         </p:txBody>
@@ -2549,7 +2549,7 @@
           <p:cNvPr id="5" name="">
             <a:extLst xmlns:a="http://schemas.openxmlformats.org/drawingml/2006/main">
               <a:ext uri="{FF2B5EF4-FFF2-40B4-BE49-F238E27FC236}">
-                <a16:creationId xmlns:a16="http://schemas.microsoft.com/office/drawing/2014/main" id="{12B371CD-945F-4853-8CB3-BD7FEAA5253D}"/>
+                <a16:creationId xmlns:a16="http://schemas.microsoft.com/office/drawing/2014/main" id="{A767BE10-162B-405B-AA98-477C87D98CF6}"/>
               </a:ext>
             </a:extLst>
           </p:cNvPr>
@@ -2581,7 +2581,7 @@
           <p:cNvPr id="6" name="">
             <a:extLst xmlns:a="http://schemas.openxmlformats.org/drawingml/2006/main">
               <a:ext uri="{FF2B5EF4-FFF2-40B4-BE49-F238E27FC236}">
-                <a16:creationId xmlns:a16="http://schemas.microsoft.com/office/drawing/2014/main" id="{3D27885D-9645-493C-A926-33954823FF55}"/>
+                <a16:creationId xmlns:a16="http://schemas.microsoft.com/office/drawing/2014/main" id="{AEA6ED3B-1A01-4142-A1C5-ED1692D57A79}"/>
               </a:ext>
             </a:extLst>
           </p:cNvPr>
@@ -2638,7 +2638,7 @@
           <p:cNvPr id="7" name="">
             <a:extLst xmlns:a="http://schemas.openxmlformats.org/drawingml/2006/main">
               <a:ext uri="{FF2B5EF4-FFF2-40B4-BE49-F238E27FC236}">
-                <a16:creationId xmlns:a16="http://schemas.microsoft.com/office/drawing/2014/main" id="{D1BB1543-3BF0-47C6-B643-5EBFD1037988}"/>
+                <a16:creationId xmlns:a16="http://schemas.microsoft.com/office/drawing/2014/main" id="{DC289635-FD94-46A5-93BD-0940BCAFA4C4}"/>
               </a:ext>
             </a:extLst>
           </p:cNvPr>
@@ -2670,7 +2670,7 @@
           <p:cNvPr id="8" name="">
             <a:extLst xmlns:a="http://schemas.openxmlformats.org/drawingml/2006/main">
               <a:ext uri="{FF2B5EF4-FFF2-40B4-BE49-F238E27FC236}">
-                <a16:creationId xmlns:a16="http://schemas.microsoft.com/office/drawing/2014/main" id="{C99BB6EA-504B-44CC-9542-847771A8F76B}"/>
+                <a16:creationId xmlns:a16="http://schemas.microsoft.com/office/drawing/2014/main" id="{E641DBDA-A8A7-4B25-910A-909CFEDB4D7D}"/>
               </a:ext>
             </a:extLst>
           </p:cNvPr>
@@ -2727,7 +2727,7 @@
           <p:cNvPr id="9" name="">
             <a:extLst xmlns:a="http://schemas.openxmlformats.org/drawingml/2006/main">
               <a:ext uri="{FF2B5EF4-FFF2-40B4-BE49-F238E27FC236}">
-                <a16:creationId xmlns:a16="http://schemas.microsoft.com/office/drawing/2014/main" id="{00A246CD-95F2-48D6-8F25-5BBBA98B41A3}"/>
+                <a16:creationId xmlns:a16="http://schemas.microsoft.com/office/drawing/2014/main" id="{9E19A478-C185-41C4-AB17-CBCBD9D3D568}"/>
               </a:ext>
             </a:extLst>
           </p:cNvPr>
@@ -2759,7 +2759,7 @@
           <p:cNvPr id="10" name="">
             <a:extLst xmlns:a="http://schemas.openxmlformats.org/drawingml/2006/main">
               <a:ext uri="{FF2B5EF4-FFF2-40B4-BE49-F238E27FC236}">
-                <a16:creationId xmlns:a16="http://schemas.microsoft.com/office/drawing/2014/main" id="{1E1FE82E-0631-4EF8-80EB-1F5003A49609}"/>
+                <a16:creationId xmlns:a16="http://schemas.microsoft.com/office/drawing/2014/main" id="{C1DF5597-7719-4650-89E0-BAF8CB07B65D}"/>
               </a:ext>
             </a:extLst>
           </p:cNvPr>
@@ -2816,7 +2816,7 @@
           <p:cNvPr id="11" name="">
             <a:extLst xmlns:a="http://schemas.openxmlformats.org/drawingml/2006/main">
               <a:ext uri="{FF2B5EF4-FFF2-40B4-BE49-F238E27FC236}">
-                <a16:creationId xmlns:a16="http://schemas.microsoft.com/office/drawing/2014/main" id="{F918E0EA-1E60-4FA4-95A1-CBE6C1BF7D0C}"/>
+                <a16:creationId xmlns:a16="http://schemas.microsoft.com/office/drawing/2014/main" id="{400D4BF9-6B70-420B-8A7C-49A4C868297A}"/>
               </a:ext>
             </a:extLst>
           </p:cNvPr>
@@ -2848,7 +2848,7 @@
           <p:cNvPr id="12" name="">
             <a:extLst xmlns:a="http://schemas.openxmlformats.org/drawingml/2006/main">
               <a:ext uri="{FF2B5EF4-FFF2-40B4-BE49-F238E27FC236}">
-                <a16:creationId xmlns:a16="http://schemas.microsoft.com/office/drawing/2014/main" id="{10305C91-F94F-44F1-93DC-CCDEC6C0628A}"/>
+                <a16:creationId xmlns:a16="http://schemas.microsoft.com/office/drawing/2014/main" id="{CFA04890-1B6A-44C8-875B-3563B81B2D19}"/>
               </a:ext>
             </a:extLst>
           </p:cNvPr>
@@ -2905,7 +2905,7 @@
           <p:cNvPr id="13" name="">
             <a:extLst xmlns:a="http://schemas.openxmlformats.org/drawingml/2006/main">
               <a:ext uri="{FF2B5EF4-FFF2-40B4-BE49-F238E27FC236}">
-                <a16:creationId xmlns:a16="http://schemas.microsoft.com/office/drawing/2014/main" id="{B516B3B7-7F95-463C-AED8-D03CC5D2CE0C}"/>
+                <a16:creationId xmlns:a16="http://schemas.microsoft.com/office/drawing/2014/main" id="{6063F49A-11BB-4F4F-85DE-E25B32858512}"/>
               </a:ext>
             </a:extLst>
           </p:cNvPr>
@@ -2937,7 +2937,7 @@
           <p:cNvPr id="14" name="">
             <a:extLst xmlns:a="http://schemas.openxmlformats.org/drawingml/2006/main">
               <a:ext uri="{FF2B5EF4-FFF2-40B4-BE49-F238E27FC236}">
-                <a16:creationId xmlns:a16="http://schemas.microsoft.com/office/drawing/2014/main" id="{631C7C11-A3D5-4EC2-AC68-8EBCFF85E3DF}"/>
+                <a16:creationId xmlns:a16="http://schemas.microsoft.com/office/drawing/2014/main" id="{A49AD0FA-E9D6-463D-BD9E-F506F892A801}"/>
               </a:ext>
             </a:extLst>
           </p:cNvPr>
@@ -2992,7 +2992,7 @@
     </p:spTree>
     <p:extLst>
       <p:ext uri="{BB962C8B-B14F-4D97-AF65-F5344CB8AC3E}">
-        <p14:creationId xmlns:p14="http://schemas.microsoft.com/office/powerpoint/2010/main" val="684070947"/>
+        <p14:creationId xmlns:p14="http://schemas.microsoft.com/office/powerpoint/2010/main" val="995629608"/>
       </p:ext>
     </p:extLst>
   </p:cSld>
@@ -3023,7 +3023,7 @@
           <p:cNvPr id="15" name="">
             <a:extLst xmlns:a="http://schemas.openxmlformats.org/drawingml/2006/main">
               <a:ext uri="{FF2B5EF4-FFF2-40B4-BE49-F238E27FC236}">
-                <a16:creationId xmlns:a16="http://schemas.microsoft.com/office/drawing/2014/main" id="{ACD88C7E-FAD6-4FDA-A669-08C9E1727D0A}"/>
+                <a16:creationId xmlns:a16="http://schemas.microsoft.com/office/drawing/2014/main" id="{6340FCF4-DC41-4976-8466-94086D15C1F7}"/>
               </a:ext>
             </a:extLst>
           </p:cNvPr>
@@ -3080,7 +3080,7 @@
           <p:cNvPr id="2" name="">
             <a:extLst xmlns:a="http://schemas.openxmlformats.org/drawingml/2006/main">
               <a:ext uri="{FF2B5EF4-FFF2-40B4-BE49-F238E27FC236}">
-                <a16:creationId xmlns:a16="http://schemas.microsoft.com/office/drawing/2014/main" id="{8D6A5E40-C54B-4C38-8832-DBD8987872E2}"/>
+                <a16:creationId xmlns:a16="http://schemas.microsoft.com/office/drawing/2014/main" id="{A9B0CFE0-3E6C-46EB-9C0C-7FC4C4C0F924}"/>
               </a:ext>
             </a:extLst>
           </p:cNvPr>
@@ -3137,7 +3137,7 @@
           <p:cNvPr id="3" name="">
             <a:extLst xmlns:a="http://schemas.openxmlformats.org/drawingml/2006/main">
               <a:ext uri="{FF2B5EF4-FFF2-40B4-BE49-F238E27FC236}">
-                <a16:creationId xmlns:a16="http://schemas.microsoft.com/office/drawing/2014/main" id="{00A06691-8C4C-44CA-96F5-D784E7440813}"/>
+                <a16:creationId xmlns:a16="http://schemas.microsoft.com/office/drawing/2014/main" id="{778E8A65-F2CB-49C2-BE19-83C08C832293}"/>
               </a:ext>
             </a:extLst>
           </p:cNvPr>
@@ -3194,7 +3194,7 @@
           <p:cNvPr id="4" name="">
             <a:extLst xmlns:a="http://schemas.openxmlformats.org/drawingml/2006/main">
               <a:ext uri="{FF2B5EF4-FFF2-40B4-BE49-F238E27FC236}">
-                <a16:creationId xmlns:a16="http://schemas.microsoft.com/office/drawing/2014/main" id="{9AF0F987-BC83-42CC-BB7C-073BC85182D5}"/>
+                <a16:creationId xmlns:a16="http://schemas.microsoft.com/office/drawing/2014/main" id="{88F49981-8576-49F3-84C5-34F181E23DBF}"/>
               </a:ext>
             </a:extLst>
           </p:cNvPr>
@@ -3251,7 +3251,7 @@
           <p:cNvPr id="5" name="">
             <a:extLst xmlns:a="http://schemas.openxmlformats.org/drawingml/2006/main">
               <a:ext uri="{FF2B5EF4-FFF2-40B4-BE49-F238E27FC236}">
-                <a16:creationId xmlns:a16="http://schemas.microsoft.com/office/drawing/2014/main" id="{F6BEA59F-7B81-4DF8-B750-623A9B3FBA87}"/>
+                <a16:creationId xmlns:a16="http://schemas.microsoft.com/office/drawing/2014/main" id="{FC6779E2-F50A-49BD-8AA9-C0687F116CC6}"/>
               </a:ext>
             </a:extLst>
           </p:cNvPr>
@@ -3283,7 +3283,7 @@
           <p:cNvPr id="6" name="">
             <a:extLst xmlns:a="http://schemas.openxmlformats.org/drawingml/2006/main">
               <a:ext uri="{FF2B5EF4-FFF2-40B4-BE49-F238E27FC236}">
-                <a16:creationId xmlns:a16="http://schemas.microsoft.com/office/drawing/2014/main" id="{708C77FD-E408-45D9-8B07-14233614CD9E}"/>
+                <a16:creationId xmlns:a16="http://schemas.microsoft.com/office/drawing/2014/main" id="{11FA64F2-F782-4B0D-A443-EFE216EFF6A6}"/>
               </a:ext>
             </a:extLst>
           </p:cNvPr>
@@ -3340,7 +3340,7 @@
           <p:cNvPr id="7" name="">
             <a:extLst xmlns:a="http://schemas.openxmlformats.org/drawingml/2006/main">
               <a:ext uri="{FF2B5EF4-FFF2-40B4-BE49-F238E27FC236}">
-                <a16:creationId xmlns:a16="http://schemas.microsoft.com/office/drawing/2014/main" id="{96A0DDE2-A57E-42E6-854A-C7452CC3CF9C}"/>
+                <a16:creationId xmlns:a16="http://schemas.microsoft.com/office/drawing/2014/main" id="{1A9506A8-D3C1-47A8-BB41-3D252076A064}"/>
               </a:ext>
             </a:extLst>
           </p:cNvPr>
@@ -3372,7 +3372,7 @@
           <p:cNvPr id="8" name="">
             <a:extLst xmlns:a="http://schemas.openxmlformats.org/drawingml/2006/main">
               <a:ext uri="{FF2B5EF4-FFF2-40B4-BE49-F238E27FC236}">
-                <a16:creationId xmlns:a16="http://schemas.microsoft.com/office/drawing/2014/main" id="{C76460AB-385D-423B-9453-B5E338658052}"/>
+                <a16:creationId xmlns:a16="http://schemas.microsoft.com/office/drawing/2014/main" id="{178FA3B3-ABCF-4E14-B4E5-3313732D5428}"/>
               </a:ext>
             </a:extLst>
           </p:cNvPr>
@@ -3429,7 +3429,7 @@
           <p:cNvPr id="9" name="">
             <a:extLst xmlns:a="http://schemas.openxmlformats.org/drawingml/2006/main">
               <a:ext uri="{FF2B5EF4-FFF2-40B4-BE49-F238E27FC236}">
-                <a16:creationId xmlns:a16="http://schemas.microsoft.com/office/drawing/2014/main" id="{632C510E-00D1-42F3-9748-456F1BC6773E}"/>
+                <a16:creationId xmlns:a16="http://schemas.microsoft.com/office/drawing/2014/main" id="{2CC585DE-43E7-4F17-B804-54BD0CB17348}"/>
               </a:ext>
             </a:extLst>
           </p:cNvPr>
@@ -3461,7 +3461,7 @@
           <p:cNvPr id="10" name="">
             <a:extLst xmlns:a="http://schemas.openxmlformats.org/drawingml/2006/main">
               <a:ext uri="{FF2B5EF4-FFF2-40B4-BE49-F238E27FC236}">
-                <a16:creationId xmlns:a16="http://schemas.microsoft.com/office/drawing/2014/main" id="{83BC6E15-1A96-427D-A573-F02C4CC4ED85}"/>
+                <a16:creationId xmlns:a16="http://schemas.microsoft.com/office/drawing/2014/main" id="{0C7C7E42-3A03-4B86-BC0C-3B5FA3D46184}"/>
               </a:ext>
             </a:extLst>
           </p:cNvPr>
@@ -3518,7 +3518,7 @@
           <p:cNvPr id="11" name="">
             <a:extLst xmlns:a="http://schemas.openxmlformats.org/drawingml/2006/main">
               <a:ext uri="{FF2B5EF4-FFF2-40B4-BE49-F238E27FC236}">
-                <a16:creationId xmlns:a16="http://schemas.microsoft.com/office/drawing/2014/main" id="{0D72D56B-3931-453C-87DA-43E2DDAB5DF8}"/>
+                <a16:creationId xmlns:a16="http://schemas.microsoft.com/office/drawing/2014/main" id="{AAFBACC7-E740-49F4-BE9D-62291FC17C76}"/>
               </a:ext>
             </a:extLst>
           </p:cNvPr>
@@ -3550,7 +3550,7 @@
           <p:cNvPr id="12" name="">
             <a:extLst xmlns:a="http://schemas.openxmlformats.org/drawingml/2006/main">
               <a:ext uri="{FF2B5EF4-FFF2-40B4-BE49-F238E27FC236}">
-                <a16:creationId xmlns:a16="http://schemas.microsoft.com/office/drawing/2014/main" id="{8B5EF876-6A89-4577-9F12-15F27DF2C864}"/>
+                <a16:creationId xmlns:a16="http://schemas.microsoft.com/office/drawing/2014/main" id="{C7DD756F-F195-4E63-97B9-D782D8782F22}"/>
               </a:ext>
             </a:extLst>
           </p:cNvPr>
@@ -3607,7 +3607,7 @@
           <p:cNvPr id="13" name="">
             <a:extLst xmlns:a="http://schemas.openxmlformats.org/drawingml/2006/main">
               <a:ext uri="{FF2B5EF4-FFF2-40B4-BE49-F238E27FC236}">
-                <a16:creationId xmlns:a16="http://schemas.microsoft.com/office/drawing/2014/main" id="{BA017733-DA50-4500-9EDB-9435F6A69F2C}"/>
+                <a16:creationId xmlns:a16="http://schemas.microsoft.com/office/drawing/2014/main" id="{1BF06A88-E938-4F1E-A4E3-84FCA79AA285}"/>
               </a:ext>
             </a:extLst>
           </p:cNvPr>
@@ -3639,7 +3639,7 @@
           <p:cNvPr id="14" name="">
             <a:extLst xmlns:a="http://schemas.openxmlformats.org/drawingml/2006/main">
               <a:ext uri="{FF2B5EF4-FFF2-40B4-BE49-F238E27FC236}">
-                <a16:creationId xmlns:a16="http://schemas.microsoft.com/office/drawing/2014/main" id="{75263A19-F6D1-4C44-B2C6-A371CFD856A8}"/>
+                <a16:creationId xmlns:a16="http://schemas.microsoft.com/office/drawing/2014/main" id="{8BB30170-6B7F-4532-BD9C-0B167712373C}"/>
               </a:ext>
             </a:extLst>
           </p:cNvPr>
@@ -3694,7 +3694,7 @@
     </p:spTree>
     <p:extLst>
       <p:ext uri="{BB962C8B-B14F-4D97-AF65-F5344CB8AC3E}">
-        <p14:creationId xmlns:p14="http://schemas.microsoft.com/office/powerpoint/2010/main" val="1071684560"/>
+        <p14:creationId xmlns:p14="http://schemas.microsoft.com/office/powerpoint/2010/main" val="291406420"/>
       </p:ext>
     </p:extLst>
   </p:cSld>
@@ -3725,7 +3725,7 @@
           <p:cNvPr id="6" name="">
             <a:extLst xmlns:a="http://schemas.openxmlformats.org/drawingml/2006/main">
               <a:ext uri="{FF2B5EF4-FFF2-40B4-BE49-F238E27FC236}">
-                <a16:creationId xmlns:a16="http://schemas.microsoft.com/office/drawing/2014/main" id="{00F8828A-144B-4E72-85B4-9E1365DE481E}"/>
+                <a16:creationId xmlns:a16="http://schemas.microsoft.com/office/drawing/2014/main" id="{5929F6DD-ABC6-487D-8BC8-50E08459725D}"/>
               </a:ext>
             </a:extLst>
           </p:cNvPr>
@@ -3782,7 +3782,7 @@
           <p:cNvPr id="2" name="">
             <a:extLst xmlns:a="http://schemas.openxmlformats.org/drawingml/2006/main">
               <a:ext uri="{FF2B5EF4-FFF2-40B4-BE49-F238E27FC236}">
-                <a16:creationId xmlns:a16="http://schemas.microsoft.com/office/drawing/2014/main" id="{244A8E12-4C24-4E26-AAC6-2F4F5685B28D}"/>
+                <a16:creationId xmlns:a16="http://schemas.microsoft.com/office/drawing/2014/main" id="{8395BB1F-3B65-4498-B584-5E87DFF51A75}"/>
               </a:ext>
             </a:extLst>
           </p:cNvPr>
@@ -3814,7 +3814,7 @@
           <p:cNvPr id="3" name="">
             <a:extLst xmlns:a="http://schemas.openxmlformats.org/drawingml/2006/main">
               <a:ext uri="{FF2B5EF4-FFF2-40B4-BE49-F238E27FC236}">
-                <a16:creationId xmlns:a16="http://schemas.microsoft.com/office/drawing/2014/main" id="{B51F8E2E-6340-4C3D-93E8-432113A72F46}"/>
+                <a16:creationId xmlns:a16="http://schemas.microsoft.com/office/drawing/2014/main" id="{875EE4C7-00B4-4F68-A4A4-42E0DC2BEE9D}"/>
               </a:ext>
             </a:extLst>
           </p:cNvPr>
@@ -3871,7 +3871,7 @@
           <p:cNvPr id="4" name="">
             <a:extLst xmlns:a="http://schemas.openxmlformats.org/drawingml/2006/main">
               <a:ext uri="{FF2B5EF4-FFF2-40B4-BE49-F238E27FC236}">
-                <a16:creationId xmlns:a16="http://schemas.microsoft.com/office/drawing/2014/main" id="{71F0C6A4-B5A5-42E8-BF57-0CDF64B9A3BE}"/>
+                <a16:creationId xmlns:a16="http://schemas.microsoft.com/office/drawing/2014/main" id="{D54C9B83-C85C-43DF-98A7-3BA102893401}"/>
               </a:ext>
             </a:extLst>
           </p:cNvPr>
@@ -3928,7 +3928,7 @@
           <p:cNvPr id="5" name="">
             <a:extLst xmlns:a="http://schemas.openxmlformats.org/drawingml/2006/main">
               <a:ext uri="{FF2B5EF4-FFF2-40B4-BE49-F238E27FC236}">
-                <a16:creationId xmlns:a16="http://schemas.microsoft.com/office/drawing/2014/main" id="{0284F8F3-51AA-4818-A1B0-1D66F022261A}"/>
+                <a16:creationId xmlns:a16="http://schemas.microsoft.com/office/drawing/2014/main" id="{2883A944-1669-43C7-9FF2-B30E31EEFC7C}"/>
               </a:ext>
             </a:extLst>
           </p:cNvPr>
@@ -3983,7 +3983,7 @@
     </p:spTree>
     <p:extLst>
       <p:ext uri="{BB962C8B-B14F-4D97-AF65-F5344CB8AC3E}">
-        <p14:creationId xmlns:p14="http://schemas.microsoft.com/office/powerpoint/2010/main" val="771031925"/>
+        <p14:creationId xmlns:p14="http://schemas.microsoft.com/office/powerpoint/2010/main" val="426420838"/>
       </p:ext>
     </p:extLst>
   </p:cSld>
@@ -4014,7 +4014,7 @@
           <p:cNvPr id="15" name="">
             <a:extLst xmlns:a="http://schemas.openxmlformats.org/drawingml/2006/main">
               <a:ext uri="{FF2B5EF4-FFF2-40B4-BE49-F238E27FC236}">
-                <a16:creationId xmlns:a16="http://schemas.microsoft.com/office/drawing/2014/main" id="{3C42D7BE-28AE-4F30-A8ED-BD6449240762}"/>
+                <a16:creationId xmlns:a16="http://schemas.microsoft.com/office/drawing/2014/main" id="{6C248388-980C-4260-864B-58F2212D2536}"/>
               </a:ext>
             </a:extLst>
           </p:cNvPr>
@@ -4071,7 +4071,7 @@
           <p:cNvPr id="2" name="">
             <a:extLst xmlns:a="http://schemas.openxmlformats.org/drawingml/2006/main">
               <a:ext uri="{FF2B5EF4-FFF2-40B4-BE49-F238E27FC236}">
-                <a16:creationId xmlns:a16="http://schemas.microsoft.com/office/drawing/2014/main" id="{65FA3635-115E-4A95-9DD3-64C37B9D1ABF}"/>
+                <a16:creationId xmlns:a16="http://schemas.microsoft.com/office/drawing/2014/main" id="{2F3CB6B8-F41B-45A6-8CCC-0393620F107C}"/>
               </a:ext>
             </a:extLst>
           </p:cNvPr>
@@ -4128,7 +4128,7 @@
           <p:cNvPr id="3" name="">
             <a:extLst xmlns:a="http://schemas.openxmlformats.org/drawingml/2006/main">
               <a:ext uri="{FF2B5EF4-FFF2-40B4-BE49-F238E27FC236}">
-                <a16:creationId xmlns:a16="http://schemas.microsoft.com/office/drawing/2014/main" id="{9AABE267-CDD2-4271-9E10-FC35CE6F5B63}"/>
+                <a16:creationId xmlns:a16="http://schemas.microsoft.com/office/drawing/2014/main" id="{A7BA7D36-22C1-4E71-BE14-6119A5F65AB5}"/>
               </a:ext>
             </a:extLst>
           </p:cNvPr>
@@ -4185,7 +4185,7 @@
           <p:cNvPr id="4" name="">
             <a:extLst xmlns:a="http://schemas.openxmlformats.org/drawingml/2006/main">
               <a:ext uri="{FF2B5EF4-FFF2-40B4-BE49-F238E27FC236}">
-                <a16:creationId xmlns:a16="http://schemas.microsoft.com/office/drawing/2014/main" id="{1489EF12-96D1-4233-A98B-128403BE1699}"/>
+                <a16:creationId xmlns:a16="http://schemas.microsoft.com/office/drawing/2014/main" id="{A8216A4E-112E-4AA9-B575-CAF1602C014C}"/>
               </a:ext>
             </a:extLst>
           </p:cNvPr>
@@ -4232,7 +4232,7 @@
                 <a:ea typeface="Arial"/>
                 <a:cs typeface="Arial"/>
               </a:rPr>
-              <a:t>Video upload or bundled synthetic squat session</a:t>
+              <a:t>Client name, profile inputs, and squat video upload</a:t>
             </a:r>
           </a:p>
         </p:txBody>
@@ -4242,7 +4242,7 @@
           <p:cNvPr id="5" name="">
             <a:extLst xmlns:a="http://schemas.openxmlformats.org/drawingml/2006/main">
               <a:ext uri="{FF2B5EF4-FFF2-40B4-BE49-F238E27FC236}">
-                <a16:creationId xmlns:a16="http://schemas.microsoft.com/office/drawing/2014/main" id="{DBAE7BE9-5FAD-4CBB-9115-D5AD9234EED8}"/>
+                <a16:creationId xmlns:a16="http://schemas.microsoft.com/office/drawing/2014/main" id="{10B27678-9AA4-49A9-AA4A-E92A20008A2B}"/>
               </a:ext>
             </a:extLst>
           </p:cNvPr>
@@ -4274,7 +4274,7 @@
           <p:cNvPr id="6" name="">
             <a:extLst xmlns:a="http://schemas.openxmlformats.org/drawingml/2006/main">
               <a:ext uri="{FF2B5EF4-FFF2-40B4-BE49-F238E27FC236}">
-                <a16:creationId xmlns:a16="http://schemas.microsoft.com/office/drawing/2014/main" id="{A700E71A-1BF0-44D8-A3BD-205031ADE673}"/>
+                <a16:creationId xmlns:a16="http://schemas.microsoft.com/office/drawing/2014/main" id="{11193E17-9115-4ACF-BDA8-88EA07F680E3}"/>
               </a:ext>
             </a:extLst>
           </p:cNvPr>
@@ -4331,7 +4331,7 @@
           <p:cNvPr id="7" name="">
             <a:extLst xmlns:a="http://schemas.openxmlformats.org/drawingml/2006/main">
               <a:ext uri="{FF2B5EF4-FFF2-40B4-BE49-F238E27FC236}">
-                <a16:creationId xmlns:a16="http://schemas.microsoft.com/office/drawing/2014/main" id="{DE40AEAA-EB9E-4C0B-84FF-AF888C205508}"/>
+                <a16:creationId xmlns:a16="http://schemas.microsoft.com/office/drawing/2014/main" id="{1DEE0844-E4B9-4A92-AFC6-8954CCAAB147}"/>
               </a:ext>
             </a:extLst>
           </p:cNvPr>
@@ -4363,7 +4363,7 @@
           <p:cNvPr id="8" name="">
             <a:extLst xmlns:a="http://schemas.openxmlformats.org/drawingml/2006/main">
               <a:ext uri="{FF2B5EF4-FFF2-40B4-BE49-F238E27FC236}">
-                <a16:creationId xmlns:a16="http://schemas.microsoft.com/office/drawing/2014/main" id="{25AC1C7B-FE6F-4085-BA92-E1F7D3AD1B9D}"/>
+                <a16:creationId xmlns:a16="http://schemas.microsoft.com/office/drawing/2014/main" id="{DA421ECA-5320-4910-A0A2-F2CE75456735}"/>
               </a:ext>
             </a:extLst>
           </p:cNvPr>
@@ -4420,7 +4420,7 @@
           <p:cNvPr id="9" name="">
             <a:extLst xmlns:a="http://schemas.openxmlformats.org/drawingml/2006/main">
               <a:ext uri="{FF2B5EF4-FFF2-40B4-BE49-F238E27FC236}">
-                <a16:creationId xmlns:a16="http://schemas.microsoft.com/office/drawing/2014/main" id="{5F33F583-E02C-4C3D-8D35-A39424FC58A1}"/>
+                <a16:creationId xmlns:a16="http://schemas.microsoft.com/office/drawing/2014/main" id="{14CCD5AC-A16E-4A71-9BB3-496611D7F4ED}"/>
               </a:ext>
             </a:extLst>
           </p:cNvPr>
@@ -4452,7 +4452,7 @@
           <p:cNvPr id="10" name="">
             <a:extLst xmlns:a="http://schemas.openxmlformats.org/drawingml/2006/main">
               <a:ext uri="{FF2B5EF4-FFF2-40B4-BE49-F238E27FC236}">
-                <a16:creationId xmlns:a16="http://schemas.microsoft.com/office/drawing/2014/main" id="{F9D7F3CE-B807-4532-90C8-69D6E512DFEF}"/>
+                <a16:creationId xmlns:a16="http://schemas.microsoft.com/office/drawing/2014/main" id="{C6A87E0D-A039-4585-88D6-BD2E4E67D35E}"/>
               </a:ext>
             </a:extLst>
           </p:cNvPr>
@@ -4509,7 +4509,7 @@
           <p:cNvPr id="11" name="">
             <a:extLst xmlns:a="http://schemas.openxmlformats.org/drawingml/2006/main">
               <a:ext uri="{FF2B5EF4-FFF2-40B4-BE49-F238E27FC236}">
-                <a16:creationId xmlns:a16="http://schemas.microsoft.com/office/drawing/2014/main" id="{9A8B9807-7502-4A45-B42A-DF0913C462A5}"/>
+                <a16:creationId xmlns:a16="http://schemas.microsoft.com/office/drawing/2014/main" id="{CF2E735A-62AE-47BF-9B11-1DD752F84C6E}"/>
               </a:ext>
             </a:extLst>
           </p:cNvPr>
@@ -4541,7 +4541,7 @@
           <p:cNvPr id="12" name="">
             <a:extLst xmlns:a="http://schemas.openxmlformats.org/drawingml/2006/main">
               <a:ext uri="{FF2B5EF4-FFF2-40B4-BE49-F238E27FC236}">
-                <a16:creationId xmlns:a16="http://schemas.microsoft.com/office/drawing/2014/main" id="{8C1A6812-061B-4C6D-B62F-E75C1C93B28D}"/>
+                <a16:creationId xmlns:a16="http://schemas.microsoft.com/office/drawing/2014/main" id="{31F11184-8484-4FB7-897F-FAC1AD93D5D4}"/>
               </a:ext>
             </a:extLst>
           </p:cNvPr>
@@ -4588,7 +4588,7 @@
                 <a:ea typeface="Arial"/>
                 <a:cs typeface="Arial"/>
               </a:rPr>
-              <a:t>Streamlit app displays explanation and charts</a:t>
+              <a:t>Dashboard separates user explanation from technical trace</a:t>
             </a:r>
           </a:p>
         </p:txBody>
@@ -4598,7 +4598,7 @@
           <p:cNvPr id="13" name="">
             <a:extLst xmlns:a="http://schemas.openxmlformats.org/drawingml/2006/main">
               <a:ext uri="{FF2B5EF4-FFF2-40B4-BE49-F238E27FC236}">
-                <a16:creationId xmlns:a16="http://schemas.microsoft.com/office/drawing/2014/main" id="{62B94287-C4DA-4E27-A027-8F311CC53562}"/>
+                <a16:creationId xmlns:a16="http://schemas.microsoft.com/office/drawing/2014/main" id="{FAA16CB3-CDD4-43F4-ABBF-BE14D627F0DF}"/>
               </a:ext>
             </a:extLst>
           </p:cNvPr>
@@ -4630,7 +4630,7 @@
           <p:cNvPr id="14" name="">
             <a:extLst xmlns:a="http://schemas.openxmlformats.org/drawingml/2006/main">
               <a:ext uri="{FF2B5EF4-FFF2-40B4-BE49-F238E27FC236}">
-                <a16:creationId xmlns:a16="http://schemas.microsoft.com/office/drawing/2014/main" id="{59510C9E-77B4-4401-A31B-E5F52DA63D96}"/>
+                <a16:creationId xmlns:a16="http://schemas.microsoft.com/office/drawing/2014/main" id="{CC83D795-148B-4FE0-A47C-0206D78E0A4C}"/>
               </a:ext>
             </a:extLst>
           </p:cNvPr>
@@ -4685,7 +4685,7 @@
     </p:spTree>
     <p:extLst>
       <p:ext uri="{BB962C8B-B14F-4D97-AF65-F5344CB8AC3E}">
-        <p14:creationId xmlns:p14="http://schemas.microsoft.com/office/powerpoint/2010/main" val="1445911365"/>
+        <p14:creationId xmlns:p14="http://schemas.microsoft.com/office/powerpoint/2010/main" val="833145198"/>
       </p:ext>
     </p:extLst>
   </p:cSld>
@@ -4716,7 +4716,7 @@
           <p:cNvPr id="16" name="">
             <a:extLst xmlns:a="http://schemas.openxmlformats.org/drawingml/2006/main">
               <a:ext uri="{FF2B5EF4-FFF2-40B4-BE49-F238E27FC236}">
-                <a16:creationId xmlns:a16="http://schemas.microsoft.com/office/drawing/2014/main" id="{941E0A48-B4CA-4A18-B4D3-2BBAF671BB1E}"/>
+                <a16:creationId xmlns:a16="http://schemas.microsoft.com/office/drawing/2014/main" id="{BC1FF04B-4BA8-4C98-9714-FFEA583B8381}"/>
               </a:ext>
             </a:extLst>
           </p:cNvPr>
@@ -4773,7 +4773,7 @@
           <p:cNvPr id="2" name="">
             <a:extLst xmlns:a="http://schemas.openxmlformats.org/drawingml/2006/main">
               <a:ext uri="{FF2B5EF4-FFF2-40B4-BE49-F238E27FC236}">
-                <a16:creationId xmlns:a16="http://schemas.microsoft.com/office/drawing/2014/main" id="{3691EE06-CB37-4997-B07B-9F32A5827004}"/>
+                <a16:creationId xmlns:a16="http://schemas.microsoft.com/office/drawing/2014/main" id="{7F11FD78-646F-443D-914F-1A74BFEE4231}"/>
               </a:ext>
             </a:extLst>
           </p:cNvPr>
@@ -4830,7 +4830,7 @@
           <p:cNvPr id="3" name="">
             <a:extLst xmlns:a="http://schemas.openxmlformats.org/drawingml/2006/main">
               <a:ext uri="{FF2B5EF4-FFF2-40B4-BE49-F238E27FC236}">
-                <a16:creationId xmlns:a16="http://schemas.microsoft.com/office/drawing/2014/main" id="{A8C11CD8-1966-4C29-BF7D-F0A3664A63CC}"/>
+                <a16:creationId xmlns:a16="http://schemas.microsoft.com/office/drawing/2014/main" id="{4D584D3E-313A-4A82-896C-4872A914C888}"/>
               </a:ext>
             </a:extLst>
           </p:cNvPr>
@@ -4887,7 +4887,7 @@
           <p:cNvPr id="4" name="">
             <a:extLst xmlns:a="http://schemas.openxmlformats.org/drawingml/2006/main">
               <a:ext uri="{FF2B5EF4-FFF2-40B4-BE49-F238E27FC236}">
-                <a16:creationId xmlns:a16="http://schemas.microsoft.com/office/drawing/2014/main" id="{633A743B-D23D-45FD-99E6-18EB0C8C0A67}"/>
+                <a16:creationId xmlns:a16="http://schemas.microsoft.com/office/drawing/2014/main" id="{1C1F13E7-3166-4E24-BCB0-714383452440}"/>
               </a:ext>
             </a:extLst>
           </p:cNvPr>
@@ -4919,7 +4919,7 @@
           <p:cNvPr id="5" name="">
             <a:extLst xmlns:a="http://schemas.openxmlformats.org/drawingml/2006/main">
               <a:ext uri="{FF2B5EF4-FFF2-40B4-BE49-F238E27FC236}">
-                <a16:creationId xmlns:a16="http://schemas.microsoft.com/office/drawing/2014/main" id="{F488E627-FA4D-4E3A-93A2-59517F62B887}"/>
+                <a16:creationId xmlns:a16="http://schemas.microsoft.com/office/drawing/2014/main" id="{02056281-50D4-46F7-BA1D-0CF1782FBAFC}"/>
               </a:ext>
             </a:extLst>
           </p:cNvPr>
@@ -4976,7 +4976,7 @@
           <p:cNvPr id="6" name="">
             <a:extLst xmlns:a="http://schemas.openxmlformats.org/drawingml/2006/main">
               <a:ext uri="{FF2B5EF4-FFF2-40B4-BE49-F238E27FC236}">
-                <a16:creationId xmlns:a16="http://schemas.microsoft.com/office/drawing/2014/main" id="{F558140A-EBA0-44FE-A6E0-3BE188F3DD9E}"/>
+                <a16:creationId xmlns:a16="http://schemas.microsoft.com/office/drawing/2014/main" id="{A22BEC5A-508F-4EA9-B28A-0E3713F1FF57}"/>
               </a:ext>
             </a:extLst>
           </p:cNvPr>
@@ -5008,7 +5008,7 @@
           <p:cNvPr id="7" name="">
             <a:extLst xmlns:a="http://schemas.openxmlformats.org/drawingml/2006/main">
               <a:ext uri="{FF2B5EF4-FFF2-40B4-BE49-F238E27FC236}">
-                <a16:creationId xmlns:a16="http://schemas.microsoft.com/office/drawing/2014/main" id="{44455616-6BB5-4E89-83E6-610DBDB023CB}"/>
+                <a16:creationId xmlns:a16="http://schemas.microsoft.com/office/drawing/2014/main" id="{602DBC61-AB7D-4411-9FF7-FE9FD59D2F6E}"/>
               </a:ext>
             </a:extLst>
           </p:cNvPr>
@@ -5065,7 +5065,7 @@
           <p:cNvPr id="8" name="">
             <a:extLst xmlns:a="http://schemas.openxmlformats.org/drawingml/2006/main">
               <a:ext uri="{FF2B5EF4-FFF2-40B4-BE49-F238E27FC236}">
-                <a16:creationId xmlns:a16="http://schemas.microsoft.com/office/drawing/2014/main" id="{F7EC2950-2C58-40B6-9F69-9C2A9C4DBC47}"/>
+                <a16:creationId xmlns:a16="http://schemas.microsoft.com/office/drawing/2014/main" id="{87D7C0A6-DE54-428D-8EBA-0D3A6F6460D3}"/>
               </a:ext>
             </a:extLst>
           </p:cNvPr>
@@ -5097,7 +5097,7 @@
           <p:cNvPr id="9" name="">
             <a:extLst xmlns:a="http://schemas.openxmlformats.org/drawingml/2006/main">
               <a:ext uri="{FF2B5EF4-FFF2-40B4-BE49-F238E27FC236}">
-                <a16:creationId xmlns:a16="http://schemas.microsoft.com/office/drawing/2014/main" id="{BA2DD26B-C8A0-4836-9EB6-C9DAF8C0C843}"/>
+                <a16:creationId xmlns:a16="http://schemas.microsoft.com/office/drawing/2014/main" id="{8B000866-DA92-456F-A4DC-4214A53264DD}"/>
               </a:ext>
             </a:extLst>
           </p:cNvPr>
@@ -5154,7 +5154,7 @@
           <p:cNvPr id="10" name="">
             <a:extLst xmlns:a="http://schemas.openxmlformats.org/drawingml/2006/main">
               <a:ext uri="{FF2B5EF4-FFF2-40B4-BE49-F238E27FC236}">
-                <a16:creationId xmlns:a16="http://schemas.microsoft.com/office/drawing/2014/main" id="{C7F87BEF-5754-4FC1-921F-6C869018521E}"/>
+                <a16:creationId xmlns:a16="http://schemas.microsoft.com/office/drawing/2014/main" id="{1561C72F-78E3-4652-BDA8-1465CD19B0B9}"/>
               </a:ext>
             </a:extLst>
           </p:cNvPr>
@@ -5186,7 +5186,7 @@
           <p:cNvPr id="11" name="">
             <a:extLst xmlns:a="http://schemas.openxmlformats.org/drawingml/2006/main">
               <a:ext uri="{FF2B5EF4-FFF2-40B4-BE49-F238E27FC236}">
-                <a16:creationId xmlns:a16="http://schemas.microsoft.com/office/drawing/2014/main" id="{A358A81E-CCEC-49F6-B10B-105FB52A63BC}"/>
+                <a16:creationId xmlns:a16="http://schemas.microsoft.com/office/drawing/2014/main" id="{A8F2B46F-144F-499C-B43D-4A29306F8958}"/>
               </a:ext>
             </a:extLst>
           </p:cNvPr>
@@ -5243,7 +5243,7 @@
           <p:cNvPr id="12" name="">
             <a:extLst xmlns:a="http://schemas.openxmlformats.org/drawingml/2006/main">
               <a:ext uri="{FF2B5EF4-FFF2-40B4-BE49-F238E27FC236}">
-                <a16:creationId xmlns:a16="http://schemas.microsoft.com/office/drawing/2014/main" id="{4BE24FC5-7B84-4478-BDB4-D2BC2E6E6007}"/>
+                <a16:creationId xmlns:a16="http://schemas.microsoft.com/office/drawing/2014/main" id="{64B91A2C-207B-430D-96A2-511F63A7638A}"/>
               </a:ext>
             </a:extLst>
           </p:cNvPr>
@@ -5275,7 +5275,7 @@
           <p:cNvPr id="13" name="">
             <a:extLst xmlns:a="http://schemas.openxmlformats.org/drawingml/2006/main">
               <a:ext uri="{FF2B5EF4-FFF2-40B4-BE49-F238E27FC236}">
-                <a16:creationId xmlns:a16="http://schemas.microsoft.com/office/drawing/2014/main" id="{B2FF9B02-CE69-43B9-BE94-2CABC3C340CD}"/>
+                <a16:creationId xmlns:a16="http://schemas.microsoft.com/office/drawing/2014/main" id="{08D90555-148C-4397-80F4-9C8B3135DE53}"/>
               </a:ext>
             </a:extLst>
           </p:cNvPr>
@@ -5332,7 +5332,7 @@
           <p:cNvPr id="14" name="">
             <a:extLst xmlns:a="http://schemas.openxmlformats.org/drawingml/2006/main">
               <a:ext uri="{FF2B5EF4-FFF2-40B4-BE49-F238E27FC236}">
-                <a16:creationId xmlns:a16="http://schemas.microsoft.com/office/drawing/2014/main" id="{B06CC6DD-DFF6-4EE6-A89D-2044AA696A53}"/>
+                <a16:creationId xmlns:a16="http://schemas.microsoft.com/office/drawing/2014/main" id="{48192E46-9B47-400F-AC29-3105AA7B670F}"/>
               </a:ext>
             </a:extLst>
           </p:cNvPr>
@@ -5389,7 +5389,7 @@
           <p:cNvPr id="15" name="">
             <a:extLst xmlns:a="http://schemas.openxmlformats.org/drawingml/2006/main">
               <a:ext uri="{FF2B5EF4-FFF2-40B4-BE49-F238E27FC236}">
-                <a16:creationId xmlns:a16="http://schemas.microsoft.com/office/drawing/2014/main" id="{0151CF47-9748-414A-8DBE-607DED37FE00}"/>
+                <a16:creationId xmlns:a16="http://schemas.microsoft.com/office/drawing/2014/main" id="{D40778B9-55DA-4B9A-8246-8393EEC14DD2}"/>
               </a:ext>
             </a:extLst>
           </p:cNvPr>
@@ -5444,7 +5444,7 @@
     </p:spTree>
     <p:extLst>
       <p:ext uri="{BB962C8B-B14F-4D97-AF65-F5344CB8AC3E}">
-        <p14:creationId xmlns:p14="http://schemas.microsoft.com/office/powerpoint/2010/main" val="2065078293"/>
+        <p14:creationId xmlns:p14="http://schemas.microsoft.com/office/powerpoint/2010/main" val="1800258856"/>
       </p:ext>
     </p:extLst>
   </p:cSld>
@@ -5475,7 +5475,7 @@
           <p:cNvPr id="23" name="">
             <a:extLst xmlns:a="http://schemas.openxmlformats.org/drawingml/2006/main">
               <a:ext uri="{FF2B5EF4-FFF2-40B4-BE49-F238E27FC236}">
-                <a16:creationId xmlns:a16="http://schemas.microsoft.com/office/drawing/2014/main" id="{33B14BC2-2EDF-402D-A3F0-BE551C07A9AD}"/>
+                <a16:creationId xmlns:a16="http://schemas.microsoft.com/office/drawing/2014/main" id="{23762A63-4322-4332-B304-4D38A66C8E62}"/>
               </a:ext>
             </a:extLst>
           </p:cNvPr>
@@ -5532,7 +5532,7 @@
           <p:cNvPr id="2" name="">
             <a:extLst xmlns:a="http://schemas.openxmlformats.org/drawingml/2006/main">
               <a:ext uri="{FF2B5EF4-FFF2-40B4-BE49-F238E27FC236}">
-                <a16:creationId xmlns:a16="http://schemas.microsoft.com/office/drawing/2014/main" id="{4A085DF8-B752-4BE4-B10F-527F7745B1DF}"/>
+                <a16:creationId xmlns:a16="http://schemas.microsoft.com/office/drawing/2014/main" id="{34FD3818-9F02-4B90-ADAB-A7D31A505C27}"/>
               </a:ext>
             </a:extLst>
           </p:cNvPr>
@@ -5589,7 +5589,7 @@
           <p:cNvPr id="3" name="">
             <a:extLst xmlns:a="http://schemas.openxmlformats.org/drawingml/2006/main">
               <a:ext uri="{FF2B5EF4-FFF2-40B4-BE49-F238E27FC236}">
-                <a16:creationId xmlns:a16="http://schemas.microsoft.com/office/drawing/2014/main" id="{42942AB6-877D-4F22-AB0B-E1E394394004}"/>
+                <a16:creationId xmlns:a16="http://schemas.microsoft.com/office/drawing/2014/main" id="{F2C02AC4-B5B3-4314-8F40-CCA874167D07}"/>
               </a:ext>
             </a:extLst>
           </p:cNvPr>
@@ -5646,7 +5646,7 @@
           <p:cNvPr id="4" name="">
             <a:extLst xmlns:a="http://schemas.openxmlformats.org/drawingml/2006/main">
               <a:ext uri="{FF2B5EF4-FFF2-40B4-BE49-F238E27FC236}">
-                <a16:creationId xmlns:a16="http://schemas.microsoft.com/office/drawing/2014/main" id="{C2DFF33D-5B89-4CFF-986E-B243C2041839}"/>
+                <a16:creationId xmlns:a16="http://schemas.microsoft.com/office/drawing/2014/main" id="{AB0662C8-51AE-4C21-846C-49BB95EE39E3}"/>
               </a:ext>
             </a:extLst>
           </p:cNvPr>
@@ -5678,7 +5678,7 @@
           <p:cNvPr id="5" name="">
             <a:extLst xmlns:a="http://schemas.openxmlformats.org/drawingml/2006/main">
               <a:ext uri="{FF2B5EF4-FFF2-40B4-BE49-F238E27FC236}">
-                <a16:creationId xmlns:a16="http://schemas.microsoft.com/office/drawing/2014/main" id="{514E7E4C-CF7E-4065-87F5-B2EB42FBDDEC}"/>
+                <a16:creationId xmlns:a16="http://schemas.microsoft.com/office/drawing/2014/main" id="{71FBBCD4-A1A1-498C-BE88-ECDC9432E55B}"/>
               </a:ext>
             </a:extLst>
           </p:cNvPr>
@@ -5735,7 +5735,7 @@
           <p:cNvPr id="6" name="">
             <a:extLst xmlns:a="http://schemas.openxmlformats.org/drawingml/2006/main">
               <a:ext uri="{FF2B5EF4-FFF2-40B4-BE49-F238E27FC236}">
-                <a16:creationId xmlns:a16="http://schemas.microsoft.com/office/drawing/2014/main" id="{8806DD26-14B8-42C0-94E9-ECB7CB2952CD}"/>
+                <a16:creationId xmlns:a16="http://schemas.microsoft.com/office/drawing/2014/main" id="{A8973065-18C0-466B-8716-7FD3158BDE75}"/>
               </a:ext>
             </a:extLst>
           </p:cNvPr>
@@ -5792,7 +5792,7 @@
           <p:cNvPr id="7" name="">
             <a:extLst xmlns:a="http://schemas.openxmlformats.org/drawingml/2006/main">
               <a:ext uri="{FF2B5EF4-FFF2-40B4-BE49-F238E27FC236}">
-                <a16:creationId xmlns:a16="http://schemas.microsoft.com/office/drawing/2014/main" id="{9E5FFBA9-8F1A-4D77-A186-89040CE4F192}"/>
+                <a16:creationId xmlns:a16="http://schemas.microsoft.com/office/drawing/2014/main" id="{0335863F-C285-4FE9-B293-8A0B58FCAE90}"/>
               </a:ext>
             </a:extLst>
           </p:cNvPr>
@@ -5824,7 +5824,7 @@
           <p:cNvPr id="8" name="">
             <a:extLst xmlns:a="http://schemas.openxmlformats.org/drawingml/2006/main">
               <a:ext uri="{FF2B5EF4-FFF2-40B4-BE49-F238E27FC236}">
-                <a16:creationId xmlns:a16="http://schemas.microsoft.com/office/drawing/2014/main" id="{5550C570-09C9-4F3F-BEC3-BF7DF31A1E47}"/>
+                <a16:creationId xmlns:a16="http://schemas.microsoft.com/office/drawing/2014/main" id="{C0115009-8734-4572-B26B-8B8D22CD2A91}"/>
               </a:ext>
             </a:extLst>
           </p:cNvPr>
@@ -5881,7 +5881,7 @@
           <p:cNvPr id="9" name="">
             <a:extLst xmlns:a="http://schemas.openxmlformats.org/drawingml/2006/main">
               <a:ext uri="{FF2B5EF4-FFF2-40B4-BE49-F238E27FC236}">
-                <a16:creationId xmlns:a16="http://schemas.microsoft.com/office/drawing/2014/main" id="{05F8BE50-D183-4B1C-8560-AFF19EE23195}"/>
+                <a16:creationId xmlns:a16="http://schemas.microsoft.com/office/drawing/2014/main" id="{4D080361-60A9-455B-A826-D30FDAD38AF8}"/>
               </a:ext>
             </a:extLst>
           </p:cNvPr>
@@ -5938,7 +5938,7 @@
           <p:cNvPr id="10" name="">
             <a:extLst xmlns:a="http://schemas.openxmlformats.org/drawingml/2006/main">
               <a:ext uri="{FF2B5EF4-FFF2-40B4-BE49-F238E27FC236}">
-                <a16:creationId xmlns:a16="http://schemas.microsoft.com/office/drawing/2014/main" id="{3CF018A1-FD49-40F1-8F21-815D37D18738}"/>
+                <a16:creationId xmlns:a16="http://schemas.microsoft.com/office/drawing/2014/main" id="{6B5326D6-2FBE-448D-949E-CCC0F7B0DF6A}"/>
               </a:ext>
             </a:extLst>
           </p:cNvPr>
@@ -5970,7 +5970,7 @@
           <p:cNvPr id="11" name="">
             <a:extLst xmlns:a="http://schemas.openxmlformats.org/drawingml/2006/main">
               <a:ext uri="{FF2B5EF4-FFF2-40B4-BE49-F238E27FC236}">
-                <a16:creationId xmlns:a16="http://schemas.microsoft.com/office/drawing/2014/main" id="{6C5FD9C6-5AAC-4C5C-BBC4-CBD0CF017CA9}"/>
+                <a16:creationId xmlns:a16="http://schemas.microsoft.com/office/drawing/2014/main" id="{B1A19422-224E-4DE1-A6C8-29BF2CC19626}"/>
               </a:ext>
             </a:extLst>
           </p:cNvPr>
@@ -6027,7 +6027,7 @@
           <p:cNvPr id="12" name="">
             <a:extLst xmlns:a="http://schemas.openxmlformats.org/drawingml/2006/main">
               <a:ext uri="{FF2B5EF4-FFF2-40B4-BE49-F238E27FC236}">
-                <a16:creationId xmlns:a16="http://schemas.microsoft.com/office/drawing/2014/main" id="{8135301A-6654-421E-85FA-68AEA56FB787}"/>
+                <a16:creationId xmlns:a16="http://schemas.microsoft.com/office/drawing/2014/main" id="{F5D60599-9D8B-48E7-8CD6-5C9E8BEAADA1}"/>
               </a:ext>
             </a:extLst>
           </p:cNvPr>
@@ -6084,7 +6084,7 @@
           <p:cNvPr id="13" name="">
             <a:extLst xmlns:a="http://schemas.openxmlformats.org/drawingml/2006/main">
               <a:ext uri="{FF2B5EF4-FFF2-40B4-BE49-F238E27FC236}">
-                <a16:creationId xmlns:a16="http://schemas.microsoft.com/office/drawing/2014/main" id="{C9D8B0F8-1533-4432-ACDD-4CFD4CBA53B6}"/>
+                <a16:creationId xmlns:a16="http://schemas.microsoft.com/office/drawing/2014/main" id="{80384DA3-3CEA-4684-BDFF-AEA8F213E2A3}"/>
               </a:ext>
             </a:extLst>
           </p:cNvPr>
@@ -6116,7 +6116,7 @@
           <p:cNvPr id="14" name="">
             <a:extLst xmlns:a="http://schemas.openxmlformats.org/drawingml/2006/main">
               <a:ext uri="{FF2B5EF4-FFF2-40B4-BE49-F238E27FC236}">
-                <a16:creationId xmlns:a16="http://schemas.microsoft.com/office/drawing/2014/main" id="{93A6DCC1-AC50-4FBF-A0A8-813A78FE2FAA}"/>
+                <a16:creationId xmlns:a16="http://schemas.microsoft.com/office/drawing/2014/main" id="{F107637F-5EAD-4E3F-8E20-DBD24ED85C0C}"/>
               </a:ext>
             </a:extLst>
           </p:cNvPr>
@@ -6173,7 +6173,7 @@
           <p:cNvPr id="15" name="">
             <a:extLst xmlns:a="http://schemas.openxmlformats.org/drawingml/2006/main">
               <a:ext uri="{FF2B5EF4-FFF2-40B4-BE49-F238E27FC236}">
-                <a16:creationId xmlns:a16="http://schemas.microsoft.com/office/drawing/2014/main" id="{69EADCF8-3E65-404A-A34E-71DC6100CD9B}"/>
+                <a16:creationId xmlns:a16="http://schemas.microsoft.com/office/drawing/2014/main" id="{019B6F98-1B69-49D1-89C2-639D4E740455}"/>
               </a:ext>
             </a:extLst>
           </p:cNvPr>
@@ -6230,7 +6230,7 @@
           <p:cNvPr id="16" name="">
             <a:extLst xmlns:a="http://schemas.openxmlformats.org/drawingml/2006/main">
               <a:ext uri="{FF2B5EF4-FFF2-40B4-BE49-F238E27FC236}">
-                <a16:creationId xmlns:a16="http://schemas.microsoft.com/office/drawing/2014/main" id="{C5AF7FC4-3CB3-4A33-85D2-5AE76AEDC9B1}"/>
+                <a16:creationId xmlns:a16="http://schemas.microsoft.com/office/drawing/2014/main" id="{1AA17FB7-7C61-4BBE-9611-3F12324ACD14}"/>
               </a:ext>
             </a:extLst>
           </p:cNvPr>
@@ -6262,7 +6262,7 @@
           <p:cNvPr id="17" name="">
             <a:extLst xmlns:a="http://schemas.openxmlformats.org/drawingml/2006/main">
               <a:ext uri="{FF2B5EF4-FFF2-40B4-BE49-F238E27FC236}">
-                <a16:creationId xmlns:a16="http://schemas.microsoft.com/office/drawing/2014/main" id="{0D406542-0B12-495C-A834-EACBA2B2A9A8}"/>
+                <a16:creationId xmlns:a16="http://schemas.microsoft.com/office/drawing/2014/main" id="{7873D71D-CE4F-43EC-A57D-468F371253EB}"/>
               </a:ext>
             </a:extLst>
           </p:cNvPr>
@@ -6319,7 +6319,7 @@
           <p:cNvPr id="18" name="">
             <a:extLst xmlns:a="http://schemas.openxmlformats.org/drawingml/2006/main">
               <a:ext uri="{FF2B5EF4-FFF2-40B4-BE49-F238E27FC236}">
-                <a16:creationId xmlns:a16="http://schemas.microsoft.com/office/drawing/2014/main" id="{82587459-C5BC-4A04-97BC-A0650D2B83A1}"/>
+                <a16:creationId xmlns:a16="http://schemas.microsoft.com/office/drawing/2014/main" id="{B00020EE-67EF-4FBE-95D6-E476B5AA315D}"/>
               </a:ext>
             </a:extLst>
           </p:cNvPr>
@@ -6376,7 +6376,7 @@
           <p:cNvPr id="19" name="">
             <a:extLst xmlns:a="http://schemas.openxmlformats.org/drawingml/2006/main">
               <a:ext uri="{FF2B5EF4-FFF2-40B4-BE49-F238E27FC236}">
-                <a16:creationId xmlns:a16="http://schemas.microsoft.com/office/drawing/2014/main" id="{29E2E4CF-89E3-4C78-AC21-F0EA16264720}"/>
+                <a16:creationId xmlns:a16="http://schemas.microsoft.com/office/drawing/2014/main" id="{3E89040B-41EF-4ECF-864A-12D81012FAD0}"/>
               </a:ext>
             </a:extLst>
           </p:cNvPr>
@@ -6408,7 +6408,7 @@
           <p:cNvPr id="20" name="">
             <a:extLst xmlns:a="http://schemas.openxmlformats.org/drawingml/2006/main">
               <a:ext uri="{FF2B5EF4-FFF2-40B4-BE49-F238E27FC236}">
-                <a16:creationId xmlns:a16="http://schemas.microsoft.com/office/drawing/2014/main" id="{F3008475-1AC7-44B5-AD2B-E2A5B13EAD61}"/>
+                <a16:creationId xmlns:a16="http://schemas.microsoft.com/office/drawing/2014/main" id="{7DF03BAD-8956-4323-992B-D854D9353E9B}"/>
               </a:ext>
             </a:extLst>
           </p:cNvPr>
@@ -6465,7 +6465,7 @@
           <p:cNvPr id="21" name="">
             <a:extLst xmlns:a="http://schemas.openxmlformats.org/drawingml/2006/main">
               <a:ext uri="{FF2B5EF4-FFF2-40B4-BE49-F238E27FC236}">
-                <a16:creationId xmlns:a16="http://schemas.microsoft.com/office/drawing/2014/main" id="{7EF60D94-7430-4953-803F-6D4A4AA72603}"/>
+                <a16:creationId xmlns:a16="http://schemas.microsoft.com/office/drawing/2014/main" id="{80D37307-3EEE-4EAC-91F5-D6958A25EF78}"/>
               </a:ext>
             </a:extLst>
           </p:cNvPr>
@@ -6522,7 +6522,7 @@
           <p:cNvPr id="22" name="">
             <a:extLst xmlns:a="http://schemas.openxmlformats.org/drawingml/2006/main">
               <a:ext uri="{FF2B5EF4-FFF2-40B4-BE49-F238E27FC236}">
-                <a16:creationId xmlns:a16="http://schemas.microsoft.com/office/drawing/2014/main" id="{249BE776-6BA5-4FDD-9D6B-BF4C7A5340DA}"/>
+                <a16:creationId xmlns:a16="http://schemas.microsoft.com/office/drawing/2014/main" id="{7F724896-E50F-4C1E-A6DF-CA600D62437D}"/>
               </a:ext>
             </a:extLst>
           </p:cNvPr>
@@ -6577,7 +6577,7 @@
     </p:spTree>
     <p:extLst>
       <p:ext uri="{BB962C8B-B14F-4D97-AF65-F5344CB8AC3E}">
-        <p14:creationId xmlns:p14="http://schemas.microsoft.com/office/powerpoint/2010/main" val="1422006259"/>
+        <p14:creationId xmlns:p14="http://schemas.microsoft.com/office/powerpoint/2010/main" val="632877822"/>
       </p:ext>
     </p:extLst>
   </p:cSld>
@@ -6608,7 +6608,7 @@
           <p:cNvPr id="15" name="">
             <a:extLst xmlns:a="http://schemas.openxmlformats.org/drawingml/2006/main">
               <a:ext uri="{FF2B5EF4-FFF2-40B4-BE49-F238E27FC236}">
-                <a16:creationId xmlns:a16="http://schemas.microsoft.com/office/drawing/2014/main" id="{A15146B3-9BA9-47EA-A7D8-651B52BD5484}"/>
+                <a16:creationId xmlns:a16="http://schemas.microsoft.com/office/drawing/2014/main" id="{AC0E6575-FA01-44CC-BCB4-1234A922A709}"/>
               </a:ext>
             </a:extLst>
           </p:cNvPr>
@@ -6665,7 +6665,7 @@
           <p:cNvPr id="2" name="">
             <a:extLst xmlns:a="http://schemas.openxmlformats.org/drawingml/2006/main">
               <a:ext uri="{FF2B5EF4-FFF2-40B4-BE49-F238E27FC236}">
-                <a16:creationId xmlns:a16="http://schemas.microsoft.com/office/drawing/2014/main" id="{54F28C26-E0DB-4BDD-B923-A644FCF5F42D}"/>
+                <a16:creationId xmlns:a16="http://schemas.microsoft.com/office/drawing/2014/main" id="{F03314F6-CA2B-4BD5-B809-B32B202212C8}"/>
               </a:ext>
             </a:extLst>
           </p:cNvPr>
@@ -6722,7 +6722,7 @@
           <p:cNvPr id="3" name="">
             <a:extLst xmlns:a="http://schemas.openxmlformats.org/drawingml/2006/main">
               <a:ext uri="{FF2B5EF4-FFF2-40B4-BE49-F238E27FC236}">
-                <a16:creationId xmlns:a16="http://schemas.microsoft.com/office/drawing/2014/main" id="{0ED4A605-24B4-49EA-B224-73A6C994BCC4}"/>
+                <a16:creationId xmlns:a16="http://schemas.microsoft.com/office/drawing/2014/main" id="{83FE5B84-D4F8-4F10-9D97-A254462A2F5E}"/>
               </a:ext>
             </a:extLst>
           </p:cNvPr>
@@ -6779,7 +6779,7 @@
           <p:cNvPr id="4" name="">
             <a:extLst xmlns:a="http://schemas.openxmlformats.org/drawingml/2006/main">
               <a:ext uri="{FF2B5EF4-FFF2-40B4-BE49-F238E27FC236}">
-                <a16:creationId xmlns:a16="http://schemas.microsoft.com/office/drawing/2014/main" id="{D2E2B06B-8EA9-42EE-AA26-8E5B217E1E92}"/>
+                <a16:creationId xmlns:a16="http://schemas.microsoft.com/office/drawing/2014/main" id="{86D04B33-BF45-46E2-A512-D0F5FCD55BD7}"/>
               </a:ext>
             </a:extLst>
           </p:cNvPr>
@@ -6836,7 +6836,7 @@
           <p:cNvPr id="5" name="">
             <a:extLst xmlns:a="http://schemas.openxmlformats.org/drawingml/2006/main">
               <a:ext uri="{FF2B5EF4-FFF2-40B4-BE49-F238E27FC236}">
-                <a16:creationId xmlns:a16="http://schemas.microsoft.com/office/drawing/2014/main" id="{61B5A986-CB7A-43AD-8C5B-99AE2FD95D5C}"/>
+                <a16:creationId xmlns:a16="http://schemas.microsoft.com/office/drawing/2014/main" id="{A9285422-831E-408E-A1D8-6F70B8E4EEE8}"/>
               </a:ext>
             </a:extLst>
           </p:cNvPr>
@@ -6868,7 +6868,7 @@
           <p:cNvPr id="6" name="">
             <a:extLst xmlns:a="http://schemas.openxmlformats.org/drawingml/2006/main">
               <a:ext uri="{FF2B5EF4-FFF2-40B4-BE49-F238E27FC236}">
-                <a16:creationId xmlns:a16="http://schemas.microsoft.com/office/drawing/2014/main" id="{3EA352BF-FCAE-47F9-9714-250B77A6DFA5}"/>
+                <a16:creationId xmlns:a16="http://schemas.microsoft.com/office/drawing/2014/main" id="{F32995D6-0AF1-40DB-9C98-C36790750755}"/>
               </a:ext>
             </a:extLst>
           </p:cNvPr>
@@ -6925,7 +6925,7 @@
           <p:cNvPr id="7" name="">
             <a:extLst xmlns:a="http://schemas.openxmlformats.org/drawingml/2006/main">
               <a:ext uri="{FF2B5EF4-FFF2-40B4-BE49-F238E27FC236}">
-                <a16:creationId xmlns:a16="http://schemas.microsoft.com/office/drawing/2014/main" id="{7F1134D2-010E-40BA-A9D9-BC97C8765C8E}"/>
+                <a16:creationId xmlns:a16="http://schemas.microsoft.com/office/drawing/2014/main" id="{71997D10-3A98-4AE5-8155-AED7BD391833}"/>
               </a:ext>
             </a:extLst>
           </p:cNvPr>
@@ -6957,7 +6957,7 @@
           <p:cNvPr id="8" name="">
             <a:extLst xmlns:a="http://schemas.openxmlformats.org/drawingml/2006/main">
               <a:ext uri="{FF2B5EF4-FFF2-40B4-BE49-F238E27FC236}">
-                <a16:creationId xmlns:a16="http://schemas.microsoft.com/office/drawing/2014/main" id="{752B55EF-2475-438D-9A94-BAC13F76DA5E}"/>
+                <a16:creationId xmlns:a16="http://schemas.microsoft.com/office/drawing/2014/main" id="{31A5616E-61B4-4126-9A8E-BD26D8A9DDCE}"/>
               </a:ext>
             </a:extLst>
           </p:cNvPr>
@@ -7014,7 +7014,7 @@
           <p:cNvPr id="9" name="">
             <a:extLst xmlns:a="http://schemas.openxmlformats.org/drawingml/2006/main">
               <a:ext uri="{FF2B5EF4-FFF2-40B4-BE49-F238E27FC236}">
-                <a16:creationId xmlns:a16="http://schemas.microsoft.com/office/drawing/2014/main" id="{B80144F7-C4CF-4193-B8F9-20A31124722C}"/>
+                <a16:creationId xmlns:a16="http://schemas.microsoft.com/office/drawing/2014/main" id="{3426CD55-A6F0-416E-857D-443706E8175D}"/>
               </a:ext>
             </a:extLst>
           </p:cNvPr>
@@ -7046,7 +7046,7 @@
           <p:cNvPr id="10" name="">
             <a:extLst xmlns:a="http://schemas.openxmlformats.org/drawingml/2006/main">
               <a:ext uri="{FF2B5EF4-FFF2-40B4-BE49-F238E27FC236}">
-                <a16:creationId xmlns:a16="http://schemas.microsoft.com/office/drawing/2014/main" id="{ADF59FD9-FAA3-4A9F-9425-C9C762DA5DCF}"/>
+                <a16:creationId xmlns:a16="http://schemas.microsoft.com/office/drawing/2014/main" id="{DBF90823-74E1-4D87-8B52-BD674CD71C60}"/>
               </a:ext>
             </a:extLst>
           </p:cNvPr>
@@ -7103,7 +7103,7 @@
           <p:cNvPr id="11" name="">
             <a:extLst xmlns:a="http://schemas.openxmlformats.org/drawingml/2006/main">
               <a:ext uri="{FF2B5EF4-FFF2-40B4-BE49-F238E27FC236}">
-                <a16:creationId xmlns:a16="http://schemas.microsoft.com/office/drawing/2014/main" id="{12C2FF14-8791-4A42-9429-182BD274B016}"/>
+                <a16:creationId xmlns:a16="http://schemas.microsoft.com/office/drawing/2014/main" id="{361E52BA-FD5D-4919-A72A-2965FAD95061}"/>
               </a:ext>
             </a:extLst>
           </p:cNvPr>
@@ -7135,7 +7135,7 @@
           <p:cNvPr id="12" name="">
             <a:extLst xmlns:a="http://schemas.openxmlformats.org/drawingml/2006/main">
               <a:ext uri="{FF2B5EF4-FFF2-40B4-BE49-F238E27FC236}">
-                <a16:creationId xmlns:a16="http://schemas.microsoft.com/office/drawing/2014/main" id="{031DF841-2F5E-4E4E-866A-67DEF6672C4C}"/>
+                <a16:creationId xmlns:a16="http://schemas.microsoft.com/office/drawing/2014/main" id="{A68FF7FB-057F-4322-9984-112E4FA2DA4A}"/>
               </a:ext>
             </a:extLst>
           </p:cNvPr>
@@ -7192,7 +7192,7 @@
           <p:cNvPr id="13" name="">
             <a:extLst xmlns:a="http://schemas.openxmlformats.org/drawingml/2006/main">
               <a:ext uri="{FF2B5EF4-FFF2-40B4-BE49-F238E27FC236}">
-                <a16:creationId xmlns:a16="http://schemas.microsoft.com/office/drawing/2014/main" id="{2459B22D-A15B-4D0E-9B26-0513A318C216}"/>
+                <a16:creationId xmlns:a16="http://schemas.microsoft.com/office/drawing/2014/main" id="{53DD218B-1270-41C7-8477-D294B61D0F1B}"/>
               </a:ext>
             </a:extLst>
           </p:cNvPr>
@@ -7224,7 +7224,7 @@
           <p:cNvPr id="14" name="">
             <a:extLst xmlns:a="http://schemas.openxmlformats.org/drawingml/2006/main">
               <a:ext uri="{FF2B5EF4-FFF2-40B4-BE49-F238E27FC236}">
-                <a16:creationId xmlns:a16="http://schemas.microsoft.com/office/drawing/2014/main" id="{2EC762E4-A662-4877-92AB-2DF3E069701D}"/>
+                <a16:creationId xmlns:a16="http://schemas.microsoft.com/office/drawing/2014/main" id="{0F998C62-5482-4402-820B-DCB2D64E3E5A}"/>
               </a:ext>
             </a:extLst>
           </p:cNvPr>
@@ -7279,7 +7279,7 @@
     </p:spTree>
     <p:extLst>
       <p:ext uri="{BB962C8B-B14F-4D97-AF65-F5344CB8AC3E}">
-        <p14:creationId xmlns:p14="http://schemas.microsoft.com/office/powerpoint/2010/main" val="519465058"/>
+        <p14:creationId xmlns:p14="http://schemas.microsoft.com/office/powerpoint/2010/main" val="1303776773"/>
       </p:ext>
     </p:extLst>
   </p:cSld>
@@ -7310,7 +7310,7 @@
           <p:cNvPr id="14" name="">
             <a:extLst xmlns:a="http://schemas.openxmlformats.org/drawingml/2006/main">
               <a:ext uri="{FF2B5EF4-FFF2-40B4-BE49-F238E27FC236}">
-                <a16:creationId xmlns:a16="http://schemas.microsoft.com/office/drawing/2014/main" id="{940FFBB1-F096-4A7F-9081-97FDB134D157}"/>
+                <a16:creationId xmlns:a16="http://schemas.microsoft.com/office/drawing/2014/main" id="{7805A3E7-1269-495E-AF6B-C5F67B31AF0B}"/>
               </a:ext>
             </a:extLst>
           </p:cNvPr>
@@ -7367,7 +7367,7 @@
           <p:cNvPr id="2" name="">
             <a:extLst xmlns:a="http://schemas.openxmlformats.org/drawingml/2006/main">
               <a:ext uri="{FF2B5EF4-FFF2-40B4-BE49-F238E27FC236}">
-                <a16:creationId xmlns:a16="http://schemas.microsoft.com/office/drawing/2014/main" id="{921B1D5A-B832-4033-AFA7-1A012801CA85}"/>
+                <a16:creationId xmlns:a16="http://schemas.microsoft.com/office/drawing/2014/main" id="{CEA11D15-4D4B-4CC2-95F0-368A4EF4814C}"/>
               </a:ext>
             </a:extLst>
           </p:cNvPr>
@@ -7424,7 +7424,7 @@
           <p:cNvPr id="3" name="">
             <a:extLst xmlns:a="http://schemas.openxmlformats.org/drawingml/2006/main">
               <a:ext uri="{FF2B5EF4-FFF2-40B4-BE49-F238E27FC236}">
-                <a16:creationId xmlns:a16="http://schemas.microsoft.com/office/drawing/2014/main" id="{29A3AC6B-DF0B-485D-8D7A-3D5EA5D0A784}"/>
+                <a16:creationId xmlns:a16="http://schemas.microsoft.com/office/drawing/2014/main" id="{DB1D882D-B23B-418D-88E9-2547E2E10EAF}"/>
               </a:ext>
             </a:extLst>
           </p:cNvPr>
@@ -7481,7 +7481,7 @@
           <p:cNvPr id="4" name="">
             <a:extLst xmlns:a="http://schemas.openxmlformats.org/drawingml/2006/main">
               <a:ext uri="{FF2B5EF4-FFF2-40B4-BE49-F238E27FC236}">
-                <a16:creationId xmlns:a16="http://schemas.microsoft.com/office/drawing/2014/main" id="{0B241470-271D-4CEC-B1A6-9C72F1971C8C}"/>
+                <a16:creationId xmlns:a16="http://schemas.microsoft.com/office/drawing/2014/main" id="{0F8C71FC-8322-463A-B0C0-AE7C88516A53}"/>
               </a:ext>
             </a:extLst>
           </p:cNvPr>
@@ -7513,7 +7513,7 @@
           <p:cNvPr id="5" name="">
             <a:extLst xmlns:a="http://schemas.openxmlformats.org/drawingml/2006/main">
               <a:ext uri="{FF2B5EF4-FFF2-40B4-BE49-F238E27FC236}">
-                <a16:creationId xmlns:a16="http://schemas.microsoft.com/office/drawing/2014/main" id="{9196AD67-5103-43A5-B2DC-F4CF224FAEB1}"/>
+                <a16:creationId xmlns:a16="http://schemas.microsoft.com/office/drawing/2014/main" id="{D10012A1-353D-44B6-9211-53FDECCC1313}"/>
               </a:ext>
             </a:extLst>
           </p:cNvPr>
@@ -7570,7 +7570,7 @@
           <p:cNvPr id="6" name="">
             <a:extLst xmlns:a="http://schemas.openxmlformats.org/drawingml/2006/main">
               <a:ext uri="{FF2B5EF4-FFF2-40B4-BE49-F238E27FC236}">
-                <a16:creationId xmlns:a16="http://schemas.microsoft.com/office/drawing/2014/main" id="{D43C322C-6E70-4C85-B6D1-3C5147450FF2}"/>
+                <a16:creationId xmlns:a16="http://schemas.microsoft.com/office/drawing/2014/main" id="{49FAC4A8-88D8-4351-A9EF-7470431E1845}"/>
               </a:ext>
             </a:extLst>
           </p:cNvPr>
@@ -7627,7 +7627,7 @@
           <p:cNvPr id="7" name="">
             <a:extLst xmlns:a="http://schemas.openxmlformats.org/drawingml/2006/main">
               <a:ext uri="{FF2B5EF4-FFF2-40B4-BE49-F238E27FC236}">
-                <a16:creationId xmlns:a16="http://schemas.microsoft.com/office/drawing/2014/main" id="{5187FD69-F1D1-48BA-B1E8-AC72E6216F81}"/>
+                <a16:creationId xmlns:a16="http://schemas.microsoft.com/office/drawing/2014/main" id="{554FFC6E-CB42-480D-BF4F-C62D08D0F703}"/>
               </a:ext>
             </a:extLst>
           </p:cNvPr>
@@ -7659,7 +7659,7 @@
           <p:cNvPr id="8" name="">
             <a:extLst xmlns:a="http://schemas.openxmlformats.org/drawingml/2006/main">
               <a:ext uri="{FF2B5EF4-FFF2-40B4-BE49-F238E27FC236}">
-                <a16:creationId xmlns:a16="http://schemas.microsoft.com/office/drawing/2014/main" id="{5ED11F88-65DB-4306-AE72-2FB70E4DAD6B}"/>
+                <a16:creationId xmlns:a16="http://schemas.microsoft.com/office/drawing/2014/main" id="{48CD0E0E-7F96-4CB7-A61E-031B2418EFC3}"/>
               </a:ext>
             </a:extLst>
           </p:cNvPr>
@@ -7716,7 +7716,7 @@
           <p:cNvPr id="9" name="">
             <a:extLst xmlns:a="http://schemas.openxmlformats.org/drawingml/2006/main">
               <a:ext uri="{FF2B5EF4-FFF2-40B4-BE49-F238E27FC236}">
-                <a16:creationId xmlns:a16="http://schemas.microsoft.com/office/drawing/2014/main" id="{0EEF0787-FD6A-4DB7-80A3-11A1C48CADA8}"/>
+                <a16:creationId xmlns:a16="http://schemas.microsoft.com/office/drawing/2014/main" id="{3CACC48E-2D57-404E-B494-B16F4DE79FB9}"/>
               </a:ext>
             </a:extLst>
           </p:cNvPr>
@@ -7773,7 +7773,7 @@
           <p:cNvPr id="10" name="">
             <a:extLst xmlns:a="http://schemas.openxmlformats.org/drawingml/2006/main">
               <a:ext uri="{FF2B5EF4-FFF2-40B4-BE49-F238E27FC236}">
-                <a16:creationId xmlns:a16="http://schemas.microsoft.com/office/drawing/2014/main" id="{266FF19A-2546-4C98-9AD0-461ACB38F589}"/>
+                <a16:creationId xmlns:a16="http://schemas.microsoft.com/office/drawing/2014/main" id="{16D3EAAA-91E6-414F-9724-E54B7970FE9B}"/>
               </a:ext>
             </a:extLst>
           </p:cNvPr>
@@ -7805,7 +7805,7 @@
           <p:cNvPr id="11" name="">
             <a:extLst xmlns:a="http://schemas.openxmlformats.org/drawingml/2006/main">
               <a:ext uri="{FF2B5EF4-FFF2-40B4-BE49-F238E27FC236}">
-                <a16:creationId xmlns:a16="http://schemas.microsoft.com/office/drawing/2014/main" id="{7C8FFEFD-400C-4D5F-BF99-1C5F5A79A783}"/>
+                <a16:creationId xmlns:a16="http://schemas.microsoft.com/office/drawing/2014/main" id="{F3AA550D-19A0-4438-B0C6-22794BDC5C19}"/>
               </a:ext>
             </a:extLst>
           </p:cNvPr>
@@ -7862,7 +7862,7 @@
           <p:cNvPr id="12" name="">
             <a:extLst xmlns:a="http://schemas.openxmlformats.org/drawingml/2006/main">
               <a:ext uri="{FF2B5EF4-FFF2-40B4-BE49-F238E27FC236}">
-                <a16:creationId xmlns:a16="http://schemas.microsoft.com/office/drawing/2014/main" id="{9B65170D-9EB5-4A53-A204-5498F5BE39FD}"/>
+                <a16:creationId xmlns:a16="http://schemas.microsoft.com/office/drawing/2014/main" id="{66D84102-89A2-4E8A-B535-050E53C0FDD7}"/>
               </a:ext>
             </a:extLst>
           </p:cNvPr>
@@ -7919,7 +7919,7 @@
           <p:cNvPr id="13" name="">
             <a:extLst xmlns:a="http://schemas.openxmlformats.org/drawingml/2006/main">
               <a:ext uri="{FF2B5EF4-FFF2-40B4-BE49-F238E27FC236}">
-                <a16:creationId xmlns:a16="http://schemas.microsoft.com/office/drawing/2014/main" id="{FA8F6176-84BB-41A7-A3BD-F1BA4BC916D1}"/>
+                <a16:creationId xmlns:a16="http://schemas.microsoft.com/office/drawing/2014/main" id="{B8B5DE8B-5D3F-44F3-91EC-1FE0484593A0}"/>
               </a:ext>
             </a:extLst>
           </p:cNvPr>
@@ -7974,7 +7974,7 @@
     </p:spTree>
     <p:extLst>
       <p:ext uri="{BB962C8B-B14F-4D97-AF65-F5344CB8AC3E}">
-        <p14:creationId xmlns:p14="http://schemas.microsoft.com/office/powerpoint/2010/main" val="585623249"/>
+        <p14:creationId xmlns:p14="http://schemas.microsoft.com/office/powerpoint/2010/main" val="1105788755"/>
       </p:ext>
     </p:extLst>
   </p:cSld>
@@ -8005,7 +8005,7 @@
           <p:cNvPr id="21" name="">
             <a:extLst xmlns:a="http://schemas.openxmlformats.org/drawingml/2006/main">
               <a:ext uri="{FF2B5EF4-FFF2-40B4-BE49-F238E27FC236}">
-                <a16:creationId xmlns:a16="http://schemas.microsoft.com/office/drawing/2014/main" id="{BE8654D0-E2C7-43C0-8A5F-7B42F32FF54B}"/>
+                <a16:creationId xmlns:a16="http://schemas.microsoft.com/office/drawing/2014/main" id="{9D12BF60-5855-49D7-9835-3973B7122B1C}"/>
               </a:ext>
             </a:extLst>
           </p:cNvPr>
@@ -8062,7 +8062,7 @@
           <p:cNvPr id="2" name="">
             <a:extLst xmlns:a="http://schemas.openxmlformats.org/drawingml/2006/main">
               <a:ext uri="{FF2B5EF4-FFF2-40B4-BE49-F238E27FC236}">
-                <a16:creationId xmlns:a16="http://schemas.microsoft.com/office/drawing/2014/main" id="{FF1434E6-65BD-4ABE-891E-730A073DDE51}"/>
+                <a16:creationId xmlns:a16="http://schemas.microsoft.com/office/drawing/2014/main" id="{E3F7CB59-E537-4F0D-B30F-8C1AC11FD3BA}"/>
               </a:ext>
             </a:extLst>
           </p:cNvPr>
@@ -8119,7 +8119,7 @@
           <p:cNvPr id="3" name="">
             <a:extLst xmlns:a="http://schemas.openxmlformats.org/drawingml/2006/main">
               <a:ext uri="{FF2B5EF4-FFF2-40B4-BE49-F238E27FC236}">
-                <a16:creationId xmlns:a16="http://schemas.microsoft.com/office/drawing/2014/main" id="{26A8BC1F-2E0C-4D0F-AEDC-04C896F7E186}"/>
+                <a16:creationId xmlns:a16="http://schemas.microsoft.com/office/drawing/2014/main" id="{4F532CD1-0606-45A7-A228-5AE1423F0939}"/>
               </a:ext>
             </a:extLst>
           </p:cNvPr>
@@ -8176,7 +8176,7 @@
           <p:cNvPr id="4" name="">
             <a:extLst xmlns:a="http://schemas.openxmlformats.org/drawingml/2006/main">
               <a:ext uri="{FF2B5EF4-FFF2-40B4-BE49-F238E27FC236}">
-                <a16:creationId xmlns:a16="http://schemas.microsoft.com/office/drawing/2014/main" id="{4020DC42-6CD4-4A25-99D1-44655514975D}"/>
+                <a16:creationId xmlns:a16="http://schemas.microsoft.com/office/drawing/2014/main" id="{8849B3B5-DC1F-4EB8-81AD-3C9C665C10F1}"/>
               </a:ext>
             </a:extLst>
           </p:cNvPr>
@@ -8208,7 +8208,7 @@
           <p:cNvPr id="5" name="">
             <a:extLst xmlns:a="http://schemas.openxmlformats.org/drawingml/2006/main">
               <a:ext uri="{FF2B5EF4-FFF2-40B4-BE49-F238E27FC236}">
-                <a16:creationId xmlns:a16="http://schemas.microsoft.com/office/drawing/2014/main" id="{A6CFE9A2-79FD-4CEA-80D8-CF49C2EB4E21}"/>
+                <a16:creationId xmlns:a16="http://schemas.microsoft.com/office/drawing/2014/main" id="{8753A238-45AF-40AB-88D9-E8CADF8725FE}"/>
               </a:ext>
             </a:extLst>
           </p:cNvPr>
@@ -8265,7 +8265,7 @@
           <p:cNvPr id="6" name="">
             <a:extLst xmlns:a="http://schemas.openxmlformats.org/drawingml/2006/main">
               <a:ext uri="{FF2B5EF4-FFF2-40B4-BE49-F238E27FC236}">
-                <a16:creationId xmlns:a16="http://schemas.microsoft.com/office/drawing/2014/main" id="{9C5BBA26-0325-421B-B4AF-B7C011E32806}"/>
+                <a16:creationId xmlns:a16="http://schemas.microsoft.com/office/drawing/2014/main" id="{46BF8951-163D-46E7-B4FE-70AFEBC6C248}"/>
               </a:ext>
             </a:extLst>
           </p:cNvPr>
@@ -8297,7 +8297,7 @@
           <p:cNvPr id="7" name="">
             <a:extLst xmlns:a="http://schemas.openxmlformats.org/drawingml/2006/main">
               <a:ext uri="{FF2B5EF4-FFF2-40B4-BE49-F238E27FC236}">
-                <a16:creationId xmlns:a16="http://schemas.microsoft.com/office/drawing/2014/main" id="{0AD12893-7967-4ADD-84F2-5BD3C3F4CEFC}"/>
+                <a16:creationId xmlns:a16="http://schemas.microsoft.com/office/drawing/2014/main" id="{BFB91F75-C885-4D1B-9E50-BBC820B74F45}"/>
               </a:ext>
             </a:extLst>
           </p:cNvPr>
@@ -8354,7 +8354,7 @@
           <p:cNvPr id="8" name="">
             <a:extLst xmlns:a="http://schemas.openxmlformats.org/drawingml/2006/main">
               <a:ext uri="{FF2B5EF4-FFF2-40B4-BE49-F238E27FC236}">
-                <a16:creationId xmlns:a16="http://schemas.microsoft.com/office/drawing/2014/main" id="{08C813AA-1580-478E-93C6-994B072D4C56}"/>
+                <a16:creationId xmlns:a16="http://schemas.microsoft.com/office/drawing/2014/main" id="{EC406688-DBC3-4675-A18D-6B8F636B17EF}"/>
               </a:ext>
             </a:extLst>
           </p:cNvPr>
@@ -8386,7 +8386,7 @@
           <p:cNvPr id="9" name="">
             <a:extLst xmlns:a="http://schemas.openxmlformats.org/drawingml/2006/main">
               <a:ext uri="{FF2B5EF4-FFF2-40B4-BE49-F238E27FC236}">
-                <a16:creationId xmlns:a16="http://schemas.microsoft.com/office/drawing/2014/main" id="{E488A365-BC70-44FE-BFE4-83234896F4E5}"/>
+                <a16:creationId xmlns:a16="http://schemas.microsoft.com/office/drawing/2014/main" id="{C7291689-C857-4FB4-8465-B621FF3284E8}"/>
               </a:ext>
             </a:extLst>
           </p:cNvPr>
@@ -8443,7 +8443,7 @@
           <p:cNvPr id="10" name="">
             <a:extLst xmlns:a="http://schemas.openxmlformats.org/drawingml/2006/main">
               <a:ext uri="{FF2B5EF4-FFF2-40B4-BE49-F238E27FC236}">
-                <a16:creationId xmlns:a16="http://schemas.microsoft.com/office/drawing/2014/main" id="{3E01613E-5614-4462-976C-BB072A8315E2}"/>
+                <a16:creationId xmlns:a16="http://schemas.microsoft.com/office/drawing/2014/main" id="{D898A45E-C571-4571-8E29-0D90967F767F}"/>
               </a:ext>
             </a:extLst>
           </p:cNvPr>
@@ -8475,7 +8475,7 @@
           <p:cNvPr id="11" name="">
             <a:extLst xmlns:a="http://schemas.openxmlformats.org/drawingml/2006/main">
               <a:ext uri="{FF2B5EF4-FFF2-40B4-BE49-F238E27FC236}">
-                <a16:creationId xmlns:a16="http://schemas.microsoft.com/office/drawing/2014/main" id="{9C043861-3674-4B2A-AB65-A53F853C4B3D}"/>
+                <a16:creationId xmlns:a16="http://schemas.microsoft.com/office/drawing/2014/main" id="{6EF914D2-2F5F-4C71-98B4-1E6363881B77}"/>
               </a:ext>
             </a:extLst>
           </p:cNvPr>
@@ -8532,7 +8532,7 @@
           <p:cNvPr id="12" name="">
             <a:extLst xmlns:a="http://schemas.openxmlformats.org/drawingml/2006/main">
               <a:ext uri="{FF2B5EF4-FFF2-40B4-BE49-F238E27FC236}">
-                <a16:creationId xmlns:a16="http://schemas.microsoft.com/office/drawing/2014/main" id="{D0705803-BF09-4135-B435-9B04C11A9316}"/>
+                <a16:creationId xmlns:a16="http://schemas.microsoft.com/office/drawing/2014/main" id="{98A74CEC-538D-4344-A7E4-BA4ACA497834}"/>
               </a:ext>
             </a:extLst>
           </p:cNvPr>
@@ -8564,7 +8564,7 @@
           <p:cNvPr id="13" name="">
             <a:extLst xmlns:a="http://schemas.openxmlformats.org/drawingml/2006/main">
               <a:ext uri="{FF2B5EF4-FFF2-40B4-BE49-F238E27FC236}">
-                <a16:creationId xmlns:a16="http://schemas.microsoft.com/office/drawing/2014/main" id="{E37CCDA4-3656-4088-AA08-B6EE48E5E527}"/>
+                <a16:creationId xmlns:a16="http://schemas.microsoft.com/office/drawing/2014/main" id="{ABAF8A89-715A-42AB-8DC6-40D5F947D669}"/>
               </a:ext>
             </a:extLst>
           </p:cNvPr>
@@ -8621,7 +8621,7 @@
           <p:cNvPr id="14" name="">
             <a:extLst xmlns:a="http://schemas.openxmlformats.org/drawingml/2006/main">
               <a:ext uri="{FF2B5EF4-FFF2-40B4-BE49-F238E27FC236}">
-                <a16:creationId xmlns:a16="http://schemas.microsoft.com/office/drawing/2014/main" id="{897203B5-2AB8-4F48-A28F-7EE5743B9DB0}"/>
+                <a16:creationId xmlns:a16="http://schemas.microsoft.com/office/drawing/2014/main" id="{923837DF-06BA-448E-ADB5-AE059122292E}"/>
               </a:ext>
             </a:extLst>
           </p:cNvPr>
@@ -8653,7 +8653,7 @@
           <p:cNvPr id="15" name="">
             <a:extLst xmlns:a="http://schemas.openxmlformats.org/drawingml/2006/main">
               <a:ext uri="{FF2B5EF4-FFF2-40B4-BE49-F238E27FC236}">
-                <a16:creationId xmlns:a16="http://schemas.microsoft.com/office/drawing/2014/main" id="{3526D71E-3021-4714-99C3-549654E7CB2E}"/>
+                <a16:creationId xmlns:a16="http://schemas.microsoft.com/office/drawing/2014/main" id="{BA7500AF-FA10-46D0-9A6E-40B8DE6081FD}"/>
               </a:ext>
             </a:extLst>
           </p:cNvPr>
@@ -8710,7 +8710,7 @@
           <p:cNvPr id="16" name="">
             <a:extLst xmlns:a="http://schemas.openxmlformats.org/drawingml/2006/main">
               <a:ext uri="{FF2B5EF4-FFF2-40B4-BE49-F238E27FC236}">
-                <a16:creationId xmlns:a16="http://schemas.microsoft.com/office/drawing/2014/main" id="{B568C455-63C9-4D04-B959-6D874F905754}"/>
+                <a16:creationId xmlns:a16="http://schemas.microsoft.com/office/drawing/2014/main" id="{888C2F81-6C20-4CC0-AFD6-38C7E73C381D}"/>
               </a:ext>
             </a:extLst>
           </p:cNvPr>
@@ -8742,7 +8742,7 @@
           <p:cNvPr id="17" name="">
             <a:extLst xmlns:a="http://schemas.openxmlformats.org/drawingml/2006/main">
               <a:ext uri="{FF2B5EF4-FFF2-40B4-BE49-F238E27FC236}">
-                <a16:creationId xmlns:a16="http://schemas.microsoft.com/office/drawing/2014/main" id="{4FC10941-4DAB-45C3-B7B1-BE2EFB3A89ED}"/>
+                <a16:creationId xmlns:a16="http://schemas.microsoft.com/office/drawing/2014/main" id="{A29A3C95-4C6C-42DE-809E-FC9231CB158D}"/>
               </a:ext>
             </a:extLst>
           </p:cNvPr>
@@ -8799,7 +8799,7 @@
           <p:cNvPr id="18" name="">
             <a:extLst xmlns:a="http://schemas.openxmlformats.org/drawingml/2006/main">
               <a:ext uri="{FF2B5EF4-FFF2-40B4-BE49-F238E27FC236}">
-                <a16:creationId xmlns:a16="http://schemas.microsoft.com/office/drawing/2014/main" id="{8D35FEE4-557F-4FE3-9CDD-9CD784B880BB}"/>
+                <a16:creationId xmlns:a16="http://schemas.microsoft.com/office/drawing/2014/main" id="{271AE4D3-F355-4D75-9AB4-A8E291298481}"/>
               </a:ext>
             </a:extLst>
           </p:cNvPr>
@@ -8831,7 +8831,7 @@
           <p:cNvPr id="19" name="">
             <a:extLst xmlns:a="http://schemas.openxmlformats.org/drawingml/2006/main">
               <a:ext uri="{FF2B5EF4-FFF2-40B4-BE49-F238E27FC236}">
-                <a16:creationId xmlns:a16="http://schemas.microsoft.com/office/drawing/2014/main" id="{2795D85D-38A6-46CF-87E5-E1DBB3A6AE52}"/>
+                <a16:creationId xmlns:a16="http://schemas.microsoft.com/office/drawing/2014/main" id="{9191E604-339A-42E9-B957-310B7436C816}"/>
               </a:ext>
             </a:extLst>
           </p:cNvPr>
@@ -8888,7 +8888,7 @@
           <p:cNvPr id="20" name="">
             <a:extLst xmlns:a="http://schemas.openxmlformats.org/drawingml/2006/main">
               <a:ext uri="{FF2B5EF4-FFF2-40B4-BE49-F238E27FC236}">
-                <a16:creationId xmlns:a16="http://schemas.microsoft.com/office/drawing/2014/main" id="{87BF0282-9124-4CB5-8AA0-E2EA82705534}"/>
+                <a16:creationId xmlns:a16="http://schemas.microsoft.com/office/drawing/2014/main" id="{1D67BE05-4235-47AF-B4D2-BE42623F4F26}"/>
               </a:ext>
             </a:extLst>
           </p:cNvPr>
@@ -8943,7 +8943,7 @@
     </p:spTree>
     <p:extLst>
       <p:ext uri="{BB962C8B-B14F-4D97-AF65-F5344CB8AC3E}">
-        <p14:creationId xmlns:p14="http://schemas.microsoft.com/office/powerpoint/2010/main" val="1747848359"/>
+        <p14:creationId xmlns:p14="http://schemas.microsoft.com/office/powerpoint/2010/main" val="196426511"/>
       </p:ext>
     </p:extLst>
   </p:cSld>
@@ -8971,10 +8971,10 @@
       </p:grpSpPr>
       <p:sp>
         <p:nvSpPr>
-          <p:cNvPr id="13" name="">
-            <a:extLst xmlns:a="http://schemas.openxmlformats.org/drawingml/2006/main">
-              <a:ext uri="{FF2B5EF4-FFF2-40B4-BE49-F238E27FC236}">
-                <a16:creationId xmlns:a16="http://schemas.microsoft.com/office/drawing/2014/main" id="{826C3F9A-9EA4-467C-B4A3-2F5C3F11C926}"/>
+          <p:cNvPr id="11" name="">
+            <a:extLst xmlns:a="http://schemas.openxmlformats.org/drawingml/2006/main">
+              <a:ext uri="{FF2B5EF4-FFF2-40B4-BE49-F238E27FC236}">
+                <a16:creationId xmlns:a16="http://schemas.microsoft.com/office/drawing/2014/main" id="{196A7C51-DF81-463E-97D3-390247005C35}"/>
               </a:ext>
             </a:extLst>
           </p:cNvPr>
@@ -9021,7 +9021,7 @@
                 <a:ea typeface="Arial"/>
                 <a:cs typeface="Arial"/>
               </a:rPr>
-              <a:t>Explainable Output</a:t>
+              <a:t>Dashboard Output</a:t>
             </a:r>
           </a:p>
         </p:txBody>
@@ -9031,7 +9031,7 @@
           <p:cNvPr id="2" name="">
             <a:extLst xmlns:a="http://schemas.openxmlformats.org/drawingml/2006/main">
               <a:ext uri="{FF2B5EF4-FFF2-40B4-BE49-F238E27FC236}">
-                <a16:creationId xmlns:a16="http://schemas.microsoft.com/office/drawing/2014/main" id="{AF3E12CD-098B-4E7B-BCFA-3A405C4DC4F8}"/>
+                <a16:creationId xmlns:a16="http://schemas.microsoft.com/office/drawing/2014/main" id="{CFBAE8CF-61EF-46DD-9079-2C48EE5A1633}"/>
               </a:ext>
             </a:extLst>
           </p:cNvPr>
@@ -9078,7 +9078,7 @@
                 <a:ea typeface="Arial"/>
                 <a:cs typeface="Arial"/>
               </a:rPr>
-              <a:t>Each correction includes evidence and next action</a:t>
+              <a:t>Each correction has a user view and a technical trace</a:t>
             </a:r>
           </a:p>
         </p:txBody>
@@ -9088,7 +9088,7 @@
           <p:cNvPr id="3" name="">
             <a:extLst xmlns:a="http://schemas.openxmlformats.org/drawingml/2006/main">
               <a:ext uri="{FF2B5EF4-FFF2-40B4-BE49-F238E27FC236}">
-                <a16:creationId xmlns:a16="http://schemas.microsoft.com/office/drawing/2014/main" id="{D9C4AC12-DC95-4320-ABBF-CAA1DBF16D8A}"/>
+                <a16:creationId xmlns:a16="http://schemas.microsoft.com/office/drawing/2014/main" id="{96BE1CC2-817D-43AC-964E-51AC055F1FE8}"/>
               </a:ext>
             </a:extLst>
           </p:cNvPr>
@@ -9145,7 +9145,7 @@
           <p:cNvPr id="4" name="">
             <a:extLst xmlns:a="http://schemas.openxmlformats.org/drawingml/2006/main">
               <a:ext uri="{FF2B5EF4-FFF2-40B4-BE49-F238E27FC236}">
-                <a16:creationId xmlns:a16="http://schemas.microsoft.com/office/drawing/2014/main" id="{66D49BC1-B960-42CF-9599-D672EC0A44BC}"/>
+                <a16:creationId xmlns:a16="http://schemas.microsoft.com/office/drawing/2014/main" id="{8FA4A3DB-0E6F-4FD1-8AD0-4FB1A8C09750}"/>
               </a:ext>
             </a:extLst>
           </p:cNvPr>
@@ -9177,7 +9177,7 @@
           <p:cNvPr id="5" name="">
             <a:extLst xmlns:a="http://schemas.openxmlformats.org/drawingml/2006/main">
               <a:ext uri="{FF2B5EF4-FFF2-40B4-BE49-F238E27FC236}">
-                <a16:creationId xmlns:a16="http://schemas.microsoft.com/office/drawing/2014/main" id="{94F71369-FCB9-4045-9B7D-C8FD0E273780}"/>
+                <a16:creationId xmlns:a16="http://schemas.microsoft.com/office/drawing/2014/main" id="{ABD39E2F-01CD-49F2-A0EA-826652FFD600}"/>
               </a:ext>
             </a:extLst>
           </p:cNvPr>
@@ -9189,7 +9189,7 @@
         <p:spPr>
           <a:xfrm xmlns:a="http://schemas.openxmlformats.org/drawingml/2006/main">
             <a:off x="1428750" y="2038350"/>
-            <a:ext cx="1714500" cy="266700"/>
+            <a:ext cx="2095500" cy="266700"/>
           </a:xfrm>
           <a:prstGeom xmlns:a="http://schemas.openxmlformats.org/drawingml/2006/main" prst="rect">
             <a:avLst/>
@@ -9208,7 +9208,7 @@
             <a:pPr>
               <a:defRPr sz="1800" b="1">
                 <a:solidFill>
-                  <a:srgbClr val="B91C1C"/>
+                  <a:srgbClr val="15803D"/>
                 </a:solidFill>
                 <a:latin typeface="Arial"/>
                 <a:ea typeface="Arial"/>
@@ -9218,13 +9218,13 @@
             <a:r>
               <a:rPr sz="1800" b="1">
                 <a:solidFill>
-                  <a:srgbClr val="B91C1C"/>
-                </a:solidFill>
-                <a:latin typeface="Arial"/>
-                <a:ea typeface="Arial"/>
-                <a:cs typeface="Arial"/>
-              </a:rPr>
-              <a:t>Problem</a:t>
+                  <a:srgbClr val="15803D"/>
+                </a:solidFill>
+                <a:latin typeface="Arial"/>
+                <a:ea typeface="Arial"/>
+                <a:cs typeface="Arial"/>
+              </a:rPr>
+              <a:t>User side</a:t>
             </a:r>
           </a:p>
         </p:txBody>
@@ -9234,7 +9234,7 @@
           <p:cNvPr id="6" name="">
             <a:extLst xmlns:a="http://schemas.openxmlformats.org/drawingml/2006/main">
               <a:ext uri="{FF2B5EF4-FFF2-40B4-BE49-F238E27FC236}">
-                <a16:creationId xmlns:a16="http://schemas.microsoft.com/office/drawing/2014/main" id="{5E10CA85-564A-4331-80EA-297F6CBEA2F6}"/>
+                <a16:creationId xmlns:a16="http://schemas.microsoft.com/office/drawing/2014/main" id="{D8CBA6E3-9CC3-44B9-8265-2E6D807C2C79}"/>
               </a:ext>
             </a:extLst>
           </p:cNvPr>
@@ -9246,19 +9246,19 @@
         <p:spPr>
           <a:xfrm xmlns:a="http://schemas.openxmlformats.org/drawingml/2006/main">
             <a:off x="1428750" y="2457450"/>
-            <a:ext cx="2476500" cy="323850"/>
-          </a:xfrm>
-          <a:prstGeom xmlns:a="http://schemas.openxmlformats.org/drawingml/2006/main" prst="rect">
-            <a:avLst/>
-          </a:prstGeom>
-          <a:noFill xmlns:a="http://schemas.openxmlformats.org/drawingml/2006/main"/>
-          <a:ln xmlns:a="http://schemas.openxmlformats.org/drawingml/2006/main" w="0">
-            <a:noFill/>
-          </a:ln>
-        </p:spPr>
-        <p:txBody>
-          <a:bodyPr xmlns:a="http://schemas.openxmlformats.org/drawingml/2006/main">
-            <a:normAutofit fontScale="84722"/>
+            <a:ext cx="3143250" cy="1143000"/>
+          </a:xfrm>
+          <a:prstGeom xmlns:a="http://schemas.openxmlformats.org/drawingml/2006/main" prst="rect">
+            <a:avLst/>
+          </a:prstGeom>
+          <a:noFill xmlns:a="http://schemas.openxmlformats.org/drawingml/2006/main"/>
+          <a:ln xmlns:a="http://schemas.openxmlformats.org/drawingml/2006/main" w="0">
+            <a:noFill/>
+          </a:ln>
+        </p:spPr>
+        <p:txBody>
+          <a:bodyPr xmlns:a="http://schemas.openxmlformats.org/drawingml/2006/main">
+            <a:normAutofit fontScale="100000"/>
           </a:bodyPr>
           <a:lstStyle xmlns:a="http://schemas.openxmlformats.org/drawingml/2006/main"/>
           <a:p xmlns:a="http://schemas.openxmlformats.org/drawingml/2006/main">
@@ -9281,7 +9281,7 @@
                 <a:ea typeface="Arial"/>
                 <a:cs typeface="Arial"/>
               </a:rPr>
-              <a:t>Knee tracking issue</a:t>
+              <a:t>Plain trainer-style summary, main issue, rest reps, and corrections</a:t>
             </a:r>
           </a:p>
         </p:txBody>
@@ -9291,19 +9291,19 @@
           <p:cNvPr id="7" name="">
             <a:extLst xmlns:a="http://schemas.openxmlformats.org/drawingml/2006/main">
               <a:ext uri="{FF2B5EF4-FFF2-40B4-BE49-F238E27FC236}">
-                <a16:creationId xmlns:a16="http://schemas.microsoft.com/office/drawing/2014/main" id="{A4E71193-CA8C-4245-9AD6-B60F23F459CB}"/>
-              </a:ext>
-            </a:extLst>
-          </p:cNvPr>
-          <p:cNvSpPr>
-            <a:spLocks xmlns:a="http://schemas.openxmlformats.org/drawingml/2006/main" noGrp="1"/>
-          </p:cNvSpPr>
-          <p:nvPr/>
-        </p:nvSpPr>
-        <p:spPr>
-          <a:xfrm xmlns:a="http://schemas.openxmlformats.org/drawingml/2006/main">
-            <a:off x="4572000" y="2038350"/>
-            <a:ext cx="1714500" cy="266700"/>
+                <a16:creationId xmlns:a16="http://schemas.microsoft.com/office/drawing/2014/main" id="{66B8AA0A-E3D5-45D2-B890-D8D0A156E4B1}"/>
+              </a:ext>
+            </a:extLst>
+          </p:cNvPr>
+          <p:cNvSpPr>
+            <a:spLocks xmlns:a="http://schemas.openxmlformats.org/drawingml/2006/main" noGrp="1"/>
+          </p:cNvSpPr>
+          <p:nvPr/>
+        </p:nvSpPr>
+        <p:spPr>
+          <a:xfrm xmlns:a="http://schemas.openxmlformats.org/drawingml/2006/main">
+            <a:off x="5619750" y="2038350"/>
+            <a:ext cx="2286000" cy="266700"/>
           </a:xfrm>
           <a:prstGeom xmlns:a="http://schemas.openxmlformats.org/drawingml/2006/main" prst="rect">
             <a:avLst/>
@@ -9322,7 +9322,7 @@
             <a:pPr>
               <a:defRPr sz="1800" b="1">
                 <a:solidFill>
-                  <a:srgbClr val="B45309"/>
+                  <a:srgbClr val="2563EB"/>
                 </a:solidFill>
                 <a:latin typeface="Arial"/>
                 <a:ea typeface="Arial"/>
@@ -9332,13 +9332,13 @@
             <a:r>
               <a:rPr sz="1800" b="1">
                 <a:solidFill>
-                  <a:srgbClr val="B45309"/>
-                </a:solidFill>
-                <a:latin typeface="Arial"/>
-                <a:ea typeface="Arial"/>
-                <a:cs typeface="Arial"/>
-              </a:rPr>
-              <a:t>Reason</a:t>
+                  <a:srgbClr val="2563EB"/>
+                </a:solidFill>
+                <a:latin typeface="Arial"/>
+                <a:ea typeface="Arial"/>
+                <a:cs typeface="Arial"/>
+              </a:rPr>
+              <a:t>Technical side</a:t>
             </a:r>
           </a:p>
         </p:txBody>
@@ -9348,19 +9348,19 @@
           <p:cNvPr id="8" name="">
             <a:extLst xmlns:a="http://schemas.openxmlformats.org/drawingml/2006/main">
               <a:ext uri="{FF2B5EF4-FFF2-40B4-BE49-F238E27FC236}">
-                <a16:creationId xmlns:a16="http://schemas.microsoft.com/office/drawing/2014/main" id="{C9AEE7D2-8770-4D49-9811-D32503D63B70}"/>
-              </a:ext>
-            </a:extLst>
-          </p:cNvPr>
-          <p:cNvSpPr>
-            <a:spLocks xmlns:a="http://schemas.openxmlformats.org/drawingml/2006/main" noGrp="1"/>
-          </p:cNvSpPr>
-          <p:nvPr/>
-        </p:nvSpPr>
-        <p:spPr>
-          <a:xfrm xmlns:a="http://schemas.openxmlformats.org/drawingml/2006/main">
-            <a:off x="4572000" y="2457450"/>
-            <a:ext cx="2667000" cy="723900"/>
+                <a16:creationId xmlns:a16="http://schemas.microsoft.com/office/drawing/2014/main" id="{9AFC4B1C-F8BF-4370-BDB2-3C17719B168A}"/>
+              </a:ext>
+            </a:extLst>
+          </p:cNvPr>
+          <p:cNvSpPr>
+            <a:spLocks xmlns:a="http://schemas.openxmlformats.org/drawingml/2006/main" noGrp="1"/>
+          </p:cNvSpPr>
+          <p:nvPr/>
+        </p:nvSpPr>
+        <p:spPr>
+          <a:xfrm xmlns:a="http://schemas.openxmlformats.org/drawingml/2006/main">
+            <a:off x="5619750" y="2457450"/>
+            <a:ext cx="4000500" cy="1428750"/>
           </a:xfrm>
           <a:prstGeom xmlns:a="http://schemas.openxmlformats.org/drawingml/2006/main" prst="rect">
             <a:avLst/>
@@ -9395,7 +9395,7 @@
                 <a:ea typeface="Arial"/>
                 <a:cs typeface="Arial"/>
               </a:rPr>
-              <a:t>Knee tracking proxy raised injury risk</a:t>
+              <a:t>Feature values, triggered thresholds, raw model action, safety decision, reward, and evidence frame</a:t>
             </a:r>
           </a:p>
         </p:txBody>
@@ -9405,121 +9405,7 @@
           <p:cNvPr id="9" name="">
             <a:extLst xmlns:a="http://schemas.openxmlformats.org/drawingml/2006/main">
               <a:ext uri="{FF2B5EF4-FFF2-40B4-BE49-F238E27FC236}">
-                <a16:creationId xmlns:a16="http://schemas.microsoft.com/office/drawing/2014/main" id="{C0508D41-3EB2-49B9-B53F-D86B1C19E74D}"/>
-              </a:ext>
-            </a:extLst>
-          </p:cNvPr>
-          <p:cNvSpPr>
-            <a:spLocks xmlns:a="http://schemas.openxmlformats.org/drawingml/2006/main" noGrp="1"/>
-          </p:cNvSpPr>
-          <p:nvPr/>
-        </p:nvSpPr>
-        <p:spPr>
-          <a:xfrm xmlns:a="http://schemas.openxmlformats.org/drawingml/2006/main">
-            <a:off x="7715250" y="2038350"/>
-            <a:ext cx="1714500" cy="266700"/>
-          </a:xfrm>
-          <a:prstGeom xmlns:a="http://schemas.openxmlformats.org/drawingml/2006/main" prst="rect">
-            <a:avLst/>
-          </a:prstGeom>
-          <a:noFill xmlns:a="http://schemas.openxmlformats.org/drawingml/2006/main"/>
-          <a:ln xmlns:a="http://schemas.openxmlformats.org/drawingml/2006/main" w="0">
-            <a:noFill/>
-          </a:ln>
-        </p:spPr>
-        <p:txBody>
-          <a:bodyPr xmlns:a="http://schemas.openxmlformats.org/drawingml/2006/main">
-            <a:normAutofit fontScale="63889"/>
-          </a:bodyPr>
-          <a:lstStyle xmlns:a="http://schemas.openxmlformats.org/drawingml/2006/main"/>
-          <a:p xmlns:a="http://schemas.openxmlformats.org/drawingml/2006/main">
-            <a:pPr>
-              <a:defRPr sz="1800" b="1">
-                <a:solidFill>
-                  <a:srgbClr val="15803D"/>
-                </a:solidFill>
-                <a:latin typeface="Arial"/>
-                <a:ea typeface="Arial"/>
-                <a:cs typeface="Arial"/>
-              </a:defRPr>
-            </a:pPr>
-            <a:r>
-              <a:rPr sz="1800" b="1">
-                <a:solidFill>
-                  <a:srgbClr val="15803D"/>
-                </a:solidFill>
-                <a:latin typeface="Arial"/>
-                <a:ea typeface="Arial"/>
-                <a:cs typeface="Arial"/>
-              </a:rPr>
-              <a:t>Correction</a:t>
-            </a:r>
-          </a:p>
-        </p:txBody>
-      </p:sp>
-      <p:sp>
-        <p:nvSpPr>
-          <p:cNvPr id="10" name="">
-            <a:extLst xmlns:a="http://schemas.openxmlformats.org/drawingml/2006/main">
-              <a:ext uri="{FF2B5EF4-FFF2-40B4-BE49-F238E27FC236}">
-                <a16:creationId xmlns:a16="http://schemas.microsoft.com/office/drawing/2014/main" id="{300F99F3-8AA8-4B41-BD81-03DB32859E92}"/>
-              </a:ext>
-            </a:extLst>
-          </p:cNvPr>
-          <p:cNvSpPr>
-            <a:spLocks xmlns:a="http://schemas.openxmlformats.org/drawingml/2006/main" noGrp="1"/>
-          </p:cNvSpPr>
-          <p:nvPr/>
-        </p:nvSpPr>
-        <p:spPr>
-          <a:xfrm xmlns:a="http://schemas.openxmlformats.org/drawingml/2006/main">
-            <a:off x="7715250" y="2457450"/>
-            <a:ext cx="2667000" cy="685800"/>
-          </a:xfrm>
-          <a:prstGeom xmlns:a="http://schemas.openxmlformats.org/drawingml/2006/main" prst="rect">
-            <a:avLst/>
-          </a:prstGeom>
-          <a:noFill xmlns:a="http://schemas.openxmlformats.org/drawingml/2006/main"/>
-          <a:ln xmlns:a="http://schemas.openxmlformats.org/drawingml/2006/main" w="0">
-            <a:noFill/>
-          </a:ln>
-        </p:spPr>
-        <p:txBody>
-          <a:bodyPr xmlns:a="http://schemas.openxmlformats.org/drawingml/2006/main">
-            <a:normAutofit fontScale="100000"/>
-          </a:bodyPr>
-          <a:lstStyle xmlns:a="http://schemas.openxmlformats.org/drawingml/2006/main"/>
-          <a:p xmlns:a="http://schemas.openxmlformats.org/drawingml/2006/main">
-            <a:pPr>
-              <a:defRPr sz="1800" b="0">
-                <a:solidFill>
-                  <a:srgbClr val="172033"/>
-                </a:solidFill>
-                <a:latin typeface="Arial"/>
-                <a:ea typeface="Arial"/>
-                <a:cs typeface="Arial"/>
-              </a:defRPr>
-            </a:pPr>
-            <a:r>
-              <a:rPr sz="1800" b="0">
-                <a:solidFill>
-                  <a:srgbClr val="172033"/>
-                </a:solidFill>
-                <a:latin typeface="Arial"/>
-                <a:ea typeface="Arial"/>
-                <a:cs typeface="Arial"/>
-              </a:rPr>
-              <a:t>Keep knees aligned with toes</a:t>
-            </a:r>
-          </a:p>
-        </p:txBody>
-      </p:sp>
-      <p:sp>
-        <p:nvSpPr>
-          <p:cNvPr id="11" name="">
-            <a:extLst xmlns:a="http://schemas.openxmlformats.org/drawingml/2006/main">
-              <a:ext uri="{FF2B5EF4-FFF2-40B4-BE49-F238E27FC236}">
-                <a16:creationId xmlns:a16="http://schemas.microsoft.com/office/drawing/2014/main" id="{EA6D7109-4B44-4BC0-9172-BB6A47884811}"/>
+                <a16:creationId xmlns:a16="http://schemas.microsoft.com/office/drawing/2014/main" id="{CB792C95-9B3D-413B-AD39-B9484D69104D}"/>
               </a:ext>
             </a:extLst>
           </p:cNvPr>
@@ -9566,17 +9452,17 @@
                 <a:ea typeface="Arial"/>
                 <a:cs typeface="Arial"/>
               </a:rPr>
-              <a:t>Evidence frame and highlighted joint are shown in the Streamlit demo.</a:t>
-            </a:r>
-          </a:p>
-        </p:txBody>
-      </p:sp>
-      <p:sp>
-        <p:nvSpPr>
-          <p:cNvPr id="12" name="">
-            <a:extLst xmlns:a="http://schemas.openxmlformats.org/drawingml/2006/main">
-              <a:ext uri="{FF2B5EF4-FFF2-40B4-BE49-F238E27FC236}">
-                <a16:creationId xmlns:a16="http://schemas.microsoft.com/office/drawing/2014/main" id="{D9F6585E-A253-4B13-A466-36C76DFA0EEE}"/>
+              <a:t>The Show results button stays disabled until video analysis completes.</a:t>
+            </a:r>
+          </a:p>
+        </p:txBody>
+      </p:sp>
+      <p:sp>
+        <p:nvSpPr>
+          <p:cNvPr id="10" name="">
+            <a:extLst xmlns:a="http://schemas.openxmlformats.org/drawingml/2006/main">
+              <a:ext uri="{FF2B5EF4-FFF2-40B4-BE49-F238E27FC236}">
+                <a16:creationId xmlns:a16="http://schemas.microsoft.com/office/drawing/2014/main" id="{C7EB0AF0-EAB9-494C-91E5-71E71A6F543E}"/>
               </a:ext>
             </a:extLst>
           </p:cNvPr>
@@ -9631,7 +9517,7 @@
     </p:spTree>
     <p:extLst>
       <p:ext uri="{BB962C8B-B14F-4D97-AF65-F5344CB8AC3E}">
-        <p14:creationId xmlns:p14="http://schemas.microsoft.com/office/powerpoint/2010/main" val="1181314840"/>
+        <p14:creationId xmlns:p14="http://schemas.microsoft.com/office/powerpoint/2010/main" val="793870793"/>
       </p:ext>
     </p:extLst>
   </p:cSld>
@@ -9662,7 +9548,7 @@
           <p:cNvPr id="8" name="">
             <a:extLst xmlns:a="http://schemas.openxmlformats.org/drawingml/2006/main">
               <a:ext uri="{FF2B5EF4-FFF2-40B4-BE49-F238E27FC236}">
-                <a16:creationId xmlns:a16="http://schemas.microsoft.com/office/drawing/2014/main" id="{564F9CD5-EEFA-435B-BE90-32AF7C37D303}"/>
+                <a16:creationId xmlns:a16="http://schemas.microsoft.com/office/drawing/2014/main" id="{AC911D77-1851-46D2-84F6-E14641D72A9C}"/>
               </a:ext>
             </a:extLst>
           </p:cNvPr>
@@ -9719,7 +9605,7 @@
           <p:cNvPr id="2" name="">
             <a:extLst xmlns:a="http://schemas.openxmlformats.org/drawingml/2006/main">
               <a:ext uri="{FF2B5EF4-FFF2-40B4-BE49-F238E27FC236}">
-                <a16:creationId xmlns:a16="http://schemas.microsoft.com/office/drawing/2014/main" id="{A2743575-0307-4D2D-B669-85BAD1409D40}"/>
+                <a16:creationId xmlns:a16="http://schemas.microsoft.com/office/drawing/2014/main" id="{FA30EBD5-61A8-4B62-BE05-F248767AA78F}"/>
               </a:ext>
             </a:extLst>
           </p:cNvPr>
@@ -9776,7 +9662,7 @@
           <p:cNvPr id="3" name="">
             <a:extLst xmlns:a="http://schemas.openxmlformats.org/drawingml/2006/main">
               <a:ext uri="{FF2B5EF4-FFF2-40B4-BE49-F238E27FC236}">
-                <a16:creationId xmlns:a16="http://schemas.microsoft.com/office/drawing/2014/main" id="{24537C0A-242A-4346-8851-E85BB435EA88}"/>
+                <a16:creationId xmlns:a16="http://schemas.microsoft.com/office/drawing/2014/main" id="{073196D2-3A58-460C-B6D1-F14498FF8EFE}"/>
               </a:ext>
             </a:extLst>
           </p:cNvPr>
@@ -9840,7 +9726,7 @@
         </p:xfrm>
         <a:graphic xmlns:a="http://schemas.openxmlformats.org/drawingml/2006/main">
           <a:graphicData uri="http://schemas.openxmlformats.org/drawingml/2006/chart">
-            <c:chart xmlns:r="http://schemas.openxmlformats.org/officeDocument/2006/relationships" xmlns:c="http://schemas.openxmlformats.org/drawingml/2006/chart" r:id="R615fb44d82a84144"/>
+            <c:chart xmlns:r="http://schemas.openxmlformats.org/officeDocument/2006/relationships" xmlns:c="http://schemas.openxmlformats.org/drawingml/2006/chart" r:id="R392562a20c3548df"/>
           </a:graphicData>
         </a:graphic>
       </p:graphicFrame>
@@ -9849,7 +9735,7 @@
           <p:cNvPr id="5" name="">
             <a:extLst xmlns:a="http://schemas.openxmlformats.org/drawingml/2006/main">
               <a:ext uri="{FF2B5EF4-FFF2-40B4-BE49-F238E27FC236}">
-                <a16:creationId xmlns:a16="http://schemas.microsoft.com/office/drawing/2014/main" id="{C6B3E7FF-D476-4FDD-9192-7B25030FA25F}"/>
+                <a16:creationId xmlns:a16="http://schemas.microsoft.com/office/drawing/2014/main" id="{04AB8BDB-560F-49D0-935C-3F2C32DA3DEF}"/>
               </a:ext>
             </a:extLst>
           </p:cNvPr>
@@ -9906,7 +9792,7 @@
           <p:cNvPr id="6" name="">
             <a:extLst xmlns:a="http://schemas.openxmlformats.org/drawingml/2006/main">
               <a:ext uri="{FF2B5EF4-FFF2-40B4-BE49-F238E27FC236}">
-                <a16:creationId xmlns:a16="http://schemas.microsoft.com/office/drawing/2014/main" id="{3E8630D7-1212-43E0-9100-EBFAA3129548}"/>
+                <a16:creationId xmlns:a16="http://schemas.microsoft.com/office/drawing/2014/main" id="{85EDDF42-C7B3-4BED-8BA1-7770C2DCC5BC}"/>
               </a:ext>
             </a:extLst>
           </p:cNvPr>
@@ -9963,7 +9849,7 @@
           <p:cNvPr id="7" name="">
             <a:extLst xmlns:a="http://schemas.openxmlformats.org/drawingml/2006/main">
               <a:ext uri="{FF2B5EF4-FFF2-40B4-BE49-F238E27FC236}">
-                <a16:creationId xmlns:a16="http://schemas.microsoft.com/office/drawing/2014/main" id="{60DAF013-B541-4195-9409-8A4E8A358421}"/>
+                <a16:creationId xmlns:a16="http://schemas.microsoft.com/office/drawing/2014/main" id="{C70E24A5-D94A-4487-89CC-34AC03252737}"/>
               </a:ext>
             </a:extLst>
           </p:cNvPr>
@@ -10018,7 +9904,7 @@
     </p:spTree>
     <p:extLst>
       <p:ext uri="{BB962C8B-B14F-4D97-AF65-F5344CB8AC3E}">
-        <p14:creationId xmlns:p14="http://schemas.microsoft.com/office/powerpoint/2010/main" val="2136769953"/>
+        <p14:creationId xmlns:p14="http://schemas.microsoft.com/office/powerpoint/2010/main" val="5192521"/>
       </p:ext>
     </p:extLst>
   </p:cSld>

</xml_diff>

<commit_message>
Fix browser playback for pose overlay video
</commit_message>
<xml_diff>
--- a/slides/final_adaptive_rl_gym_coach_v3.pptx
+++ b/slides/final_adaptive_rl_gym_coach_v3.pptx
@@ -2,24 +2,24 @@
 <file path=ppt/presentation.xml><?xml version="1.0" encoding="utf-8"?>
 <p:presentation xmlns:p="http://schemas.openxmlformats.org/presentationml/2006/main">
   <p:sldMasterIdLst>
-    <p:sldMasterId xmlns:r="http://schemas.openxmlformats.org/officeDocument/2006/relationships" id="2147483648" r:id="Re2ee0d4ebe734ec8"/>
+    <p:sldMasterId xmlns:r="http://schemas.openxmlformats.org/officeDocument/2006/relationships" id="2147483648" r:id="Re047d135042f4d39"/>
   </p:sldMasterIdLst>
   <p:notesMasterIdLst>
-    <p:notesMasterId xmlns:r="http://schemas.openxmlformats.org/officeDocument/2006/relationships" r:id="R182d40fdb91c4e8d"/>
+    <p:notesMasterId xmlns:r="http://schemas.openxmlformats.org/officeDocument/2006/relationships" r:id="Rc6d29d8aa5ca4d52"/>
   </p:notesMasterIdLst>
   <p:sldIdLst>
-    <p:sldId xmlns:r="http://schemas.openxmlformats.org/officeDocument/2006/relationships" id="256" r:id="Rebadb4cdd48f45f9"/>
-    <p:sldId xmlns:r="http://schemas.openxmlformats.org/officeDocument/2006/relationships" id="257" r:id="R2e31a65f996a4009"/>
-    <p:sldId xmlns:r="http://schemas.openxmlformats.org/officeDocument/2006/relationships" id="258" r:id="Rf52483facb1f4aad"/>
-    <p:sldId xmlns:r="http://schemas.openxmlformats.org/officeDocument/2006/relationships" id="259" r:id="Rdeb5f05ad79340f3"/>
-    <p:sldId xmlns:r="http://schemas.openxmlformats.org/officeDocument/2006/relationships" id="260" r:id="R0a808f98310146c2"/>
-    <p:sldId xmlns:r="http://schemas.openxmlformats.org/officeDocument/2006/relationships" id="261" r:id="R83c3eb41d0294dc0"/>
-    <p:sldId xmlns:r="http://schemas.openxmlformats.org/officeDocument/2006/relationships" id="262" r:id="R9f89a386dac44174"/>
-    <p:sldId xmlns:r="http://schemas.openxmlformats.org/officeDocument/2006/relationships" id="263" r:id="Rf20a8510613b49ff"/>
-    <p:sldId xmlns:r="http://schemas.openxmlformats.org/officeDocument/2006/relationships" id="264" r:id="R4ae6b4a6ef2240b5"/>
-    <p:sldId xmlns:r="http://schemas.openxmlformats.org/officeDocument/2006/relationships" id="265" r:id="R709553ddfeea47d1"/>
-    <p:sldId xmlns:r="http://schemas.openxmlformats.org/officeDocument/2006/relationships" id="266" r:id="Rc509f03b7acb487a"/>
-    <p:sldId xmlns:r="http://schemas.openxmlformats.org/officeDocument/2006/relationships" id="267" r:id="R757c35f48a364b6a"/>
+    <p:sldId xmlns:r="http://schemas.openxmlformats.org/officeDocument/2006/relationships" id="256" r:id="R85925c5ddfd64a22"/>
+    <p:sldId xmlns:r="http://schemas.openxmlformats.org/officeDocument/2006/relationships" id="257" r:id="Rb9be68b3db9946ac"/>
+    <p:sldId xmlns:r="http://schemas.openxmlformats.org/officeDocument/2006/relationships" id="258" r:id="Re6ea10cb7a00485d"/>
+    <p:sldId xmlns:r="http://schemas.openxmlformats.org/officeDocument/2006/relationships" id="259" r:id="R90a4034c478f4b0f"/>
+    <p:sldId xmlns:r="http://schemas.openxmlformats.org/officeDocument/2006/relationships" id="260" r:id="R25a140a9c16c4f3c"/>
+    <p:sldId xmlns:r="http://schemas.openxmlformats.org/officeDocument/2006/relationships" id="261" r:id="R73da5f9c904e4279"/>
+    <p:sldId xmlns:r="http://schemas.openxmlformats.org/officeDocument/2006/relationships" id="262" r:id="Ra3d0d5e713234f6e"/>
+    <p:sldId xmlns:r="http://schemas.openxmlformats.org/officeDocument/2006/relationships" id="263" r:id="Rd2dfa8e9bf38477a"/>
+    <p:sldId xmlns:r="http://schemas.openxmlformats.org/officeDocument/2006/relationships" id="264" r:id="R70507a0881494bf6"/>
+    <p:sldId xmlns:r="http://schemas.openxmlformats.org/officeDocument/2006/relationships" id="265" r:id="Re8508c902b504af0"/>
+    <p:sldId xmlns:r="http://schemas.openxmlformats.org/officeDocument/2006/relationships" id="266" r:id="R65aa353b88194e06"/>
+    <p:sldId xmlns:r="http://schemas.openxmlformats.org/officeDocument/2006/relationships" id="267" r:id="R7a40549556c74e39"/>
   </p:sldIdLst>
   <p:sldSz cx="12192000" cy="6858000"/>
   <p:notesSz cx="6858000" cy="9144000"/>
@@ -1243,7 +1243,7 @@
   </p:cSld>
   <p:clrMap bg1="lt1" tx1="dk1" bg2="lt2" tx2="dk2" accent1="accent1" accent2="accent2" accent3="accent3" accent4="accent4" accent5="accent5" accent6="accent6" hlink="hlink" folHlink="folHlink"/>
   <p:sldLayoutIdLst>
-    <p:sldLayoutId xmlns:r="http://schemas.openxmlformats.org/officeDocument/2006/relationships" id="2147483649" r:id="Rddcd5a116bf34fa6"/>
+    <p:sldLayoutId xmlns:r="http://schemas.openxmlformats.org/officeDocument/2006/relationships" id="2147483649" r:id="Ra5c13b41596a4188"/>
   </p:sldLayoutIdLst>
   <p:txStyles>
     <p:titleStyle>
@@ -1975,7 +1975,7 @@
           <p:cNvPr id="7" name="">
             <a:extLst xmlns:a="http://schemas.openxmlformats.org/drawingml/2006/main">
               <a:ext uri="{FF2B5EF4-FFF2-40B4-BE49-F238E27FC236}">
-                <a16:creationId xmlns:a16="http://schemas.microsoft.com/office/drawing/2014/main" id="{5260B729-D866-4059-9685-262126F4496E}"/>
+                <a16:creationId xmlns:a16="http://schemas.microsoft.com/office/drawing/2014/main" id="{9FE3F218-E8C2-4927-836A-AC7C515AD38C}"/>
               </a:ext>
             </a:extLst>
           </p:cNvPr>
@@ -2032,7 +2032,7 @@
           <p:cNvPr id="2" name="">
             <a:extLst xmlns:a="http://schemas.openxmlformats.org/drawingml/2006/main">
               <a:ext uri="{FF2B5EF4-FFF2-40B4-BE49-F238E27FC236}">
-                <a16:creationId xmlns:a16="http://schemas.microsoft.com/office/drawing/2014/main" id="{C5B657E3-D615-4CFF-817F-27E99EC28F5C}"/>
+                <a16:creationId xmlns:a16="http://schemas.microsoft.com/office/drawing/2014/main" id="{C40940FF-5C5C-405D-9C5C-B7F7CE33BDCB}"/>
               </a:ext>
             </a:extLst>
           </p:cNvPr>
@@ -2089,7 +2089,7 @@
           <p:cNvPr id="3" name="">
             <a:extLst xmlns:a="http://schemas.openxmlformats.org/drawingml/2006/main">
               <a:ext uri="{FF2B5EF4-FFF2-40B4-BE49-F238E27FC236}">
-                <a16:creationId xmlns:a16="http://schemas.microsoft.com/office/drawing/2014/main" id="{B76248F3-68FA-48C1-A3A3-41971C40606A}"/>
+                <a16:creationId xmlns:a16="http://schemas.microsoft.com/office/drawing/2014/main" id="{4FA068DC-A5AD-41E3-AE2C-A9278E9076C6}"/>
               </a:ext>
             </a:extLst>
           </p:cNvPr>
@@ -2121,7 +2121,7 @@
           <p:cNvPr id="4" name="">
             <a:extLst xmlns:a="http://schemas.openxmlformats.org/drawingml/2006/main">
               <a:ext uri="{FF2B5EF4-FFF2-40B4-BE49-F238E27FC236}">
-                <a16:creationId xmlns:a16="http://schemas.microsoft.com/office/drawing/2014/main" id="{53A0A5EA-18AA-4116-98C9-613A360B72A5}"/>
+                <a16:creationId xmlns:a16="http://schemas.microsoft.com/office/drawing/2014/main" id="{BC97FDD4-D129-445A-89E5-E92EF70F2262}"/>
               </a:ext>
             </a:extLst>
           </p:cNvPr>
@@ -2178,7 +2178,7 @@
           <p:cNvPr id="5" name="">
             <a:extLst xmlns:a="http://schemas.openxmlformats.org/drawingml/2006/main">
               <a:ext uri="{FF2B5EF4-FFF2-40B4-BE49-F238E27FC236}">
-                <a16:creationId xmlns:a16="http://schemas.microsoft.com/office/drawing/2014/main" id="{E343E5CF-5D55-4DA0-9E30-F36D94E142EC}"/>
+                <a16:creationId xmlns:a16="http://schemas.microsoft.com/office/drawing/2014/main" id="{FEE02F8E-47F5-4170-AC05-EC54B5F7D7D4}"/>
               </a:ext>
             </a:extLst>
           </p:cNvPr>
@@ -2235,7 +2235,7 @@
           <p:cNvPr id="6" name="">
             <a:extLst xmlns:a="http://schemas.openxmlformats.org/drawingml/2006/main">
               <a:ext uri="{FF2B5EF4-FFF2-40B4-BE49-F238E27FC236}">
-                <a16:creationId xmlns:a16="http://schemas.microsoft.com/office/drawing/2014/main" id="{7D8D8664-4678-4281-867A-AEA82A90FF5A}"/>
+                <a16:creationId xmlns:a16="http://schemas.microsoft.com/office/drawing/2014/main" id="{E7C7E610-D68C-4CD8-BB26-42B9A9B68EC0}"/>
               </a:ext>
             </a:extLst>
           </p:cNvPr>
@@ -2290,7 +2290,7 @@
     </p:spTree>
     <p:extLst>
       <p:ext uri="{BB962C8B-B14F-4D97-AF65-F5344CB8AC3E}">
-        <p14:creationId xmlns:p14="http://schemas.microsoft.com/office/powerpoint/2010/main" val="1316825493"/>
+        <p14:creationId xmlns:p14="http://schemas.microsoft.com/office/powerpoint/2010/main" val="145468954"/>
       </p:ext>
     </p:extLst>
   </p:cSld>
@@ -2321,7 +2321,7 @@
           <p:cNvPr id="15" name="">
             <a:extLst xmlns:a="http://schemas.openxmlformats.org/drawingml/2006/main">
               <a:ext uri="{FF2B5EF4-FFF2-40B4-BE49-F238E27FC236}">
-                <a16:creationId xmlns:a16="http://schemas.microsoft.com/office/drawing/2014/main" id="{E99B8F78-C879-4E50-AB16-0A2BF21222AC}"/>
+                <a16:creationId xmlns:a16="http://schemas.microsoft.com/office/drawing/2014/main" id="{D15DF358-C478-4FB6-9130-76224C0F7840}"/>
               </a:ext>
             </a:extLst>
           </p:cNvPr>
@@ -2378,7 +2378,7 @@
           <p:cNvPr id="2" name="">
             <a:extLst xmlns:a="http://schemas.openxmlformats.org/drawingml/2006/main">
               <a:ext uri="{FF2B5EF4-FFF2-40B4-BE49-F238E27FC236}">
-                <a16:creationId xmlns:a16="http://schemas.microsoft.com/office/drawing/2014/main" id="{08EDF287-1882-4266-912A-0D19C6847D6E}"/>
+                <a16:creationId xmlns:a16="http://schemas.microsoft.com/office/drawing/2014/main" id="{3F9D070A-B558-49A9-8DFC-3BF09D38A197}"/>
               </a:ext>
             </a:extLst>
           </p:cNvPr>
@@ -2435,7 +2435,7 @@
           <p:cNvPr id="3" name="">
             <a:extLst xmlns:a="http://schemas.openxmlformats.org/drawingml/2006/main">
               <a:ext uri="{FF2B5EF4-FFF2-40B4-BE49-F238E27FC236}">
-                <a16:creationId xmlns:a16="http://schemas.microsoft.com/office/drawing/2014/main" id="{51E95716-947B-4BBE-A320-EF51AAE72A1C}"/>
+                <a16:creationId xmlns:a16="http://schemas.microsoft.com/office/drawing/2014/main" id="{46D75E1B-442F-4587-B177-DC5BC490C8AE}"/>
               </a:ext>
             </a:extLst>
           </p:cNvPr>
@@ -2492,7 +2492,7 @@
           <p:cNvPr id="4" name="">
             <a:extLst xmlns:a="http://schemas.openxmlformats.org/drawingml/2006/main">
               <a:ext uri="{FF2B5EF4-FFF2-40B4-BE49-F238E27FC236}">
-                <a16:creationId xmlns:a16="http://schemas.microsoft.com/office/drawing/2014/main" id="{709B3502-60B9-49D8-A0AF-B4A5FA796906}"/>
+                <a16:creationId xmlns:a16="http://schemas.microsoft.com/office/drawing/2014/main" id="{8C993DBD-67DD-40F5-B3A9-E7427B45679E}"/>
               </a:ext>
             </a:extLst>
           </p:cNvPr>
@@ -2539,7 +2539,7 @@
                 <a:ea typeface="Arial"/>
                 <a:cs typeface="Arial"/>
               </a:rPr>
-              <a:t>Pytest passed with 28 unit and integration tests</a:t>
+              <a:t>Pytest passed with 30 unit and integration tests</a:t>
             </a:r>
           </a:p>
         </p:txBody>
@@ -2549,7 +2549,7 @@
           <p:cNvPr id="5" name="">
             <a:extLst xmlns:a="http://schemas.openxmlformats.org/drawingml/2006/main">
               <a:ext uri="{FF2B5EF4-FFF2-40B4-BE49-F238E27FC236}">
-                <a16:creationId xmlns:a16="http://schemas.microsoft.com/office/drawing/2014/main" id="{A767BE10-162B-405B-AA98-477C87D98CF6}"/>
+                <a16:creationId xmlns:a16="http://schemas.microsoft.com/office/drawing/2014/main" id="{53F48319-2AB1-4384-878A-400F7103B770}"/>
               </a:ext>
             </a:extLst>
           </p:cNvPr>
@@ -2581,7 +2581,7 @@
           <p:cNvPr id="6" name="">
             <a:extLst xmlns:a="http://schemas.openxmlformats.org/drawingml/2006/main">
               <a:ext uri="{FF2B5EF4-FFF2-40B4-BE49-F238E27FC236}">
-                <a16:creationId xmlns:a16="http://schemas.microsoft.com/office/drawing/2014/main" id="{AEA6ED3B-1A01-4142-A1C5-ED1692D57A79}"/>
+                <a16:creationId xmlns:a16="http://schemas.microsoft.com/office/drawing/2014/main" id="{D3E3BB4C-7656-4044-BFA1-DA1C26874923}"/>
               </a:ext>
             </a:extLst>
           </p:cNvPr>
@@ -2638,7 +2638,7 @@
           <p:cNvPr id="7" name="">
             <a:extLst xmlns:a="http://schemas.openxmlformats.org/drawingml/2006/main">
               <a:ext uri="{FF2B5EF4-FFF2-40B4-BE49-F238E27FC236}">
-                <a16:creationId xmlns:a16="http://schemas.microsoft.com/office/drawing/2014/main" id="{DC289635-FD94-46A5-93BD-0940BCAFA4C4}"/>
+                <a16:creationId xmlns:a16="http://schemas.microsoft.com/office/drawing/2014/main" id="{EC2F8FE5-2062-4708-8816-D68E9A07D05B}"/>
               </a:ext>
             </a:extLst>
           </p:cNvPr>
@@ -2670,7 +2670,7 @@
           <p:cNvPr id="8" name="">
             <a:extLst xmlns:a="http://schemas.openxmlformats.org/drawingml/2006/main">
               <a:ext uri="{FF2B5EF4-FFF2-40B4-BE49-F238E27FC236}">
-                <a16:creationId xmlns:a16="http://schemas.microsoft.com/office/drawing/2014/main" id="{E641DBDA-A8A7-4B25-910A-909CFEDB4D7D}"/>
+                <a16:creationId xmlns:a16="http://schemas.microsoft.com/office/drawing/2014/main" id="{1589B109-4ABD-424D-8016-AA87A08FF89B}"/>
               </a:ext>
             </a:extLst>
           </p:cNvPr>
@@ -2727,7 +2727,7 @@
           <p:cNvPr id="9" name="">
             <a:extLst xmlns:a="http://schemas.openxmlformats.org/drawingml/2006/main">
               <a:ext uri="{FF2B5EF4-FFF2-40B4-BE49-F238E27FC236}">
-                <a16:creationId xmlns:a16="http://schemas.microsoft.com/office/drawing/2014/main" id="{9E19A478-C185-41C4-AB17-CBCBD9D3D568}"/>
+                <a16:creationId xmlns:a16="http://schemas.microsoft.com/office/drawing/2014/main" id="{A9F28E0C-894A-4789-BC15-69A43A872A76}"/>
               </a:ext>
             </a:extLst>
           </p:cNvPr>
@@ -2759,7 +2759,7 @@
           <p:cNvPr id="10" name="">
             <a:extLst xmlns:a="http://schemas.openxmlformats.org/drawingml/2006/main">
               <a:ext uri="{FF2B5EF4-FFF2-40B4-BE49-F238E27FC236}">
-                <a16:creationId xmlns:a16="http://schemas.microsoft.com/office/drawing/2014/main" id="{C1DF5597-7719-4650-89E0-BAF8CB07B65D}"/>
+                <a16:creationId xmlns:a16="http://schemas.microsoft.com/office/drawing/2014/main" id="{31A8A97F-79C2-4FA6-996B-9B78FB629385}"/>
               </a:ext>
             </a:extLst>
           </p:cNvPr>
@@ -2816,7 +2816,7 @@
           <p:cNvPr id="11" name="">
             <a:extLst xmlns:a="http://schemas.openxmlformats.org/drawingml/2006/main">
               <a:ext uri="{FF2B5EF4-FFF2-40B4-BE49-F238E27FC236}">
-                <a16:creationId xmlns:a16="http://schemas.microsoft.com/office/drawing/2014/main" id="{400D4BF9-6B70-420B-8A7C-49A4C868297A}"/>
+                <a16:creationId xmlns:a16="http://schemas.microsoft.com/office/drawing/2014/main" id="{1F986F04-9787-4543-B46B-83877BF4871C}"/>
               </a:ext>
             </a:extLst>
           </p:cNvPr>
@@ -2848,7 +2848,7 @@
           <p:cNvPr id="12" name="">
             <a:extLst xmlns:a="http://schemas.openxmlformats.org/drawingml/2006/main">
               <a:ext uri="{FF2B5EF4-FFF2-40B4-BE49-F238E27FC236}">
-                <a16:creationId xmlns:a16="http://schemas.microsoft.com/office/drawing/2014/main" id="{CFA04890-1B6A-44C8-875B-3563B81B2D19}"/>
+                <a16:creationId xmlns:a16="http://schemas.microsoft.com/office/drawing/2014/main" id="{CE4B5A0F-BC52-4653-AB8D-5934BA6D26F6}"/>
               </a:ext>
             </a:extLst>
           </p:cNvPr>
@@ -2895,7 +2895,7 @@
                 <a:ea typeface="Arial"/>
                 <a:cs typeface="Arial"/>
               </a:rPr>
-              <a:t>Real-video overlay and evidence frames generated</a:t>
+              <a:t>Browser-safe H.264 overlay and evidence frames generated</a:t>
             </a:r>
           </a:p>
         </p:txBody>
@@ -2905,7 +2905,7 @@
           <p:cNvPr id="13" name="">
             <a:extLst xmlns:a="http://schemas.openxmlformats.org/drawingml/2006/main">
               <a:ext uri="{FF2B5EF4-FFF2-40B4-BE49-F238E27FC236}">
-                <a16:creationId xmlns:a16="http://schemas.microsoft.com/office/drawing/2014/main" id="{6063F49A-11BB-4F4F-85DE-E25B32858512}"/>
+                <a16:creationId xmlns:a16="http://schemas.microsoft.com/office/drawing/2014/main" id="{FB0A83D8-8011-45BB-AACC-D6B370FF3113}"/>
               </a:ext>
             </a:extLst>
           </p:cNvPr>
@@ -2937,7 +2937,7 @@
           <p:cNvPr id="14" name="">
             <a:extLst xmlns:a="http://schemas.openxmlformats.org/drawingml/2006/main">
               <a:ext uri="{FF2B5EF4-FFF2-40B4-BE49-F238E27FC236}">
-                <a16:creationId xmlns:a16="http://schemas.microsoft.com/office/drawing/2014/main" id="{A49AD0FA-E9D6-463D-BD9E-F506F892A801}"/>
+                <a16:creationId xmlns:a16="http://schemas.microsoft.com/office/drawing/2014/main" id="{B00F9D58-966C-4D7D-8F51-5F42C3A8AE20}"/>
               </a:ext>
             </a:extLst>
           </p:cNvPr>
@@ -2992,7 +2992,7 @@
     </p:spTree>
     <p:extLst>
       <p:ext uri="{BB962C8B-B14F-4D97-AF65-F5344CB8AC3E}">
-        <p14:creationId xmlns:p14="http://schemas.microsoft.com/office/powerpoint/2010/main" val="995629608"/>
+        <p14:creationId xmlns:p14="http://schemas.microsoft.com/office/powerpoint/2010/main" val="391469766"/>
       </p:ext>
     </p:extLst>
   </p:cSld>
@@ -3023,7 +3023,7 @@
           <p:cNvPr id="15" name="">
             <a:extLst xmlns:a="http://schemas.openxmlformats.org/drawingml/2006/main">
               <a:ext uri="{FF2B5EF4-FFF2-40B4-BE49-F238E27FC236}">
-                <a16:creationId xmlns:a16="http://schemas.microsoft.com/office/drawing/2014/main" id="{6340FCF4-DC41-4976-8466-94086D15C1F7}"/>
+                <a16:creationId xmlns:a16="http://schemas.microsoft.com/office/drawing/2014/main" id="{5093F919-D0CB-468D-B35F-CECAB794B7C4}"/>
               </a:ext>
             </a:extLst>
           </p:cNvPr>
@@ -3080,7 +3080,7 @@
           <p:cNvPr id="2" name="">
             <a:extLst xmlns:a="http://schemas.openxmlformats.org/drawingml/2006/main">
               <a:ext uri="{FF2B5EF4-FFF2-40B4-BE49-F238E27FC236}">
-                <a16:creationId xmlns:a16="http://schemas.microsoft.com/office/drawing/2014/main" id="{A9B0CFE0-3E6C-46EB-9C0C-7FC4C4C0F924}"/>
+                <a16:creationId xmlns:a16="http://schemas.microsoft.com/office/drawing/2014/main" id="{031C0959-5986-4A6B-973C-02EED033FB35}"/>
               </a:ext>
             </a:extLst>
           </p:cNvPr>
@@ -3137,7 +3137,7 @@
           <p:cNvPr id="3" name="">
             <a:extLst xmlns:a="http://schemas.openxmlformats.org/drawingml/2006/main">
               <a:ext uri="{FF2B5EF4-FFF2-40B4-BE49-F238E27FC236}">
-                <a16:creationId xmlns:a16="http://schemas.microsoft.com/office/drawing/2014/main" id="{778E8A65-F2CB-49C2-BE19-83C08C832293}"/>
+                <a16:creationId xmlns:a16="http://schemas.microsoft.com/office/drawing/2014/main" id="{FB979C11-AF86-476F-AA34-D80D3B8A1B3A}"/>
               </a:ext>
             </a:extLst>
           </p:cNvPr>
@@ -3194,7 +3194,7 @@
           <p:cNvPr id="4" name="">
             <a:extLst xmlns:a="http://schemas.openxmlformats.org/drawingml/2006/main">
               <a:ext uri="{FF2B5EF4-FFF2-40B4-BE49-F238E27FC236}">
-                <a16:creationId xmlns:a16="http://schemas.microsoft.com/office/drawing/2014/main" id="{88F49981-8576-49F3-84C5-34F181E23DBF}"/>
+                <a16:creationId xmlns:a16="http://schemas.microsoft.com/office/drawing/2014/main" id="{3C847070-55D0-49BB-9836-32E2D56118B2}"/>
               </a:ext>
             </a:extLst>
           </p:cNvPr>
@@ -3251,7 +3251,7 @@
           <p:cNvPr id="5" name="">
             <a:extLst xmlns:a="http://schemas.openxmlformats.org/drawingml/2006/main">
               <a:ext uri="{FF2B5EF4-FFF2-40B4-BE49-F238E27FC236}">
-                <a16:creationId xmlns:a16="http://schemas.microsoft.com/office/drawing/2014/main" id="{FC6779E2-F50A-49BD-8AA9-C0687F116CC6}"/>
+                <a16:creationId xmlns:a16="http://schemas.microsoft.com/office/drawing/2014/main" id="{5128F7A3-38F3-49DF-A433-0738BA314969}"/>
               </a:ext>
             </a:extLst>
           </p:cNvPr>
@@ -3283,7 +3283,7 @@
           <p:cNvPr id="6" name="">
             <a:extLst xmlns:a="http://schemas.openxmlformats.org/drawingml/2006/main">
               <a:ext uri="{FF2B5EF4-FFF2-40B4-BE49-F238E27FC236}">
-                <a16:creationId xmlns:a16="http://schemas.microsoft.com/office/drawing/2014/main" id="{11FA64F2-F782-4B0D-A443-EFE216EFF6A6}"/>
+                <a16:creationId xmlns:a16="http://schemas.microsoft.com/office/drawing/2014/main" id="{8C7FC333-0F65-44DC-945B-94DB513E9856}"/>
               </a:ext>
             </a:extLst>
           </p:cNvPr>
@@ -3340,7 +3340,7 @@
           <p:cNvPr id="7" name="">
             <a:extLst xmlns:a="http://schemas.openxmlformats.org/drawingml/2006/main">
               <a:ext uri="{FF2B5EF4-FFF2-40B4-BE49-F238E27FC236}">
-                <a16:creationId xmlns:a16="http://schemas.microsoft.com/office/drawing/2014/main" id="{1A9506A8-D3C1-47A8-BB41-3D252076A064}"/>
+                <a16:creationId xmlns:a16="http://schemas.microsoft.com/office/drawing/2014/main" id="{BA43CB07-F004-47D1-AA00-17A5A86206AF}"/>
               </a:ext>
             </a:extLst>
           </p:cNvPr>
@@ -3372,7 +3372,7 @@
           <p:cNvPr id="8" name="">
             <a:extLst xmlns:a="http://schemas.openxmlformats.org/drawingml/2006/main">
               <a:ext uri="{FF2B5EF4-FFF2-40B4-BE49-F238E27FC236}">
-                <a16:creationId xmlns:a16="http://schemas.microsoft.com/office/drawing/2014/main" id="{178FA3B3-ABCF-4E14-B4E5-3313732D5428}"/>
+                <a16:creationId xmlns:a16="http://schemas.microsoft.com/office/drawing/2014/main" id="{738740F8-E907-4613-9C08-9398F175E149}"/>
               </a:ext>
             </a:extLst>
           </p:cNvPr>
@@ -3429,7 +3429,7 @@
           <p:cNvPr id="9" name="">
             <a:extLst xmlns:a="http://schemas.openxmlformats.org/drawingml/2006/main">
               <a:ext uri="{FF2B5EF4-FFF2-40B4-BE49-F238E27FC236}">
-                <a16:creationId xmlns:a16="http://schemas.microsoft.com/office/drawing/2014/main" id="{2CC585DE-43E7-4F17-B804-54BD0CB17348}"/>
+                <a16:creationId xmlns:a16="http://schemas.microsoft.com/office/drawing/2014/main" id="{72B3053B-DBD4-4B6D-AE0F-5C86877BA158}"/>
               </a:ext>
             </a:extLst>
           </p:cNvPr>
@@ -3461,7 +3461,7 @@
           <p:cNvPr id="10" name="">
             <a:extLst xmlns:a="http://schemas.openxmlformats.org/drawingml/2006/main">
               <a:ext uri="{FF2B5EF4-FFF2-40B4-BE49-F238E27FC236}">
-                <a16:creationId xmlns:a16="http://schemas.microsoft.com/office/drawing/2014/main" id="{0C7C7E42-3A03-4B86-BC0C-3B5FA3D46184}"/>
+                <a16:creationId xmlns:a16="http://schemas.microsoft.com/office/drawing/2014/main" id="{A86E87C0-BD13-4798-B19F-5CDA80DA4666}"/>
               </a:ext>
             </a:extLst>
           </p:cNvPr>
@@ -3518,7 +3518,7 @@
           <p:cNvPr id="11" name="">
             <a:extLst xmlns:a="http://schemas.openxmlformats.org/drawingml/2006/main">
               <a:ext uri="{FF2B5EF4-FFF2-40B4-BE49-F238E27FC236}">
-                <a16:creationId xmlns:a16="http://schemas.microsoft.com/office/drawing/2014/main" id="{AAFBACC7-E740-49F4-BE9D-62291FC17C76}"/>
+                <a16:creationId xmlns:a16="http://schemas.microsoft.com/office/drawing/2014/main" id="{2C96F595-C2D3-4574-A16C-27F326FC9F49}"/>
               </a:ext>
             </a:extLst>
           </p:cNvPr>
@@ -3550,7 +3550,7 @@
           <p:cNvPr id="12" name="">
             <a:extLst xmlns:a="http://schemas.openxmlformats.org/drawingml/2006/main">
               <a:ext uri="{FF2B5EF4-FFF2-40B4-BE49-F238E27FC236}">
-                <a16:creationId xmlns:a16="http://schemas.microsoft.com/office/drawing/2014/main" id="{C7DD756F-F195-4E63-97B9-D782D8782F22}"/>
+                <a16:creationId xmlns:a16="http://schemas.microsoft.com/office/drawing/2014/main" id="{D140584B-7EB1-4D83-866A-9283654A1115}"/>
               </a:ext>
             </a:extLst>
           </p:cNvPr>
@@ -3607,7 +3607,7 @@
           <p:cNvPr id="13" name="">
             <a:extLst xmlns:a="http://schemas.openxmlformats.org/drawingml/2006/main">
               <a:ext uri="{FF2B5EF4-FFF2-40B4-BE49-F238E27FC236}">
-                <a16:creationId xmlns:a16="http://schemas.microsoft.com/office/drawing/2014/main" id="{1BF06A88-E938-4F1E-A4E3-84FCA79AA285}"/>
+                <a16:creationId xmlns:a16="http://schemas.microsoft.com/office/drawing/2014/main" id="{1684DDAE-AF9B-40E6-8F03-5CB430717E72}"/>
               </a:ext>
             </a:extLst>
           </p:cNvPr>
@@ -3639,7 +3639,7 @@
           <p:cNvPr id="14" name="">
             <a:extLst xmlns:a="http://schemas.openxmlformats.org/drawingml/2006/main">
               <a:ext uri="{FF2B5EF4-FFF2-40B4-BE49-F238E27FC236}">
-                <a16:creationId xmlns:a16="http://schemas.microsoft.com/office/drawing/2014/main" id="{8BB30170-6B7F-4532-BD9C-0B167712373C}"/>
+                <a16:creationId xmlns:a16="http://schemas.microsoft.com/office/drawing/2014/main" id="{BD87C44E-C3D3-4E2E-ACDF-AE9CF90CB9BC}"/>
               </a:ext>
             </a:extLst>
           </p:cNvPr>
@@ -3694,7 +3694,7 @@
     </p:spTree>
     <p:extLst>
       <p:ext uri="{BB962C8B-B14F-4D97-AF65-F5344CB8AC3E}">
-        <p14:creationId xmlns:p14="http://schemas.microsoft.com/office/powerpoint/2010/main" val="291406420"/>
+        <p14:creationId xmlns:p14="http://schemas.microsoft.com/office/powerpoint/2010/main" val="330076323"/>
       </p:ext>
     </p:extLst>
   </p:cSld>
@@ -3725,7 +3725,7 @@
           <p:cNvPr id="6" name="">
             <a:extLst xmlns:a="http://schemas.openxmlformats.org/drawingml/2006/main">
               <a:ext uri="{FF2B5EF4-FFF2-40B4-BE49-F238E27FC236}">
-                <a16:creationId xmlns:a16="http://schemas.microsoft.com/office/drawing/2014/main" id="{5929F6DD-ABC6-487D-8BC8-50E08459725D}"/>
+                <a16:creationId xmlns:a16="http://schemas.microsoft.com/office/drawing/2014/main" id="{F5EAB189-4DBA-4830-B1DA-9EECD1D62294}"/>
               </a:ext>
             </a:extLst>
           </p:cNvPr>
@@ -3782,7 +3782,7 @@
           <p:cNvPr id="2" name="">
             <a:extLst xmlns:a="http://schemas.openxmlformats.org/drawingml/2006/main">
               <a:ext uri="{FF2B5EF4-FFF2-40B4-BE49-F238E27FC236}">
-                <a16:creationId xmlns:a16="http://schemas.microsoft.com/office/drawing/2014/main" id="{8395BB1F-3B65-4498-B584-5E87DFF51A75}"/>
+                <a16:creationId xmlns:a16="http://schemas.microsoft.com/office/drawing/2014/main" id="{D5CFD9BC-6A30-442F-9DBD-C8A99C7AE69C}"/>
               </a:ext>
             </a:extLst>
           </p:cNvPr>
@@ -3814,7 +3814,7 @@
           <p:cNvPr id="3" name="">
             <a:extLst xmlns:a="http://schemas.openxmlformats.org/drawingml/2006/main">
               <a:ext uri="{FF2B5EF4-FFF2-40B4-BE49-F238E27FC236}">
-                <a16:creationId xmlns:a16="http://schemas.microsoft.com/office/drawing/2014/main" id="{875EE4C7-00B4-4F68-A4A4-42E0DC2BEE9D}"/>
+                <a16:creationId xmlns:a16="http://schemas.microsoft.com/office/drawing/2014/main" id="{0B198B84-745B-4EAE-9532-A0C1A595F81D}"/>
               </a:ext>
             </a:extLst>
           </p:cNvPr>
@@ -3871,7 +3871,7 @@
           <p:cNvPr id="4" name="">
             <a:extLst xmlns:a="http://schemas.openxmlformats.org/drawingml/2006/main">
               <a:ext uri="{FF2B5EF4-FFF2-40B4-BE49-F238E27FC236}">
-                <a16:creationId xmlns:a16="http://schemas.microsoft.com/office/drawing/2014/main" id="{D54C9B83-C85C-43DF-98A7-3BA102893401}"/>
+                <a16:creationId xmlns:a16="http://schemas.microsoft.com/office/drawing/2014/main" id="{74E492D8-1DA6-48C5-A198-58A56ABF5715}"/>
               </a:ext>
             </a:extLst>
           </p:cNvPr>
@@ -3928,7 +3928,7 @@
           <p:cNvPr id="5" name="">
             <a:extLst xmlns:a="http://schemas.openxmlformats.org/drawingml/2006/main">
               <a:ext uri="{FF2B5EF4-FFF2-40B4-BE49-F238E27FC236}">
-                <a16:creationId xmlns:a16="http://schemas.microsoft.com/office/drawing/2014/main" id="{2883A944-1669-43C7-9FF2-B30E31EEFC7C}"/>
+                <a16:creationId xmlns:a16="http://schemas.microsoft.com/office/drawing/2014/main" id="{3F1869E1-7764-4FCC-9117-7ECAF513E7A3}"/>
               </a:ext>
             </a:extLst>
           </p:cNvPr>
@@ -3983,7 +3983,7 @@
     </p:spTree>
     <p:extLst>
       <p:ext uri="{BB962C8B-B14F-4D97-AF65-F5344CB8AC3E}">
-        <p14:creationId xmlns:p14="http://schemas.microsoft.com/office/powerpoint/2010/main" val="426420838"/>
+        <p14:creationId xmlns:p14="http://schemas.microsoft.com/office/powerpoint/2010/main" val="543756616"/>
       </p:ext>
     </p:extLst>
   </p:cSld>
@@ -4014,7 +4014,7 @@
           <p:cNvPr id="15" name="">
             <a:extLst xmlns:a="http://schemas.openxmlformats.org/drawingml/2006/main">
               <a:ext uri="{FF2B5EF4-FFF2-40B4-BE49-F238E27FC236}">
-                <a16:creationId xmlns:a16="http://schemas.microsoft.com/office/drawing/2014/main" id="{6C248388-980C-4260-864B-58F2212D2536}"/>
+                <a16:creationId xmlns:a16="http://schemas.microsoft.com/office/drawing/2014/main" id="{FF50C682-A532-4908-A1F4-9EF8531341DC}"/>
               </a:ext>
             </a:extLst>
           </p:cNvPr>
@@ -4071,7 +4071,7 @@
           <p:cNvPr id="2" name="">
             <a:extLst xmlns:a="http://schemas.openxmlformats.org/drawingml/2006/main">
               <a:ext uri="{FF2B5EF4-FFF2-40B4-BE49-F238E27FC236}">
-                <a16:creationId xmlns:a16="http://schemas.microsoft.com/office/drawing/2014/main" id="{2F3CB6B8-F41B-45A6-8CCC-0393620F107C}"/>
+                <a16:creationId xmlns:a16="http://schemas.microsoft.com/office/drawing/2014/main" id="{D06C5250-BBAA-407E-8AFF-3B334AD59839}"/>
               </a:ext>
             </a:extLst>
           </p:cNvPr>
@@ -4128,7 +4128,7 @@
           <p:cNvPr id="3" name="">
             <a:extLst xmlns:a="http://schemas.openxmlformats.org/drawingml/2006/main">
               <a:ext uri="{FF2B5EF4-FFF2-40B4-BE49-F238E27FC236}">
-                <a16:creationId xmlns:a16="http://schemas.microsoft.com/office/drawing/2014/main" id="{A7BA7D36-22C1-4E71-BE14-6119A5F65AB5}"/>
+                <a16:creationId xmlns:a16="http://schemas.microsoft.com/office/drawing/2014/main" id="{64B661D9-124D-4D86-A3E3-8438578FC83A}"/>
               </a:ext>
             </a:extLst>
           </p:cNvPr>
@@ -4185,7 +4185,7 @@
           <p:cNvPr id="4" name="">
             <a:extLst xmlns:a="http://schemas.openxmlformats.org/drawingml/2006/main">
               <a:ext uri="{FF2B5EF4-FFF2-40B4-BE49-F238E27FC236}">
-                <a16:creationId xmlns:a16="http://schemas.microsoft.com/office/drawing/2014/main" id="{A8216A4E-112E-4AA9-B575-CAF1602C014C}"/>
+                <a16:creationId xmlns:a16="http://schemas.microsoft.com/office/drawing/2014/main" id="{A1CCBF9C-E5C8-4445-BC90-D6B5049C5969}"/>
               </a:ext>
             </a:extLst>
           </p:cNvPr>
@@ -4242,7 +4242,7 @@
           <p:cNvPr id="5" name="">
             <a:extLst xmlns:a="http://schemas.openxmlformats.org/drawingml/2006/main">
               <a:ext uri="{FF2B5EF4-FFF2-40B4-BE49-F238E27FC236}">
-                <a16:creationId xmlns:a16="http://schemas.microsoft.com/office/drawing/2014/main" id="{10B27678-9AA4-49A9-AA4A-E92A20008A2B}"/>
+                <a16:creationId xmlns:a16="http://schemas.microsoft.com/office/drawing/2014/main" id="{6AE86988-68CE-4341-BF00-49F43F75FB41}"/>
               </a:ext>
             </a:extLst>
           </p:cNvPr>
@@ -4274,7 +4274,7 @@
           <p:cNvPr id="6" name="">
             <a:extLst xmlns:a="http://schemas.openxmlformats.org/drawingml/2006/main">
               <a:ext uri="{FF2B5EF4-FFF2-40B4-BE49-F238E27FC236}">
-                <a16:creationId xmlns:a16="http://schemas.microsoft.com/office/drawing/2014/main" id="{11193E17-9115-4ACF-BDA8-88EA07F680E3}"/>
+                <a16:creationId xmlns:a16="http://schemas.microsoft.com/office/drawing/2014/main" id="{D41D4B99-EB7D-442A-9A0D-2DA21A11747F}"/>
               </a:ext>
             </a:extLst>
           </p:cNvPr>
@@ -4331,7 +4331,7 @@
           <p:cNvPr id="7" name="">
             <a:extLst xmlns:a="http://schemas.openxmlformats.org/drawingml/2006/main">
               <a:ext uri="{FF2B5EF4-FFF2-40B4-BE49-F238E27FC236}">
-                <a16:creationId xmlns:a16="http://schemas.microsoft.com/office/drawing/2014/main" id="{1DEE0844-E4B9-4A92-AFC6-8954CCAAB147}"/>
+                <a16:creationId xmlns:a16="http://schemas.microsoft.com/office/drawing/2014/main" id="{32EF8F1E-1D48-400D-9816-B6D93D9939C3}"/>
               </a:ext>
             </a:extLst>
           </p:cNvPr>
@@ -4363,7 +4363,7 @@
           <p:cNvPr id="8" name="">
             <a:extLst xmlns:a="http://schemas.openxmlformats.org/drawingml/2006/main">
               <a:ext uri="{FF2B5EF4-FFF2-40B4-BE49-F238E27FC236}">
-                <a16:creationId xmlns:a16="http://schemas.microsoft.com/office/drawing/2014/main" id="{DA421ECA-5320-4910-A0A2-F2CE75456735}"/>
+                <a16:creationId xmlns:a16="http://schemas.microsoft.com/office/drawing/2014/main" id="{C11F37AC-4F04-4972-B8D9-13E6A014B82F}"/>
               </a:ext>
             </a:extLst>
           </p:cNvPr>
@@ -4420,7 +4420,7 @@
           <p:cNvPr id="9" name="">
             <a:extLst xmlns:a="http://schemas.openxmlformats.org/drawingml/2006/main">
               <a:ext uri="{FF2B5EF4-FFF2-40B4-BE49-F238E27FC236}">
-                <a16:creationId xmlns:a16="http://schemas.microsoft.com/office/drawing/2014/main" id="{14CCD5AC-A16E-4A71-9BB3-496611D7F4ED}"/>
+                <a16:creationId xmlns:a16="http://schemas.microsoft.com/office/drawing/2014/main" id="{0A736DE3-AF13-445F-83FB-884E7181EC94}"/>
               </a:ext>
             </a:extLst>
           </p:cNvPr>
@@ -4452,7 +4452,7 @@
           <p:cNvPr id="10" name="">
             <a:extLst xmlns:a="http://schemas.openxmlformats.org/drawingml/2006/main">
               <a:ext uri="{FF2B5EF4-FFF2-40B4-BE49-F238E27FC236}">
-                <a16:creationId xmlns:a16="http://schemas.microsoft.com/office/drawing/2014/main" id="{C6A87E0D-A039-4585-88D6-BD2E4E67D35E}"/>
+                <a16:creationId xmlns:a16="http://schemas.microsoft.com/office/drawing/2014/main" id="{398AD06B-C716-4708-87AF-5CA75664FA32}"/>
               </a:ext>
             </a:extLst>
           </p:cNvPr>
@@ -4509,7 +4509,7 @@
           <p:cNvPr id="11" name="">
             <a:extLst xmlns:a="http://schemas.openxmlformats.org/drawingml/2006/main">
               <a:ext uri="{FF2B5EF4-FFF2-40B4-BE49-F238E27FC236}">
-                <a16:creationId xmlns:a16="http://schemas.microsoft.com/office/drawing/2014/main" id="{CF2E735A-62AE-47BF-9B11-1DD752F84C6E}"/>
+                <a16:creationId xmlns:a16="http://schemas.microsoft.com/office/drawing/2014/main" id="{F6460361-1A12-4A1D-9969-185DB0EFF17C}"/>
               </a:ext>
             </a:extLst>
           </p:cNvPr>
@@ -4541,7 +4541,7 @@
           <p:cNvPr id="12" name="">
             <a:extLst xmlns:a="http://schemas.openxmlformats.org/drawingml/2006/main">
               <a:ext uri="{FF2B5EF4-FFF2-40B4-BE49-F238E27FC236}">
-                <a16:creationId xmlns:a16="http://schemas.microsoft.com/office/drawing/2014/main" id="{31F11184-8484-4FB7-897F-FAC1AD93D5D4}"/>
+                <a16:creationId xmlns:a16="http://schemas.microsoft.com/office/drawing/2014/main" id="{7DA1E6BE-6669-4BE9-8F08-3655F0D155A4}"/>
               </a:ext>
             </a:extLst>
           </p:cNvPr>
@@ -4598,7 +4598,7 @@
           <p:cNvPr id="13" name="">
             <a:extLst xmlns:a="http://schemas.openxmlformats.org/drawingml/2006/main">
               <a:ext uri="{FF2B5EF4-FFF2-40B4-BE49-F238E27FC236}">
-                <a16:creationId xmlns:a16="http://schemas.microsoft.com/office/drawing/2014/main" id="{FAA16CB3-CDD4-43F4-ABBF-BE14D627F0DF}"/>
+                <a16:creationId xmlns:a16="http://schemas.microsoft.com/office/drawing/2014/main" id="{C6678E95-8FAD-4146-8A9E-2794CD1B2A43}"/>
               </a:ext>
             </a:extLst>
           </p:cNvPr>
@@ -4630,7 +4630,7 @@
           <p:cNvPr id="14" name="">
             <a:extLst xmlns:a="http://schemas.openxmlformats.org/drawingml/2006/main">
               <a:ext uri="{FF2B5EF4-FFF2-40B4-BE49-F238E27FC236}">
-                <a16:creationId xmlns:a16="http://schemas.microsoft.com/office/drawing/2014/main" id="{CC83D795-148B-4FE0-A47C-0206D78E0A4C}"/>
+                <a16:creationId xmlns:a16="http://schemas.microsoft.com/office/drawing/2014/main" id="{8FCA6CB9-5238-42B0-9230-4A9EC408087E}"/>
               </a:ext>
             </a:extLst>
           </p:cNvPr>
@@ -4685,7 +4685,7 @@
     </p:spTree>
     <p:extLst>
       <p:ext uri="{BB962C8B-B14F-4D97-AF65-F5344CB8AC3E}">
-        <p14:creationId xmlns:p14="http://schemas.microsoft.com/office/powerpoint/2010/main" val="833145198"/>
+        <p14:creationId xmlns:p14="http://schemas.microsoft.com/office/powerpoint/2010/main" val="216271857"/>
       </p:ext>
     </p:extLst>
   </p:cSld>
@@ -4716,7 +4716,7 @@
           <p:cNvPr id="16" name="">
             <a:extLst xmlns:a="http://schemas.openxmlformats.org/drawingml/2006/main">
               <a:ext uri="{FF2B5EF4-FFF2-40B4-BE49-F238E27FC236}">
-                <a16:creationId xmlns:a16="http://schemas.microsoft.com/office/drawing/2014/main" id="{BC1FF04B-4BA8-4C98-9714-FFEA583B8381}"/>
+                <a16:creationId xmlns:a16="http://schemas.microsoft.com/office/drawing/2014/main" id="{E66D1600-1266-4012-9C1F-12DDE6D335B0}"/>
               </a:ext>
             </a:extLst>
           </p:cNvPr>
@@ -4773,7 +4773,7 @@
           <p:cNvPr id="2" name="">
             <a:extLst xmlns:a="http://schemas.openxmlformats.org/drawingml/2006/main">
               <a:ext uri="{FF2B5EF4-FFF2-40B4-BE49-F238E27FC236}">
-                <a16:creationId xmlns:a16="http://schemas.microsoft.com/office/drawing/2014/main" id="{7F11FD78-646F-443D-914F-1A74BFEE4231}"/>
+                <a16:creationId xmlns:a16="http://schemas.microsoft.com/office/drawing/2014/main" id="{1F724263-592C-4528-8ACB-8A14FB248A10}"/>
               </a:ext>
             </a:extLst>
           </p:cNvPr>
@@ -4830,7 +4830,7 @@
           <p:cNvPr id="3" name="">
             <a:extLst xmlns:a="http://schemas.openxmlformats.org/drawingml/2006/main">
               <a:ext uri="{FF2B5EF4-FFF2-40B4-BE49-F238E27FC236}">
-                <a16:creationId xmlns:a16="http://schemas.microsoft.com/office/drawing/2014/main" id="{4D584D3E-313A-4A82-896C-4872A914C888}"/>
+                <a16:creationId xmlns:a16="http://schemas.microsoft.com/office/drawing/2014/main" id="{F6711E77-DEE4-42FD-B277-8AE45773D2B3}"/>
               </a:ext>
             </a:extLst>
           </p:cNvPr>
@@ -4887,7 +4887,7 @@
           <p:cNvPr id="4" name="">
             <a:extLst xmlns:a="http://schemas.openxmlformats.org/drawingml/2006/main">
               <a:ext uri="{FF2B5EF4-FFF2-40B4-BE49-F238E27FC236}">
-                <a16:creationId xmlns:a16="http://schemas.microsoft.com/office/drawing/2014/main" id="{1C1F13E7-3166-4E24-BCB0-714383452440}"/>
+                <a16:creationId xmlns:a16="http://schemas.microsoft.com/office/drawing/2014/main" id="{76369C56-B616-4560-9081-7C6F924761F5}"/>
               </a:ext>
             </a:extLst>
           </p:cNvPr>
@@ -4919,7 +4919,7 @@
           <p:cNvPr id="5" name="">
             <a:extLst xmlns:a="http://schemas.openxmlformats.org/drawingml/2006/main">
               <a:ext uri="{FF2B5EF4-FFF2-40B4-BE49-F238E27FC236}">
-                <a16:creationId xmlns:a16="http://schemas.microsoft.com/office/drawing/2014/main" id="{02056281-50D4-46F7-BA1D-0CF1782FBAFC}"/>
+                <a16:creationId xmlns:a16="http://schemas.microsoft.com/office/drawing/2014/main" id="{7358557C-1911-40A6-A0D3-0E5EED3820B5}"/>
               </a:ext>
             </a:extLst>
           </p:cNvPr>
@@ -4976,7 +4976,7 @@
           <p:cNvPr id="6" name="">
             <a:extLst xmlns:a="http://schemas.openxmlformats.org/drawingml/2006/main">
               <a:ext uri="{FF2B5EF4-FFF2-40B4-BE49-F238E27FC236}">
-                <a16:creationId xmlns:a16="http://schemas.microsoft.com/office/drawing/2014/main" id="{A22BEC5A-508F-4EA9-B28A-0E3713F1FF57}"/>
+                <a16:creationId xmlns:a16="http://schemas.microsoft.com/office/drawing/2014/main" id="{32D6E934-82B1-4267-A195-4053CB237858}"/>
               </a:ext>
             </a:extLst>
           </p:cNvPr>
@@ -5008,7 +5008,7 @@
           <p:cNvPr id="7" name="">
             <a:extLst xmlns:a="http://schemas.openxmlformats.org/drawingml/2006/main">
               <a:ext uri="{FF2B5EF4-FFF2-40B4-BE49-F238E27FC236}">
-                <a16:creationId xmlns:a16="http://schemas.microsoft.com/office/drawing/2014/main" id="{602DBC61-AB7D-4411-9FF7-FE9FD59D2F6E}"/>
+                <a16:creationId xmlns:a16="http://schemas.microsoft.com/office/drawing/2014/main" id="{6BF70D6F-2D30-4A5A-B583-2388EBE162CD}"/>
               </a:ext>
             </a:extLst>
           </p:cNvPr>
@@ -5065,7 +5065,7 @@
           <p:cNvPr id="8" name="">
             <a:extLst xmlns:a="http://schemas.openxmlformats.org/drawingml/2006/main">
               <a:ext uri="{FF2B5EF4-FFF2-40B4-BE49-F238E27FC236}">
-                <a16:creationId xmlns:a16="http://schemas.microsoft.com/office/drawing/2014/main" id="{87D7C0A6-DE54-428D-8EBA-0D3A6F6460D3}"/>
+                <a16:creationId xmlns:a16="http://schemas.microsoft.com/office/drawing/2014/main" id="{3F7356C8-3FCE-4372-9653-CAB1FC4320E0}"/>
               </a:ext>
             </a:extLst>
           </p:cNvPr>
@@ -5097,7 +5097,7 @@
           <p:cNvPr id="9" name="">
             <a:extLst xmlns:a="http://schemas.openxmlformats.org/drawingml/2006/main">
               <a:ext uri="{FF2B5EF4-FFF2-40B4-BE49-F238E27FC236}">
-                <a16:creationId xmlns:a16="http://schemas.microsoft.com/office/drawing/2014/main" id="{8B000866-DA92-456F-A4DC-4214A53264DD}"/>
+                <a16:creationId xmlns:a16="http://schemas.microsoft.com/office/drawing/2014/main" id="{DEE2F4DB-CD54-4F49-9E6A-F4F9B20CEAE6}"/>
               </a:ext>
             </a:extLst>
           </p:cNvPr>
@@ -5154,7 +5154,7 @@
           <p:cNvPr id="10" name="">
             <a:extLst xmlns:a="http://schemas.openxmlformats.org/drawingml/2006/main">
               <a:ext uri="{FF2B5EF4-FFF2-40B4-BE49-F238E27FC236}">
-                <a16:creationId xmlns:a16="http://schemas.microsoft.com/office/drawing/2014/main" id="{1561C72F-78E3-4652-BDA8-1465CD19B0B9}"/>
+                <a16:creationId xmlns:a16="http://schemas.microsoft.com/office/drawing/2014/main" id="{2D310B86-D6CB-41FC-AABA-48E1F0352DEB}"/>
               </a:ext>
             </a:extLst>
           </p:cNvPr>
@@ -5186,7 +5186,7 @@
           <p:cNvPr id="11" name="">
             <a:extLst xmlns:a="http://schemas.openxmlformats.org/drawingml/2006/main">
               <a:ext uri="{FF2B5EF4-FFF2-40B4-BE49-F238E27FC236}">
-                <a16:creationId xmlns:a16="http://schemas.microsoft.com/office/drawing/2014/main" id="{A8F2B46F-144F-499C-B43D-4A29306F8958}"/>
+                <a16:creationId xmlns:a16="http://schemas.microsoft.com/office/drawing/2014/main" id="{AB23E9A8-B74D-4A34-B945-3227E19CBC07}"/>
               </a:ext>
             </a:extLst>
           </p:cNvPr>
@@ -5243,7 +5243,7 @@
           <p:cNvPr id="12" name="">
             <a:extLst xmlns:a="http://schemas.openxmlformats.org/drawingml/2006/main">
               <a:ext uri="{FF2B5EF4-FFF2-40B4-BE49-F238E27FC236}">
-                <a16:creationId xmlns:a16="http://schemas.microsoft.com/office/drawing/2014/main" id="{64B91A2C-207B-430D-96A2-511F63A7638A}"/>
+                <a16:creationId xmlns:a16="http://schemas.microsoft.com/office/drawing/2014/main" id="{E445EA9E-B79A-4F55-896C-D1585628C3D1}"/>
               </a:ext>
             </a:extLst>
           </p:cNvPr>
@@ -5275,7 +5275,7 @@
           <p:cNvPr id="13" name="">
             <a:extLst xmlns:a="http://schemas.openxmlformats.org/drawingml/2006/main">
               <a:ext uri="{FF2B5EF4-FFF2-40B4-BE49-F238E27FC236}">
-                <a16:creationId xmlns:a16="http://schemas.microsoft.com/office/drawing/2014/main" id="{08D90555-148C-4397-80F4-9C8B3135DE53}"/>
+                <a16:creationId xmlns:a16="http://schemas.microsoft.com/office/drawing/2014/main" id="{49A6FEFD-363F-490B-82ED-098A032D7E90}"/>
               </a:ext>
             </a:extLst>
           </p:cNvPr>
@@ -5332,7 +5332,7 @@
           <p:cNvPr id="14" name="">
             <a:extLst xmlns:a="http://schemas.openxmlformats.org/drawingml/2006/main">
               <a:ext uri="{FF2B5EF4-FFF2-40B4-BE49-F238E27FC236}">
-                <a16:creationId xmlns:a16="http://schemas.microsoft.com/office/drawing/2014/main" id="{48192E46-9B47-400F-AC29-3105AA7B670F}"/>
+                <a16:creationId xmlns:a16="http://schemas.microsoft.com/office/drawing/2014/main" id="{09E220EB-AF9F-48C8-A634-ED594649B73B}"/>
               </a:ext>
             </a:extLst>
           </p:cNvPr>
@@ -5389,7 +5389,7 @@
           <p:cNvPr id="15" name="">
             <a:extLst xmlns:a="http://schemas.openxmlformats.org/drawingml/2006/main">
               <a:ext uri="{FF2B5EF4-FFF2-40B4-BE49-F238E27FC236}">
-                <a16:creationId xmlns:a16="http://schemas.microsoft.com/office/drawing/2014/main" id="{D40778B9-55DA-4B9A-8246-8393EEC14DD2}"/>
+                <a16:creationId xmlns:a16="http://schemas.microsoft.com/office/drawing/2014/main" id="{4A2E270B-54CC-4217-AC23-84CA41B1E5A4}"/>
               </a:ext>
             </a:extLst>
           </p:cNvPr>
@@ -5444,7 +5444,7 @@
     </p:spTree>
     <p:extLst>
       <p:ext uri="{BB962C8B-B14F-4D97-AF65-F5344CB8AC3E}">
-        <p14:creationId xmlns:p14="http://schemas.microsoft.com/office/powerpoint/2010/main" val="1800258856"/>
+        <p14:creationId xmlns:p14="http://schemas.microsoft.com/office/powerpoint/2010/main" val="1334038422"/>
       </p:ext>
     </p:extLst>
   </p:cSld>
@@ -5475,7 +5475,7 @@
           <p:cNvPr id="23" name="">
             <a:extLst xmlns:a="http://schemas.openxmlformats.org/drawingml/2006/main">
               <a:ext uri="{FF2B5EF4-FFF2-40B4-BE49-F238E27FC236}">
-                <a16:creationId xmlns:a16="http://schemas.microsoft.com/office/drawing/2014/main" id="{23762A63-4322-4332-B304-4D38A66C8E62}"/>
+                <a16:creationId xmlns:a16="http://schemas.microsoft.com/office/drawing/2014/main" id="{5EDBE9AB-16BC-463F-AB36-DAD5F80422C6}"/>
               </a:ext>
             </a:extLst>
           </p:cNvPr>
@@ -5532,7 +5532,7 @@
           <p:cNvPr id="2" name="">
             <a:extLst xmlns:a="http://schemas.openxmlformats.org/drawingml/2006/main">
               <a:ext uri="{FF2B5EF4-FFF2-40B4-BE49-F238E27FC236}">
-                <a16:creationId xmlns:a16="http://schemas.microsoft.com/office/drawing/2014/main" id="{34FD3818-9F02-4B90-ADAB-A7D31A505C27}"/>
+                <a16:creationId xmlns:a16="http://schemas.microsoft.com/office/drawing/2014/main" id="{FB848C24-CD43-4227-BA00-C67EEC75C7B4}"/>
               </a:ext>
             </a:extLst>
           </p:cNvPr>
@@ -5589,7 +5589,7 @@
           <p:cNvPr id="3" name="">
             <a:extLst xmlns:a="http://schemas.openxmlformats.org/drawingml/2006/main">
               <a:ext uri="{FF2B5EF4-FFF2-40B4-BE49-F238E27FC236}">
-                <a16:creationId xmlns:a16="http://schemas.microsoft.com/office/drawing/2014/main" id="{F2C02AC4-B5B3-4314-8F40-CCA874167D07}"/>
+                <a16:creationId xmlns:a16="http://schemas.microsoft.com/office/drawing/2014/main" id="{BFB53556-9638-44C8-9338-5FA9F173A8BB}"/>
               </a:ext>
             </a:extLst>
           </p:cNvPr>
@@ -5646,7 +5646,7 @@
           <p:cNvPr id="4" name="">
             <a:extLst xmlns:a="http://schemas.openxmlformats.org/drawingml/2006/main">
               <a:ext uri="{FF2B5EF4-FFF2-40B4-BE49-F238E27FC236}">
-                <a16:creationId xmlns:a16="http://schemas.microsoft.com/office/drawing/2014/main" id="{AB0662C8-51AE-4C21-846C-49BB95EE39E3}"/>
+                <a16:creationId xmlns:a16="http://schemas.microsoft.com/office/drawing/2014/main" id="{D585EE22-2459-441B-A03A-6B721F7E752A}"/>
               </a:ext>
             </a:extLst>
           </p:cNvPr>
@@ -5678,7 +5678,7 @@
           <p:cNvPr id="5" name="">
             <a:extLst xmlns:a="http://schemas.openxmlformats.org/drawingml/2006/main">
               <a:ext uri="{FF2B5EF4-FFF2-40B4-BE49-F238E27FC236}">
-                <a16:creationId xmlns:a16="http://schemas.microsoft.com/office/drawing/2014/main" id="{71FBBCD4-A1A1-498C-BE88-ECDC9432E55B}"/>
+                <a16:creationId xmlns:a16="http://schemas.microsoft.com/office/drawing/2014/main" id="{9AFE45F6-0A9F-472B-96CE-98F9AFF49F0D}"/>
               </a:ext>
             </a:extLst>
           </p:cNvPr>
@@ -5735,7 +5735,7 @@
           <p:cNvPr id="6" name="">
             <a:extLst xmlns:a="http://schemas.openxmlformats.org/drawingml/2006/main">
               <a:ext uri="{FF2B5EF4-FFF2-40B4-BE49-F238E27FC236}">
-                <a16:creationId xmlns:a16="http://schemas.microsoft.com/office/drawing/2014/main" id="{A8973065-18C0-466B-8716-7FD3158BDE75}"/>
+                <a16:creationId xmlns:a16="http://schemas.microsoft.com/office/drawing/2014/main" id="{9885A76B-57F9-4C05-96AD-F681F1751703}"/>
               </a:ext>
             </a:extLst>
           </p:cNvPr>
@@ -5792,7 +5792,7 @@
           <p:cNvPr id="7" name="">
             <a:extLst xmlns:a="http://schemas.openxmlformats.org/drawingml/2006/main">
               <a:ext uri="{FF2B5EF4-FFF2-40B4-BE49-F238E27FC236}">
-                <a16:creationId xmlns:a16="http://schemas.microsoft.com/office/drawing/2014/main" id="{0335863F-C285-4FE9-B293-8A0B58FCAE90}"/>
+                <a16:creationId xmlns:a16="http://schemas.microsoft.com/office/drawing/2014/main" id="{DA4118D7-FAA8-44CE-9B91-A51F9BFA337F}"/>
               </a:ext>
             </a:extLst>
           </p:cNvPr>
@@ -5824,7 +5824,7 @@
           <p:cNvPr id="8" name="">
             <a:extLst xmlns:a="http://schemas.openxmlformats.org/drawingml/2006/main">
               <a:ext uri="{FF2B5EF4-FFF2-40B4-BE49-F238E27FC236}">
-                <a16:creationId xmlns:a16="http://schemas.microsoft.com/office/drawing/2014/main" id="{C0115009-8734-4572-B26B-8B8D22CD2A91}"/>
+                <a16:creationId xmlns:a16="http://schemas.microsoft.com/office/drawing/2014/main" id="{F990D55A-99BD-43EE-8310-996A21DA3770}"/>
               </a:ext>
             </a:extLst>
           </p:cNvPr>
@@ -5881,7 +5881,7 @@
           <p:cNvPr id="9" name="">
             <a:extLst xmlns:a="http://schemas.openxmlformats.org/drawingml/2006/main">
               <a:ext uri="{FF2B5EF4-FFF2-40B4-BE49-F238E27FC236}">
-                <a16:creationId xmlns:a16="http://schemas.microsoft.com/office/drawing/2014/main" id="{4D080361-60A9-455B-A826-D30FDAD38AF8}"/>
+                <a16:creationId xmlns:a16="http://schemas.microsoft.com/office/drawing/2014/main" id="{61611AF8-F452-41AD-8882-A066972D343B}"/>
               </a:ext>
             </a:extLst>
           </p:cNvPr>
@@ -5938,7 +5938,7 @@
           <p:cNvPr id="10" name="">
             <a:extLst xmlns:a="http://schemas.openxmlformats.org/drawingml/2006/main">
               <a:ext uri="{FF2B5EF4-FFF2-40B4-BE49-F238E27FC236}">
-                <a16:creationId xmlns:a16="http://schemas.microsoft.com/office/drawing/2014/main" id="{6B5326D6-2FBE-448D-949E-CCC0F7B0DF6A}"/>
+                <a16:creationId xmlns:a16="http://schemas.microsoft.com/office/drawing/2014/main" id="{B82412BE-A23A-43B0-9592-4F03A0CA1BF0}"/>
               </a:ext>
             </a:extLst>
           </p:cNvPr>
@@ -5970,7 +5970,7 @@
           <p:cNvPr id="11" name="">
             <a:extLst xmlns:a="http://schemas.openxmlformats.org/drawingml/2006/main">
               <a:ext uri="{FF2B5EF4-FFF2-40B4-BE49-F238E27FC236}">
-                <a16:creationId xmlns:a16="http://schemas.microsoft.com/office/drawing/2014/main" id="{B1A19422-224E-4DE1-A6C8-29BF2CC19626}"/>
+                <a16:creationId xmlns:a16="http://schemas.microsoft.com/office/drawing/2014/main" id="{63A090BA-1879-406A-8D2B-7086527A2E91}"/>
               </a:ext>
             </a:extLst>
           </p:cNvPr>
@@ -6027,7 +6027,7 @@
           <p:cNvPr id="12" name="">
             <a:extLst xmlns:a="http://schemas.openxmlformats.org/drawingml/2006/main">
               <a:ext uri="{FF2B5EF4-FFF2-40B4-BE49-F238E27FC236}">
-                <a16:creationId xmlns:a16="http://schemas.microsoft.com/office/drawing/2014/main" id="{F5D60599-9D8B-48E7-8CD6-5C9E8BEAADA1}"/>
+                <a16:creationId xmlns:a16="http://schemas.microsoft.com/office/drawing/2014/main" id="{05365DE3-8E77-4E24-B2E7-FF4019631BFF}"/>
               </a:ext>
             </a:extLst>
           </p:cNvPr>
@@ -6084,7 +6084,7 @@
           <p:cNvPr id="13" name="">
             <a:extLst xmlns:a="http://schemas.openxmlformats.org/drawingml/2006/main">
               <a:ext uri="{FF2B5EF4-FFF2-40B4-BE49-F238E27FC236}">
-                <a16:creationId xmlns:a16="http://schemas.microsoft.com/office/drawing/2014/main" id="{80384DA3-3CEA-4684-BDFF-AEA8F213E2A3}"/>
+                <a16:creationId xmlns:a16="http://schemas.microsoft.com/office/drawing/2014/main" id="{CBC88740-14F6-4A28-A37D-0441A0EC4735}"/>
               </a:ext>
             </a:extLst>
           </p:cNvPr>
@@ -6116,7 +6116,7 @@
           <p:cNvPr id="14" name="">
             <a:extLst xmlns:a="http://schemas.openxmlformats.org/drawingml/2006/main">
               <a:ext uri="{FF2B5EF4-FFF2-40B4-BE49-F238E27FC236}">
-                <a16:creationId xmlns:a16="http://schemas.microsoft.com/office/drawing/2014/main" id="{F107637F-5EAD-4E3F-8E20-DBD24ED85C0C}"/>
+                <a16:creationId xmlns:a16="http://schemas.microsoft.com/office/drawing/2014/main" id="{C1348FD1-B50B-441D-947F-B164D3A98D44}"/>
               </a:ext>
             </a:extLst>
           </p:cNvPr>
@@ -6173,7 +6173,7 @@
           <p:cNvPr id="15" name="">
             <a:extLst xmlns:a="http://schemas.openxmlformats.org/drawingml/2006/main">
               <a:ext uri="{FF2B5EF4-FFF2-40B4-BE49-F238E27FC236}">
-                <a16:creationId xmlns:a16="http://schemas.microsoft.com/office/drawing/2014/main" id="{019B6F98-1B69-49D1-89C2-639D4E740455}"/>
+                <a16:creationId xmlns:a16="http://schemas.microsoft.com/office/drawing/2014/main" id="{2BFDAD39-5119-4428-8F7C-22F466252D0B}"/>
               </a:ext>
             </a:extLst>
           </p:cNvPr>
@@ -6230,7 +6230,7 @@
           <p:cNvPr id="16" name="">
             <a:extLst xmlns:a="http://schemas.openxmlformats.org/drawingml/2006/main">
               <a:ext uri="{FF2B5EF4-FFF2-40B4-BE49-F238E27FC236}">
-                <a16:creationId xmlns:a16="http://schemas.microsoft.com/office/drawing/2014/main" id="{1AA17FB7-7C61-4BBE-9611-3F12324ACD14}"/>
+                <a16:creationId xmlns:a16="http://schemas.microsoft.com/office/drawing/2014/main" id="{026A2EE4-167A-4F50-B3D4-DC57C7008DC3}"/>
               </a:ext>
             </a:extLst>
           </p:cNvPr>
@@ -6262,7 +6262,7 @@
           <p:cNvPr id="17" name="">
             <a:extLst xmlns:a="http://schemas.openxmlformats.org/drawingml/2006/main">
               <a:ext uri="{FF2B5EF4-FFF2-40B4-BE49-F238E27FC236}">
-                <a16:creationId xmlns:a16="http://schemas.microsoft.com/office/drawing/2014/main" id="{7873D71D-CE4F-43EC-A57D-468F371253EB}"/>
+                <a16:creationId xmlns:a16="http://schemas.microsoft.com/office/drawing/2014/main" id="{EBB072CB-CFBA-43C9-903C-7313D6F5B6E5}"/>
               </a:ext>
             </a:extLst>
           </p:cNvPr>
@@ -6319,7 +6319,7 @@
           <p:cNvPr id="18" name="">
             <a:extLst xmlns:a="http://schemas.openxmlformats.org/drawingml/2006/main">
               <a:ext uri="{FF2B5EF4-FFF2-40B4-BE49-F238E27FC236}">
-                <a16:creationId xmlns:a16="http://schemas.microsoft.com/office/drawing/2014/main" id="{B00020EE-67EF-4FBE-95D6-E476B5AA315D}"/>
+                <a16:creationId xmlns:a16="http://schemas.microsoft.com/office/drawing/2014/main" id="{ED3C8EF8-6380-43A2-A3AD-A06BCC96869D}"/>
               </a:ext>
             </a:extLst>
           </p:cNvPr>
@@ -6376,7 +6376,7 @@
           <p:cNvPr id="19" name="">
             <a:extLst xmlns:a="http://schemas.openxmlformats.org/drawingml/2006/main">
               <a:ext uri="{FF2B5EF4-FFF2-40B4-BE49-F238E27FC236}">
-                <a16:creationId xmlns:a16="http://schemas.microsoft.com/office/drawing/2014/main" id="{3E89040B-41EF-4ECF-864A-12D81012FAD0}"/>
+                <a16:creationId xmlns:a16="http://schemas.microsoft.com/office/drawing/2014/main" id="{0C5946DA-48C4-4A49-A14F-3D6A4876AB8E}"/>
               </a:ext>
             </a:extLst>
           </p:cNvPr>
@@ -6408,7 +6408,7 @@
           <p:cNvPr id="20" name="">
             <a:extLst xmlns:a="http://schemas.openxmlformats.org/drawingml/2006/main">
               <a:ext uri="{FF2B5EF4-FFF2-40B4-BE49-F238E27FC236}">
-                <a16:creationId xmlns:a16="http://schemas.microsoft.com/office/drawing/2014/main" id="{7DF03BAD-8956-4323-992B-D854D9353E9B}"/>
+                <a16:creationId xmlns:a16="http://schemas.microsoft.com/office/drawing/2014/main" id="{2EAE94C2-14A4-44FA-B603-D5E91A1CC76B}"/>
               </a:ext>
             </a:extLst>
           </p:cNvPr>
@@ -6465,7 +6465,7 @@
           <p:cNvPr id="21" name="">
             <a:extLst xmlns:a="http://schemas.openxmlformats.org/drawingml/2006/main">
               <a:ext uri="{FF2B5EF4-FFF2-40B4-BE49-F238E27FC236}">
-                <a16:creationId xmlns:a16="http://schemas.microsoft.com/office/drawing/2014/main" id="{80D37307-3EEE-4EAC-91F5-D6958A25EF78}"/>
+                <a16:creationId xmlns:a16="http://schemas.microsoft.com/office/drawing/2014/main" id="{CE88A5B4-5EF9-4F7F-AA3E-5A1A239207D0}"/>
               </a:ext>
             </a:extLst>
           </p:cNvPr>
@@ -6522,7 +6522,7 @@
           <p:cNvPr id="22" name="">
             <a:extLst xmlns:a="http://schemas.openxmlformats.org/drawingml/2006/main">
               <a:ext uri="{FF2B5EF4-FFF2-40B4-BE49-F238E27FC236}">
-                <a16:creationId xmlns:a16="http://schemas.microsoft.com/office/drawing/2014/main" id="{7F724896-E50F-4C1E-A6DF-CA600D62437D}"/>
+                <a16:creationId xmlns:a16="http://schemas.microsoft.com/office/drawing/2014/main" id="{0735126C-0D8B-4945-9137-7F862E168804}"/>
               </a:ext>
             </a:extLst>
           </p:cNvPr>
@@ -6577,7 +6577,7 @@
     </p:spTree>
     <p:extLst>
       <p:ext uri="{BB962C8B-B14F-4D97-AF65-F5344CB8AC3E}">
-        <p14:creationId xmlns:p14="http://schemas.microsoft.com/office/powerpoint/2010/main" val="632877822"/>
+        <p14:creationId xmlns:p14="http://schemas.microsoft.com/office/powerpoint/2010/main" val="275460005"/>
       </p:ext>
     </p:extLst>
   </p:cSld>
@@ -6608,7 +6608,7 @@
           <p:cNvPr id="15" name="">
             <a:extLst xmlns:a="http://schemas.openxmlformats.org/drawingml/2006/main">
               <a:ext uri="{FF2B5EF4-FFF2-40B4-BE49-F238E27FC236}">
-                <a16:creationId xmlns:a16="http://schemas.microsoft.com/office/drawing/2014/main" id="{AC0E6575-FA01-44CC-BCB4-1234A922A709}"/>
+                <a16:creationId xmlns:a16="http://schemas.microsoft.com/office/drawing/2014/main" id="{C93ED4A0-6F42-48E3-B987-486A35B7B3C3}"/>
               </a:ext>
             </a:extLst>
           </p:cNvPr>
@@ -6665,7 +6665,7 @@
           <p:cNvPr id="2" name="">
             <a:extLst xmlns:a="http://schemas.openxmlformats.org/drawingml/2006/main">
               <a:ext uri="{FF2B5EF4-FFF2-40B4-BE49-F238E27FC236}">
-                <a16:creationId xmlns:a16="http://schemas.microsoft.com/office/drawing/2014/main" id="{F03314F6-CA2B-4BD5-B809-B32B202212C8}"/>
+                <a16:creationId xmlns:a16="http://schemas.microsoft.com/office/drawing/2014/main" id="{33F08128-4438-4606-B273-1256DBC962BF}"/>
               </a:ext>
             </a:extLst>
           </p:cNvPr>
@@ -6722,7 +6722,7 @@
           <p:cNvPr id="3" name="">
             <a:extLst xmlns:a="http://schemas.openxmlformats.org/drawingml/2006/main">
               <a:ext uri="{FF2B5EF4-FFF2-40B4-BE49-F238E27FC236}">
-                <a16:creationId xmlns:a16="http://schemas.microsoft.com/office/drawing/2014/main" id="{83FE5B84-D4F8-4F10-9D97-A254462A2F5E}"/>
+                <a16:creationId xmlns:a16="http://schemas.microsoft.com/office/drawing/2014/main" id="{4D78100F-A5B3-442A-AF08-0A712BE77055}"/>
               </a:ext>
             </a:extLst>
           </p:cNvPr>
@@ -6779,7 +6779,7 @@
           <p:cNvPr id="4" name="">
             <a:extLst xmlns:a="http://schemas.openxmlformats.org/drawingml/2006/main">
               <a:ext uri="{FF2B5EF4-FFF2-40B4-BE49-F238E27FC236}">
-                <a16:creationId xmlns:a16="http://schemas.microsoft.com/office/drawing/2014/main" id="{86D04B33-BF45-46E2-A512-D0F5FCD55BD7}"/>
+                <a16:creationId xmlns:a16="http://schemas.microsoft.com/office/drawing/2014/main" id="{3F1CB79C-F568-444C-95BE-178CD9B6B1B8}"/>
               </a:ext>
             </a:extLst>
           </p:cNvPr>
@@ -6836,7 +6836,7 @@
           <p:cNvPr id="5" name="">
             <a:extLst xmlns:a="http://schemas.openxmlformats.org/drawingml/2006/main">
               <a:ext uri="{FF2B5EF4-FFF2-40B4-BE49-F238E27FC236}">
-                <a16:creationId xmlns:a16="http://schemas.microsoft.com/office/drawing/2014/main" id="{A9285422-831E-408E-A1D8-6F70B8E4EEE8}"/>
+                <a16:creationId xmlns:a16="http://schemas.microsoft.com/office/drawing/2014/main" id="{84B73BA6-956D-4CFB-AC48-9ECEC2F2B51D}"/>
               </a:ext>
             </a:extLst>
           </p:cNvPr>
@@ -6868,7 +6868,7 @@
           <p:cNvPr id="6" name="">
             <a:extLst xmlns:a="http://schemas.openxmlformats.org/drawingml/2006/main">
               <a:ext uri="{FF2B5EF4-FFF2-40B4-BE49-F238E27FC236}">
-                <a16:creationId xmlns:a16="http://schemas.microsoft.com/office/drawing/2014/main" id="{F32995D6-0AF1-40DB-9C98-C36790750755}"/>
+                <a16:creationId xmlns:a16="http://schemas.microsoft.com/office/drawing/2014/main" id="{A7327B6C-9CE1-4F78-8F5E-A58BD60487EB}"/>
               </a:ext>
             </a:extLst>
           </p:cNvPr>
@@ -6925,7 +6925,7 @@
           <p:cNvPr id="7" name="">
             <a:extLst xmlns:a="http://schemas.openxmlformats.org/drawingml/2006/main">
               <a:ext uri="{FF2B5EF4-FFF2-40B4-BE49-F238E27FC236}">
-                <a16:creationId xmlns:a16="http://schemas.microsoft.com/office/drawing/2014/main" id="{71997D10-3A98-4AE5-8155-AED7BD391833}"/>
+                <a16:creationId xmlns:a16="http://schemas.microsoft.com/office/drawing/2014/main" id="{16662DD5-7028-49B6-AA64-F8E05727B59C}"/>
               </a:ext>
             </a:extLst>
           </p:cNvPr>
@@ -6957,7 +6957,7 @@
           <p:cNvPr id="8" name="">
             <a:extLst xmlns:a="http://schemas.openxmlformats.org/drawingml/2006/main">
               <a:ext uri="{FF2B5EF4-FFF2-40B4-BE49-F238E27FC236}">
-                <a16:creationId xmlns:a16="http://schemas.microsoft.com/office/drawing/2014/main" id="{31A5616E-61B4-4126-9A8E-BD26D8A9DDCE}"/>
+                <a16:creationId xmlns:a16="http://schemas.microsoft.com/office/drawing/2014/main" id="{90DB9AC8-A6A5-4AAF-BD1D-21F8DE22D987}"/>
               </a:ext>
             </a:extLst>
           </p:cNvPr>
@@ -7014,7 +7014,7 @@
           <p:cNvPr id="9" name="">
             <a:extLst xmlns:a="http://schemas.openxmlformats.org/drawingml/2006/main">
               <a:ext uri="{FF2B5EF4-FFF2-40B4-BE49-F238E27FC236}">
-                <a16:creationId xmlns:a16="http://schemas.microsoft.com/office/drawing/2014/main" id="{3426CD55-A6F0-416E-857D-443706E8175D}"/>
+                <a16:creationId xmlns:a16="http://schemas.microsoft.com/office/drawing/2014/main" id="{DA6D0AE9-F719-48AF-B9EC-08E9EED77F46}"/>
               </a:ext>
             </a:extLst>
           </p:cNvPr>
@@ -7046,7 +7046,7 @@
           <p:cNvPr id="10" name="">
             <a:extLst xmlns:a="http://schemas.openxmlformats.org/drawingml/2006/main">
               <a:ext uri="{FF2B5EF4-FFF2-40B4-BE49-F238E27FC236}">
-                <a16:creationId xmlns:a16="http://schemas.microsoft.com/office/drawing/2014/main" id="{DBF90823-74E1-4D87-8B52-BD674CD71C60}"/>
+                <a16:creationId xmlns:a16="http://schemas.microsoft.com/office/drawing/2014/main" id="{00648916-C153-4D54-B779-5392BE45F5A4}"/>
               </a:ext>
             </a:extLst>
           </p:cNvPr>
@@ -7103,7 +7103,7 @@
           <p:cNvPr id="11" name="">
             <a:extLst xmlns:a="http://schemas.openxmlformats.org/drawingml/2006/main">
               <a:ext uri="{FF2B5EF4-FFF2-40B4-BE49-F238E27FC236}">
-                <a16:creationId xmlns:a16="http://schemas.microsoft.com/office/drawing/2014/main" id="{361E52BA-FD5D-4919-A72A-2965FAD95061}"/>
+                <a16:creationId xmlns:a16="http://schemas.microsoft.com/office/drawing/2014/main" id="{0725F68C-2876-48AA-AF3B-778E6D4FF37F}"/>
               </a:ext>
             </a:extLst>
           </p:cNvPr>
@@ -7135,7 +7135,7 @@
           <p:cNvPr id="12" name="">
             <a:extLst xmlns:a="http://schemas.openxmlformats.org/drawingml/2006/main">
               <a:ext uri="{FF2B5EF4-FFF2-40B4-BE49-F238E27FC236}">
-                <a16:creationId xmlns:a16="http://schemas.microsoft.com/office/drawing/2014/main" id="{A68FF7FB-057F-4322-9984-112E4FA2DA4A}"/>
+                <a16:creationId xmlns:a16="http://schemas.microsoft.com/office/drawing/2014/main" id="{57D9740D-7CC3-4BBD-AB06-F5F66342E4DD}"/>
               </a:ext>
             </a:extLst>
           </p:cNvPr>
@@ -7192,7 +7192,7 @@
           <p:cNvPr id="13" name="">
             <a:extLst xmlns:a="http://schemas.openxmlformats.org/drawingml/2006/main">
               <a:ext uri="{FF2B5EF4-FFF2-40B4-BE49-F238E27FC236}">
-                <a16:creationId xmlns:a16="http://schemas.microsoft.com/office/drawing/2014/main" id="{53DD218B-1270-41C7-8477-D294B61D0F1B}"/>
+                <a16:creationId xmlns:a16="http://schemas.microsoft.com/office/drawing/2014/main" id="{63A81896-A55E-4535-AEFC-AECF973989EE}"/>
               </a:ext>
             </a:extLst>
           </p:cNvPr>
@@ -7224,7 +7224,7 @@
           <p:cNvPr id="14" name="">
             <a:extLst xmlns:a="http://schemas.openxmlformats.org/drawingml/2006/main">
               <a:ext uri="{FF2B5EF4-FFF2-40B4-BE49-F238E27FC236}">
-                <a16:creationId xmlns:a16="http://schemas.microsoft.com/office/drawing/2014/main" id="{0F998C62-5482-4402-820B-DCB2D64E3E5A}"/>
+                <a16:creationId xmlns:a16="http://schemas.microsoft.com/office/drawing/2014/main" id="{F09BDF7E-DE05-40FA-BC13-B4F83BEDD89E}"/>
               </a:ext>
             </a:extLst>
           </p:cNvPr>
@@ -7279,7 +7279,7 @@
     </p:spTree>
     <p:extLst>
       <p:ext uri="{BB962C8B-B14F-4D97-AF65-F5344CB8AC3E}">
-        <p14:creationId xmlns:p14="http://schemas.microsoft.com/office/powerpoint/2010/main" val="1303776773"/>
+        <p14:creationId xmlns:p14="http://schemas.microsoft.com/office/powerpoint/2010/main" val="1723267185"/>
       </p:ext>
     </p:extLst>
   </p:cSld>
@@ -7310,7 +7310,7 @@
           <p:cNvPr id="14" name="">
             <a:extLst xmlns:a="http://schemas.openxmlformats.org/drawingml/2006/main">
               <a:ext uri="{FF2B5EF4-FFF2-40B4-BE49-F238E27FC236}">
-                <a16:creationId xmlns:a16="http://schemas.microsoft.com/office/drawing/2014/main" id="{7805A3E7-1269-495E-AF6B-C5F67B31AF0B}"/>
+                <a16:creationId xmlns:a16="http://schemas.microsoft.com/office/drawing/2014/main" id="{DD09F5F7-121A-488B-8344-D1C95FB59196}"/>
               </a:ext>
             </a:extLst>
           </p:cNvPr>
@@ -7367,7 +7367,7 @@
           <p:cNvPr id="2" name="">
             <a:extLst xmlns:a="http://schemas.openxmlformats.org/drawingml/2006/main">
               <a:ext uri="{FF2B5EF4-FFF2-40B4-BE49-F238E27FC236}">
-                <a16:creationId xmlns:a16="http://schemas.microsoft.com/office/drawing/2014/main" id="{CEA11D15-4D4B-4CC2-95F0-368A4EF4814C}"/>
+                <a16:creationId xmlns:a16="http://schemas.microsoft.com/office/drawing/2014/main" id="{CAF3FB82-5986-493D-8506-DF6EB147D759}"/>
               </a:ext>
             </a:extLst>
           </p:cNvPr>
@@ -7424,7 +7424,7 @@
           <p:cNvPr id="3" name="">
             <a:extLst xmlns:a="http://schemas.openxmlformats.org/drawingml/2006/main">
               <a:ext uri="{FF2B5EF4-FFF2-40B4-BE49-F238E27FC236}">
-                <a16:creationId xmlns:a16="http://schemas.microsoft.com/office/drawing/2014/main" id="{DB1D882D-B23B-418D-88E9-2547E2E10EAF}"/>
+                <a16:creationId xmlns:a16="http://schemas.microsoft.com/office/drawing/2014/main" id="{DCDA214C-CEF4-44C3-AD9A-8FC42F603DA9}"/>
               </a:ext>
             </a:extLst>
           </p:cNvPr>
@@ -7481,7 +7481,7 @@
           <p:cNvPr id="4" name="">
             <a:extLst xmlns:a="http://schemas.openxmlformats.org/drawingml/2006/main">
               <a:ext uri="{FF2B5EF4-FFF2-40B4-BE49-F238E27FC236}">
-                <a16:creationId xmlns:a16="http://schemas.microsoft.com/office/drawing/2014/main" id="{0F8C71FC-8322-463A-B0C0-AE7C88516A53}"/>
+                <a16:creationId xmlns:a16="http://schemas.microsoft.com/office/drawing/2014/main" id="{C0F3A5CC-6CA3-46BC-A605-930C72239635}"/>
               </a:ext>
             </a:extLst>
           </p:cNvPr>
@@ -7513,7 +7513,7 @@
           <p:cNvPr id="5" name="">
             <a:extLst xmlns:a="http://schemas.openxmlformats.org/drawingml/2006/main">
               <a:ext uri="{FF2B5EF4-FFF2-40B4-BE49-F238E27FC236}">
-                <a16:creationId xmlns:a16="http://schemas.microsoft.com/office/drawing/2014/main" id="{D10012A1-353D-44B6-9211-53FDECCC1313}"/>
+                <a16:creationId xmlns:a16="http://schemas.microsoft.com/office/drawing/2014/main" id="{320A5EE2-8509-4B7D-8EDB-4D85197B7F85}"/>
               </a:ext>
             </a:extLst>
           </p:cNvPr>
@@ -7570,7 +7570,7 @@
           <p:cNvPr id="6" name="">
             <a:extLst xmlns:a="http://schemas.openxmlformats.org/drawingml/2006/main">
               <a:ext uri="{FF2B5EF4-FFF2-40B4-BE49-F238E27FC236}">
-                <a16:creationId xmlns:a16="http://schemas.microsoft.com/office/drawing/2014/main" id="{49FAC4A8-88D8-4351-A9EF-7470431E1845}"/>
+                <a16:creationId xmlns:a16="http://schemas.microsoft.com/office/drawing/2014/main" id="{97CEB32C-F92A-4482-B53C-2FCB27DD02A8}"/>
               </a:ext>
             </a:extLst>
           </p:cNvPr>
@@ -7627,7 +7627,7 @@
           <p:cNvPr id="7" name="">
             <a:extLst xmlns:a="http://schemas.openxmlformats.org/drawingml/2006/main">
               <a:ext uri="{FF2B5EF4-FFF2-40B4-BE49-F238E27FC236}">
-                <a16:creationId xmlns:a16="http://schemas.microsoft.com/office/drawing/2014/main" id="{554FFC6E-CB42-480D-BF4F-C62D08D0F703}"/>
+                <a16:creationId xmlns:a16="http://schemas.microsoft.com/office/drawing/2014/main" id="{A6EDA4F8-456B-4CB8-A082-B0F8E18465A4}"/>
               </a:ext>
             </a:extLst>
           </p:cNvPr>
@@ -7659,7 +7659,7 @@
           <p:cNvPr id="8" name="">
             <a:extLst xmlns:a="http://schemas.openxmlformats.org/drawingml/2006/main">
               <a:ext uri="{FF2B5EF4-FFF2-40B4-BE49-F238E27FC236}">
-                <a16:creationId xmlns:a16="http://schemas.microsoft.com/office/drawing/2014/main" id="{48CD0E0E-7F96-4CB7-A61E-031B2418EFC3}"/>
+                <a16:creationId xmlns:a16="http://schemas.microsoft.com/office/drawing/2014/main" id="{114493D4-F174-474C-B3FA-DE4F403D01E8}"/>
               </a:ext>
             </a:extLst>
           </p:cNvPr>
@@ -7716,7 +7716,7 @@
           <p:cNvPr id="9" name="">
             <a:extLst xmlns:a="http://schemas.openxmlformats.org/drawingml/2006/main">
               <a:ext uri="{FF2B5EF4-FFF2-40B4-BE49-F238E27FC236}">
-                <a16:creationId xmlns:a16="http://schemas.microsoft.com/office/drawing/2014/main" id="{3CACC48E-2D57-404E-B494-B16F4DE79FB9}"/>
+                <a16:creationId xmlns:a16="http://schemas.microsoft.com/office/drawing/2014/main" id="{B59BEAE8-19FC-4E58-8528-EDDCCBCA7F5C}"/>
               </a:ext>
             </a:extLst>
           </p:cNvPr>
@@ -7773,7 +7773,7 @@
           <p:cNvPr id="10" name="">
             <a:extLst xmlns:a="http://schemas.openxmlformats.org/drawingml/2006/main">
               <a:ext uri="{FF2B5EF4-FFF2-40B4-BE49-F238E27FC236}">
-                <a16:creationId xmlns:a16="http://schemas.microsoft.com/office/drawing/2014/main" id="{16D3EAAA-91E6-414F-9724-E54B7970FE9B}"/>
+                <a16:creationId xmlns:a16="http://schemas.microsoft.com/office/drawing/2014/main" id="{95540F86-0666-4A16-B66F-F87454987D35}"/>
               </a:ext>
             </a:extLst>
           </p:cNvPr>
@@ -7805,7 +7805,7 @@
           <p:cNvPr id="11" name="">
             <a:extLst xmlns:a="http://schemas.openxmlformats.org/drawingml/2006/main">
               <a:ext uri="{FF2B5EF4-FFF2-40B4-BE49-F238E27FC236}">
-                <a16:creationId xmlns:a16="http://schemas.microsoft.com/office/drawing/2014/main" id="{F3AA550D-19A0-4438-B0C6-22794BDC5C19}"/>
+                <a16:creationId xmlns:a16="http://schemas.microsoft.com/office/drawing/2014/main" id="{5B5C5CF1-E35B-4786-8F0A-393B32A845A6}"/>
               </a:ext>
             </a:extLst>
           </p:cNvPr>
@@ -7862,7 +7862,7 @@
           <p:cNvPr id="12" name="">
             <a:extLst xmlns:a="http://schemas.openxmlformats.org/drawingml/2006/main">
               <a:ext uri="{FF2B5EF4-FFF2-40B4-BE49-F238E27FC236}">
-                <a16:creationId xmlns:a16="http://schemas.microsoft.com/office/drawing/2014/main" id="{66D84102-89A2-4E8A-B535-050E53C0FDD7}"/>
+                <a16:creationId xmlns:a16="http://schemas.microsoft.com/office/drawing/2014/main" id="{4663E623-692E-4941-8ED9-2866319084A7}"/>
               </a:ext>
             </a:extLst>
           </p:cNvPr>
@@ -7919,7 +7919,7 @@
           <p:cNvPr id="13" name="">
             <a:extLst xmlns:a="http://schemas.openxmlformats.org/drawingml/2006/main">
               <a:ext uri="{FF2B5EF4-FFF2-40B4-BE49-F238E27FC236}">
-                <a16:creationId xmlns:a16="http://schemas.microsoft.com/office/drawing/2014/main" id="{B8B5DE8B-5D3F-44F3-91EC-1FE0484593A0}"/>
+                <a16:creationId xmlns:a16="http://schemas.microsoft.com/office/drawing/2014/main" id="{D89A624D-6CA4-43E3-A704-D31EE0EEB379}"/>
               </a:ext>
             </a:extLst>
           </p:cNvPr>
@@ -7974,7 +7974,7 @@
     </p:spTree>
     <p:extLst>
       <p:ext uri="{BB962C8B-B14F-4D97-AF65-F5344CB8AC3E}">
-        <p14:creationId xmlns:p14="http://schemas.microsoft.com/office/powerpoint/2010/main" val="1105788755"/>
+        <p14:creationId xmlns:p14="http://schemas.microsoft.com/office/powerpoint/2010/main" val="906290817"/>
       </p:ext>
     </p:extLst>
   </p:cSld>
@@ -8005,7 +8005,7 @@
           <p:cNvPr id="21" name="">
             <a:extLst xmlns:a="http://schemas.openxmlformats.org/drawingml/2006/main">
               <a:ext uri="{FF2B5EF4-FFF2-40B4-BE49-F238E27FC236}">
-                <a16:creationId xmlns:a16="http://schemas.microsoft.com/office/drawing/2014/main" id="{9D12BF60-5855-49D7-9835-3973B7122B1C}"/>
+                <a16:creationId xmlns:a16="http://schemas.microsoft.com/office/drawing/2014/main" id="{DC6BF16A-486B-4462-8270-A012FACB7DD4}"/>
               </a:ext>
             </a:extLst>
           </p:cNvPr>
@@ -8062,7 +8062,7 @@
           <p:cNvPr id="2" name="">
             <a:extLst xmlns:a="http://schemas.openxmlformats.org/drawingml/2006/main">
               <a:ext uri="{FF2B5EF4-FFF2-40B4-BE49-F238E27FC236}">
-                <a16:creationId xmlns:a16="http://schemas.microsoft.com/office/drawing/2014/main" id="{E3F7CB59-E537-4F0D-B30F-8C1AC11FD3BA}"/>
+                <a16:creationId xmlns:a16="http://schemas.microsoft.com/office/drawing/2014/main" id="{C1CAD5EC-B2EB-4440-B2EE-B06A393C2132}"/>
               </a:ext>
             </a:extLst>
           </p:cNvPr>
@@ -8119,7 +8119,7 @@
           <p:cNvPr id="3" name="">
             <a:extLst xmlns:a="http://schemas.openxmlformats.org/drawingml/2006/main">
               <a:ext uri="{FF2B5EF4-FFF2-40B4-BE49-F238E27FC236}">
-                <a16:creationId xmlns:a16="http://schemas.microsoft.com/office/drawing/2014/main" id="{4F532CD1-0606-45A7-A228-5AE1423F0939}"/>
+                <a16:creationId xmlns:a16="http://schemas.microsoft.com/office/drawing/2014/main" id="{38CFE49D-DCD1-430F-AC55-C5EA664E97CA}"/>
               </a:ext>
             </a:extLst>
           </p:cNvPr>
@@ -8176,7 +8176,7 @@
           <p:cNvPr id="4" name="">
             <a:extLst xmlns:a="http://schemas.openxmlformats.org/drawingml/2006/main">
               <a:ext uri="{FF2B5EF4-FFF2-40B4-BE49-F238E27FC236}">
-                <a16:creationId xmlns:a16="http://schemas.microsoft.com/office/drawing/2014/main" id="{8849B3B5-DC1F-4EB8-81AD-3C9C665C10F1}"/>
+                <a16:creationId xmlns:a16="http://schemas.microsoft.com/office/drawing/2014/main" id="{3048750D-8633-4C25-8094-084684BC2878}"/>
               </a:ext>
             </a:extLst>
           </p:cNvPr>
@@ -8208,7 +8208,7 @@
           <p:cNvPr id="5" name="">
             <a:extLst xmlns:a="http://schemas.openxmlformats.org/drawingml/2006/main">
               <a:ext uri="{FF2B5EF4-FFF2-40B4-BE49-F238E27FC236}">
-                <a16:creationId xmlns:a16="http://schemas.microsoft.com/office/drawing/2014/main" id="{8753A238-45AF-40AB-88D9-E8CADF8725FE}"/>
+                <a16:creationId xmlns:a16="http://schemas.microsoft.com/office/drawing/2014/main" id="{4F27475B-9DD4-40E7-ADB8-84FF89012DF2}"/>
               </a:ext>
             </a:extLst>
           </p:cNvPr>
@@ -8265,7 +8265,7 @@
           <p:cNvPr id="6" name="">
             <a:extLst xmlns:a="http://schemas.openxmlformats.org/drawingml/2006/main">
               <a:ext uri="{FF2B5EF4-FFF2-40B4-BE49-F238E27FC236}">
-                <a16:creationId xmlns:a16="http://schemas.microsoft.com/office/drawing/2014/main" id="{46BF8951-163D-46E7-B4FE-70AFEBC6C248}"/>
+                <a16:creationId xmlns:a16="http://schemas.microsoft.com/office/drawing/2014/main" id="{62C83AA3-7658-431C-87EC-43AAD8255CBB}"/>
               </a:ext>
             </a:extLst>
           </p:cNvPr>
@@ -8297,7 +8297,7 @@
           <p:cNvPr id="7" name="">
             <a:extLst xmlns:a="http://schemas.openxmlformats.org/drawingml/2006/main">
               <a:ext uri="{FF2B5EF4-FFF2-40B4-BE49-F238E27FC236}">
-                <a16:creationId xmlns:a16="http://schemas.microsoft.com/office/drawing/2014/main" id="{BFB91F75-C885-4D1B-9E50-BBC820B74F45}"/>
+                <a16:creationId xmlns:a16="http://schemas.microsoft.com/office/drawing/2014/main" id="{1F9E1A3A-53B2-4DB6-8D38-909D142F6A0B}"/>
               </a:ext>
             </a:extLst>
           </p:cNvPr>
@@ -8354,7 +8354,7 @@
           <p:cNvPr id="8" name="">
             <a:extLst xmlns:a="http://schemas.openxmlformats.org/drawingml/2006/main">
               <a:ext uri="{FF2B5EF4-FFF2-40B4-BE49-F238E27FC236}">
-                <a16:creationId xmlns:a16="http://schemas.microsoft.com/office/drawing/2014/main" id="{EC406688-DBC3-4675-A18D-6B8F636B17EF}"/>
+                <a16:creationId xmlns:a16="http://schemas.microsoft.com/office/drawing/2014/main" id="{FF827EB3-D248-4FD3-85EC-8D1EAE394D77}"/>
               </a:ext>
             </a:extLst>
           </p:cNvPr>
@@ -8386,7 +8386,7 @@
           <p:cNvPr id="9" name="">
             <a:extLst xmlns:a="http://schemas.openxmlformats.org/drawingml/2006/main">
               <a:ext uri="{FF2B5EF4-FFF2-40B4-BE49-F238E27FC236}">
-                <a16:creationId xmlns:a16="http://schemas.microsoft.com/office/drawing/2014/main" id="{C7291689-C857-4FB4-8465-B621FF3284E8}"/>
+                <a16:creationId xmlns:a16="http://schemas.microsoft.com/office/drawing/2014/main" id="{A3634C4B-4A08-4DA8-82A5-738E81FBF57C}"/>
               </a:ext>
             </a:extLst>
           </p:cNvPr>
@@ -8443,7 +8443,7 @@
           <p:cNvPr id="10" name="">
             <a:extLst xmlns:a="http://schemas.openxmlformats.org/drawingml/2006/main">
               <a:ext uri="{FF2B5EF4-FFF2-40B4-BE49-F238E27FC236}">
-                <a16:creationId xmlns:a16="http://schemas.microsoft.com/office/drawing/2014/main" id="{D898A45E-C571-4571-8E29-0D90967F767F}"/>
+                <a16:creationId xmlns:a16="http://schemas.microsoft.com/office/drawing/2014/main" id="{C0F70491-3507-42B9-9FA8-FE4661C6180D}"/>
               </a:ext>
             </a:extLst>
           </p:cNvPr>
@@ -8475,7 +8475,7 @@
           <p:cNvPr id="11" name="">
             <a:extLst xmlns:a="http://schemas.openxmlformats.org/drawingml/2006/main">
               <a:ext uri="{FF2B5EF4-FFF2-40B4-BE49-F238E27FC236}">
-                <a16:creationId xmlns:a16="http://schemas.microsoft.com/office/drawing/2014/main" id="{6EF914D2-2F5F-4C71-98B4-1E6363881B77}"/>
+                <a16:creationId xmlns:a16="http://schemas.microsoft.com/office/drawing/2014/main" id="{A971DDF5-282C-4BFA-85D2-1D3CA53C15CD}"/>
               </a:ext>
             </a:extLst>
           </p:cNvPr>
@@ -8532,7 +8532,7 @@
           <p:cNvPr id="12" name="">
             <a:extLst xmlns:a="http://schemas.openxmlformats.org/drawingml/2006/main">
               <a:ext uri="{FF2B5EF4-FFF2-40B4-BE49-F238E27FC236}">
-                <a16:creationId xmlns:a16="http://schemas.microsoft.com/office/drawing/2014/main" id="{98A74CEC-538D-4344-A7E4-BA4ACA497834}"/>
+                <a16:creationId xmlns:a16="http://schemas.microsoft.com/office/drawing/2014/main" id="{FABB0C18-A05C-4932-8A0E-054D4E228653}"/>
               </a:ext>
             </a:extLst>
           </p:cNvPr>
@@ -8564,7 +8564,7 @@
           <p:cNvPr id="13" name="">
             <a:extLst xmlns:a="http://schemas.openxmlformats.org/drawingml/2006/main">
               <a:ext uri="{FF2B5EF4-FFF2-40B4-BE49-F238E27FC236}">
-                <a16:creationId xmlns:a16="http://schemas.microsoft.com/office/drawing/2014/main" id="{ABAF8A89-715A-42AB-8DC6-40D5F947D669}"/>
+                <a16:creationId xmlns:a16="http://schemas.microsoft.com/office/drawing/2014/main" id="{B57BEADA-D0EE-4491-90E3-CD844A1D3E9F}"/>
               </a:ext>
             </a:extLst>
           </p:cNvPr>
@@ -8621,7 +8621,7 @@
           <p:cNvPr id="14" name="">
             <a:extLst xmlns:a="http://schemas.openxmlformats.org/drawingml/2006/main">
               <a:ext uri="{FF2B5EF4-FFF2-40B4-BE49-F238E27FC236}">
-                <a16:creationId xmlns:a16="http://schemas.microsoft.com/office/drawing/2014/main" id="{923837DF-06BA-448E-ADB5-AE059122292E}"/>
+                <a16:creationId xmlns:a16="http://schemas.microsoft.com/office/drawing/2014/main" id="{450780DA-94D8-4BA5-8CF7-A3C06B382E6A}"/>
               </a:ext>
             </a:extLst>
           </p:cNvPr>
@@ -8653,7 +8653,7 @@
           <p:cNvPr id="15" name="">
             <a:extLst xmlns:a="http://schemas.openxmlformats.org/drawingml/2006/main">
               <a:ext uri="{FF2B5EF4-FFF2-40B4-BE49-F238E27FC236}">
-                <a16:creationId xmlns:a16="http://schemas.microsoft.com/office/drawing/2014/main" id="{BA7500AF-FA10-46D0-9A6E-40B8DE6081FD}"/>
+                <a16:creationId xmlns:a16="http://schemas.microsoft.com/office/drawing/2014/main" id="{A7B99C6E-9DCB-4A3D-9548-C7225ED410C0}"/>
               </a:ext>
             </a:extLst>
           </p:cNvPr>
@@ -8710,7 +8710,7 @@
           <p:cNvPr id="16" name="">
             <a:extLst xmlns:a="http://schemas.openxmlformats.org/drawingml/2006/main">
               <a:ext uri="{FF2B5EF4-FFF2-40B4-BE49-F238E27FC236}">
-                <a16:creationId xmlns:a16="http://schemas.microsoft.com/office/drawing/2014/main" id="{888C2F81-6C20-4CC0-AFD6-38C7E73C381D}"/>
+                <a16:creationId xmlns:a16="http://schemas.microsoft.com/office/drawing/2014/main" id="{E3BEE0D3-C8DA-45B3-8C46-8D55607EB6BE}"/>
               </a:ext>
             </a:extLst>
           </p:cNvPr>
@@ -8742,7 +8742,7 @@
           <p:cNvPr id="17" name="">
             <a:extLst xmlns:a="http://schemas.openxmlformats.org/drawingml/2006/main">
               <a:ext uri="{FF2B5EF4-FFF2-40B4-BE49-F238E27FC236}">
-                <a16:creationId xmlns:a16="http://schemas.microsoft.com/office/drawing/2014/main" id="{A29A3C95-4C6C-42DE-809E-FC9231CB158D}"/>
+                <a16:creationId xmlns:a16="http://schemas.microsoft.com/office/drawing/2014/main" id="{635A85E3-7134-473B-A652-EDF07DF3EF05}"/>
               </a:ext>
             </a:extLst>
           </p:cNvPr>
@@ -8799,7 +8799,7 @@
           <p:cNvPr id="18" name="">
             <a:extLst xmlns:a="http://schemas.openxmlformats.org/drawingml/2006/main">
               <a:ext uri="{FF2B5EF4-FFF2-40B4-BE49-F238E27FC236}">
-                <a16:creationId xmlns:a16="http://schemas.microsoft.com/office/drawing/2014/main" id="{271AE4D3-F355-4D75-9AB4-A8E291298481}"/>
+                <a16:creationId xmlns:a16="http://schemas.microsoft.com/office/drawing/2014/main" id="{765FB0FD-1E6D-4081-B5F0-6889DA61E02B}"/>
               </a:ext>
             </a:extLst>
           </p:cNvPr>
@@ -8831,7 +8831,7 @@
           <p:cNvPr id="19" name="">
             <a:extLst xmlns:a="http://schemas.openxmlformats.org/drawingml/2006/main">
               <a:ext uri="{FF2B5EF4-FFF2-40B4-BE49-F238E27FC236}">
-                <a16:creationId xmlns:a16="http://schemas.microsoft.com/office/drawing/2014/main" id="{9191E604-339A-42E9-B957-310B7436C816}"/>
+                <a16:creationId xmlns:a16="http://schemas.microsoft.com/office/drawing/2014/main" id="{53646DBB-C2E8-48E6-A5AF-699B562B41CC}"/>
               </a:ext>
             </a:extLst>
           </p:cNvPr>
@@ -8888,7 +8888,7 @@
           <p:cNvPr id="20" name="">
             <a:extLst xmlns:a="http://schemas.openxmlformats.org/drawingml/2006/main">
               <a:ext uri="{FF2B5EF4-FFF2-40B4-BE49-F238E27FC236}">
-                <a16:creationId xmlns:a16="http://schemas.microsoft.com/office/drawing/2014/main" id="{1D67BE05-4235-47AF-B4D2-BE42623F4F26}"/>
+                <a16:creationId xmlns:a16="http://schemas.microsoft.com/office/drawing/2014/main" id="{B19F0043-6020-401B-9826-6F9B58746B3C}"/>
               </a:ext>
             </a:extLst>
           </p:cNvPr>
@@ -8943,7 +8943,7 @@
     </p:spTree>
     <p:extLst>
       <p:ext uri="{BB962C8B-B14F-4D97-AF65-F5344CB8AC3E}">
-        <p14:creationId xmlns:p14="http://schemas.microsoft.com/office/powerpoint/2010/main" val="196426511"/>
+        <p14:creationId xmlns:p14="http://schemas.microsoft.com/office/powerpoint/2010/main" val="1365720579"/>
       </p:ext>
     </p:extLst>
   </p:cSld>
@@ -8974,7 +8974,7 @@
           <p:cNvPr id="11" name="">
             <a:extLst xmlns:a="http://schemas.openxmlformats.org/drawingml/2006/main">
               <a:ext uri="{FF2B5EF4-FFF2-40B4-BE49-F238E27FC236}">
-                <a16:creationId xmlns:a16="http://schemas.microsoft.com/office/drawing/2014/main" id="{196A7C51-DF81-463E-97D3-390247005C35}"/>
+                <a16:creationId xmlns:a16="http://schemas.microsoft.com/office/drawing/2014/main" id="{6135F3D2-3B49-4B5F-825A-3B131FB93033}"/>
               </a:ext>
             </a:extLst>
           </p:cNvPr>
@@ -9031,7 +9031,7 @@
           <p:cNvPr id="2" name="">
             <a:extLst xmlns:a="http://schemas.openxmlformats.org/drawingml/2006/main">
               <a:ext uri="{FF2B5EF4-FFF2-40B4-BE49-F238E27FC236}">
-                <a16:creationId xmlns:a16="http://schemas.microsoft.com/office/drawing/2014/main" id="{CFBAE8CF-61EF-46DD-9079-2C48EE5A1633}"/>
+                <a16:creationId xmlns:a16="http://schemas.microsoft.com/office/drawing/2014/main" id="{2F07D0A7-F84A-4A24-87BA-0D2891313703}"/>
               </a:ext>
             </a:extLst>
           </p:cNvPr>
@@ -9088,7 +9088,7 @@
           <p:cNvPr id="3" name="">
             <a:extLst xmlns:a="http://schemas.openxmlformats.org/drawingml/2006/main">
               <a:ext uri="{FF2B5EF4-FFF2-40B4-BE49-F238E27FC236}">
-                <a16:creationId xmlns:a16="http://schemas.microsoft.com/office/drawing/2014/main" id="{96BE1CC2-817D-43AC-964E-51AC055F1FE8}"/>
+                <a16:creationId xmlns:a16="http://schemas.microsoft.com/office/drawing/2014/main" id="{FE6FC925-A8DC-4DEC-A4D5-1BDEE197760D}"/>
               </a:ext>
             </a:extLst>
           </p:cNvPr>
@@ -9145,7 +9145,7 @@
           <p:cNvPr id="4" name="">
             <a:extLst xmlns:a="http://schemas.openxmlformats.org/drawingml/2006/main">
               <a:ext uri="{FF2B5EF4-FFF2-40B4-BE49-F238E27FC236}">
-                <a16:creationId xmlns:a16="http://schemas.microsoft.com/office/drawing/2014/main" id="{8FA4A3DB-0E6F-4FD1-8AD0-4FB1A8C09750}"/>
+                <a16:creationId xmlns:a16="http://schemas.microsoft.com/office/drawing/2014/main" id="{C37F4F09-5E36-43DB-8E80-7172E9968E54}"/>
               </a:ext>
             </a:extLst>
           </p:cNvPr>
@@ -9177,7 +9177,7 @@
           <p:cNvPr id="5" name="">
             <a:extLst xmlns:a="http://schemas.openxmlformats.org/drawingml/2006/main">
               <a:ext uri="{FF2B5EF4-FFF2-40B4-BE49-F238E27FC236}">
-                <a16:creationId xmlns:a16="http://schemas.microsoft.com/office/drawing/2014/main" id="{ABD39E2F-01CD-49F2-A0EA-826652FFD600}"/>
+                <a16:creationId xmlns:a16="http://schemas.microsoft.com/office/drawing/2014/main" id="{CD356923-33DD-4243-AE56-0C54B66604F9}"/>
               </a:ext>
             </a:extLst>
           </p:cNvPr>
@@ -9234,7 +9234,7 @@
           <p:cNvPr id="6" name="">
             <a:extLst xmlns:a="http://schemas.openxmlformats.org/drawingml/2006/main">
               <a:ext uri="{FF2B5EF4-FFF2-40B4-BE49-F238E27FC236}">
-                <a16:creationId xmlns:a16="http://schemas.microsoft.com/office/drawing/2014/main" id="{D8CBA6E3-9CC3-44B9-8265-2E6D807C2C79}"/>
+                <a16:creationId xmlns:a16="http://schemas.microsoft.com/office/drawing/2014/main" id="{56D9F0C7-06E0-480F-80A3-8BEB388CBA02}"/>
               </a:ext>
             </a:extLst>
           </p:cNvPr>
@@ -9291,7 +9291,7 @@
           <p:cNvPr id="7" name="">
             <a:extLst xmlns:a="http://schemas.openxmlformats.org/drawingml/2006/main">
               <a:ext uri="{FF2B5EF4-FFF2-40B4-BE49-F238E27FC236}">
-                <a16:creationId xmlns:a16="http://schemas.microsoft.com/office/drawing/2014/main" id="{66B8AA0A-E3D5-45D2-B890-D8D0A156E4B1}"/>
+                <a16:creationId xmlns:a16="http://schemas.microsoft.com/office/drawing/2014/main" id="{BB6279AB-1AA2-4E7D-AC2A-860DEFE48607}"/>
               </a:ext>
             </a:extLst>
           </p:cNvPr>
@@ -9348,7 +9348,7 @@
           <p:cNvPr id="8" name="">
             <a:extLst xmlns:a="http://schemas.openxmlformats.org/drawingml/2006/main">
               <a:ext uri="{FF2B5EF4-FFF2-40B4-BE49-F238E27FC236}">
-                <a16:creationId xmlns:a16="http://schemas.microsoft.com/office/drawing/2014/main" id="{9AFC4B1C-F8BF-4370-BDB2-3C17719B168A}"/>
+                <a16:creationId xmlns:a16="http://schemas.microsoft.com/office/drawing/2014/main" id="{731A231E-5A3C-4AA9-86E1-AA5B94E634D6}"/>
               </a:ext>
             </a:extLst>
           </p:cNvPr>
@@ -9405,7 +9405,7 @@
           <p:cNvPr id="9" name="">
             <a:extLst xmlns:a="http://schemas.openxmlformats.org/drawingml/2006/main">
               <a:ext uri="{FF2B5EF4-FFF2-40B4-BE49-F238E27FC236}">
-                <a16:creationId xmlns:a16="http://schemas.microsoft.com/office/drawing/2014/main" id="{CB792C95-9B3D-413B-AD39-B9484D69104D}"/>
+                <a16:creationId xmlns:a16="http://schemas.microsoft.com/office/drawing/2014/main" id="{8B6D8A04-EE3C-4D89-9284-C7CF11DCBF31}"/>
               </a:ext>
             </a:extLst>
           </p:cNvPr>
@@ -9462,7 +9462,7 @@
           <p:cNvPr id="10" name="">
             <a:extLst xmlns:a="http://schemas.openxmlformats.org/drawingml/2006/main">
               <a:ext uri="{FF2B5EF4-FFF2-40B4-BE49-F238E27FC236}">
-                <a16:creationId xmlns:a16="http://schemas.microsoft.com/office/drawing/2014/main" id="{C7EB0AF0-EAB9-494C-91E5-71E71A6F543E}"/>
+                <a16:creationId xmlns:a16="http://schemas.microsoft.com/office/drawing/2014/main" id="{0EBDECB3-8F79-4B71-A9D0-431C8C14E744}"/>
               </a:ext>
             </a:extLst>
           </p:cNvPr>
@@ -9517,7 +9517,7 @@
     </p:spTree>
     <p:extLst>
       <p:ext uri="{BB962C8B-B14F-4D97-AF65-F5344CB8AC3E}">
-        <p14:creationId xmlns:p14="http://schemas.microsoft.com/office/powerpoint/2010/main" val="793870793"/>
+        <p14:creationId xmlns:p14="http://schemas.microsoft.com/office/powerpoint/2010/main" val="556877708"/>
       </p:ext>
     </p:extLst>
   </p:cSld>
@@ -9548,7 +9548,7 @@
           <p:cNvPr id="8" name="">
             <a:extLst xmlns:a="http://schemas.openxmlformats.org/drawingml/2006/main">
               <a:ext uri="{FF2B5EF4-FFF2-40B4-BE49-F238E27FC236}">
-                <a16:creationId xmlns:a16="http://schemas.microsoft.com/office/drawing/2014/main" id="{AC911D77-1851-46D2-84F6-E14641D72A9C}"/>
+                <a16:creationId xmlns:a16="http://schemas.microsoft.com/office/drawing/2014/main" id="{47D46D4C-35FF-4595-9410-34E495B3EA8E}"/>
               </a:ext>
             </a:extLst>
           </p:cNvPr>
@@ -9605,7 +9605,7 @@
           <p:cNvPr id="2" name="">
             <a:extLst xmlns:a="http://schemas.openxmlformats.org/drawingml/2006/main">
               <a:ext uri="{FF2B5EF4-FFF2-40B4-BE49-F238E27FC236}">
-                <a16:creationId xmlns:a16="http://schemas.microsoft.com/office/drawing/2014/main" id="{FA30EBD5-61A8-4B62-BE05-F248767AA78F}"/>
+                <a16:creationId xmlns:a16="http://schemas.microsoft.com/office/drawing/2014/main" id="{E5260BC7-AEE9-480D-A0AB-F7F0C3FBA0B3}"/>
               </a:ext>
             </a:extLst>
           </p:cNvPr>
@@ -9662,7 +9662,7 @@
           <p:cNvPr id="3" name="">
             <a:extLst xmlns:a="http://schemas.openxmlformats.org/drawingml/2006/main">
               <a:ext uri="{FF2B5EF4-FFF2-40B4-BE49-F238E27FC236}">
-                <a16:creationId xmlns:a16="http://schemas.microsoft.com/office/drawing/2014/main" id="{073196D2-3A58-460C-B6D1-F14498FF8EFE}"/>
+                <a16:creationId xmlns:a16="http://schemas.microsoft.com/office/drawing/2014/main" id="{BEB0461B-B477-41DD-AAEC-42266DCA5799}"/>
               </a:ext>
             </a:extLst>
           </p:cNvPr>
@@ -9726,7 +9726,7 @@
         </p:xfrm>
         <a:graphic xmlns:a="http://schemas.openxmlformats.org/drawingml/2006/main">
           <a:graphicData uri="http://schemas.openxmlformats.org/drawingml/2006/chart">
-            <c:chart xmlns:r="http://schemas.openxmlformats.org/officeDocument/2006/relationships" xmlns:c="http://schemas.openxmlformats.org/drawingml/2006/chart" r:id="R392562a20c3548df"/>
+            <c:chart xmlns:r="http://schemas.openxmlformats.org/officeDocument/2006/relationships" xmlns:c="http://schemas.openxmlformats.org/drawingml/2006/chart" r:id="Rf1ed1d3aa99543e9"/>
           </a:graphicData>
         </a:graphic>
       </p:graphicFrame>
@@ -9735,7 +9735,7 @@
           <p:cNvPr id="5" name="">
             <a:extLst xmlns:a="http://schemas.openxmlformats.org/drawingml/2006/main">
               <a:ext uri="{FF2B5EF4-FFF2-40B4-BE49-F238E27FC236}">
-                <a16:creationId xmlns:a16="http://schemas.microsoft.com/office/drawing/2014/main" id="{04AB8BDB-560F-49D0-935C-3F2C32DA3DEF}"/>
+                <a16:creationId xmlns:a16="http://schemas.microsoft.com/office/drawing/2014/main" id="{CF862DA0-242B-41FB-BC4E-0ABF7955665D}"/>
               </a:ext>
             </a:extLst>
           </p:cNvPr>
@@ -9792,7 +9792,7 @@
           <p:cNvPr id="6" name="">
             <a:extLst xmlns:a="http://schemas.openxmlformats.org/drawingml/2006/main">
               <a:ext uri="{FF2B5EF4-FFF2-40B4-BE49-F238E27FC236}">
-                <a16:creationId xmlns:a16="http://schemas.microsoft.com/office/drawing/2014/main" id="{85EDDF42-C7B3-4BED-8BA1-7770C2DCC5BC}"/>
+                <a16:creationId xmlns:a16="http://schemas.microsoft.com/office/drawing/2014/main" id="{B3DFADAB-A34A-434F-ADAB-4EB891B0E2A5}"/>
               </a:ext>
             </a:extLst>
           </p:cNvPr>
@@ -9849,7 +9849,7 @@
           <p:cNvPr id="7" name="">
             <a:extLst xmlns:a="http://schemas.openxmlformats.org/drawingml/2006/main">
               <a:ext uri="{FF2B5EF4-FFF2-40B4-BE49-F238E27FC236}">
-                <a16:creationId xmlns:a16="http://schemas.microsoft.com/office/drawing/2014/main" id="{C70E24A5-D94A-4487-89CC-34AC03252737}"/>
+                <a16:creationId xmlns:a16="http://schemas.microsoft.com/office/drawing/2014/main" id="{0587CDE8-8CAB-4A91-A0E5-1756001A9F3D}"/>
               </a:ext>
             </a:extLst>
           </p:cNvPr>
@@ -9904,7 +9904,7 @@
     </p:spTree>
     <p:extLst>
       <p:ext uri="{BB962C8B-B14F-4D97-AF65-F5344CB8AC3E}">
-        <p14:creationId xmlns:p14="http://schemas.microsoft.com/office/powerpoint/2010/main" val="5192521"/>
+        <p14:creationId xmlns:p14="http://schemas.microsoft.com/office/powerpoint/2010/main" val="1430488649"/>
       </p:ext>
     </p:extLst>
   </p:cSld>

</xml_diff>